<commit_message>
docs: clarify stacked PR overview visual
</commit_message>
<xml_diff>
--- a/github-stacked-prs.pptx
+++ b/github-stacked-prs.pptx
@@ -2135,7 +2135,7 @@
         </p:nvSpPr>
         <p:spPr>
           <a:xfrm>
-            <a:off x="482501" y="381000"/>
+            <a:off x="482501" y="355550"/>
             <a:ext cx="8342578" cy="152400"/>
           </a:xfrm>
           <a:prstGeom prst="rect">
@@ -2150,7 +2150,7 @@
           <a:p>
             <a:pPr algn="l" indent="0" marL="0">
               <a:spcAft>
-                <a:spcPts val="700"/>
+                <a:spcPts val="600"/>
               </a:spcAft>
               <a:buNone/>
             </a:pPr>
@@ -2163,7 +2163,7 @@
                 <a:ea typeface="Arial" pitchFamily="34" charset="-122"/>
                 <a:cs typeface="Arial" pitchFamily="34" charset="-120"/>
               </a:rPr>
-              <a:t>THE THIRD OPTION</a:t>
+              <a:t>THE HIGH-LEVEL IDEA</a:t>
             </a:r>
             <a:endParaRPr lang="en-US" sz="1100" dirty="0"/>
           </a:p>
@@ -2177,8 +2177,8 @@
         </p:nvSpPr>
         <p:spPr>
           <a:xfrm>
-            <a:off x="482501" y="622250"/>
-            <a:ext cx="8342578" cy="413296"/>
+            <a:off x="482501" y="584150"/>
+            <a:ext cx="8342578" cy="383084"/>
           </a:xfrm>
           <a:prstGeom prst="rect">
             <a:avLst/>
@@ -2192,12 +2192,12 @@
           <a:p>
             <a:pPr algn="l" indent="0" marL="0">
               <a:lnSpc>
-                <a:spcPts val="3255"/>
+                <a:spcPts val="3016"/>
               </a:lnSpc>
               <a:buNone/>
             </a:pPr>
             <a:r>
-              <a:rPr lang="en-US" sz="3100" b="1" dirty="0">
+              <a:rPr lang="en-US" sz="2900" b="1" dirty="0">
                 <a:solidFill>
                   <a:srgbClr val="F0F6FC"/>
                 </a:solidFill>
@@ -2205,9 +2205,9 @@
                 <a:ea typeface="Arial" pitchFamily="34" charset="-122"/>
                 <a:cs typeface="Arial" pitchFamily="34" charset="-120"/>
               </a:rPr>
-              <a:t>Develop together. Review separately.</a:t>
-            </a:r>
-            <a:endParaRPr lang="en-US" sz="3100" dirty="0"/>
+              <a:t>Turn one large change into reviewable layers</a:t>
+            </a:r>
+            <a:endParaRPr lang="en-US" sz="2900" dirty="0"/>
           </a:p>
         </p:txBody>
       </p:sp>
@@ -2219,8 +2219,8 @@
         </p:nvSpPr>
         <p:spPr>
           <a:xfrm>
-            <a:off x="482501" y="1124396"/>
-            <a:ext cx="8342578" cy="238125"/>
+            <a:off x="482501" y="1043434"/>
+            <a:ext cx="8342578" cy="219075"/>
           </a:xfrm>
           <a:prstGeom prst="rect">
             <a:avLst/>
@@ -2234,7 +2234,7 @@
           <a:p>
             <a:pPr algn="l" indent="0" marL="0">
               <a:spcBef>
-                <a:spcPts val="700"/>
+                <a:spcPts val="600"/>
               </a:spcBef>
               <a:spcAft>
                 <a:spcPts val="2000"/>
@@ -2242,7 +2242,7 @@
               <a:buNone/>
             </a:pPr>
             <a:r>
-              <a:rPr lang="en-US" sz="1600" dirty="0">
+              <a:rPr lang="en-US" sz="1500" dirty="0">
                 <a:solidFill>
                   <a:srgbClr val="B1BAC4"/>
                 </a:solidFill>
@@ -2250,9 +2250,9 @@
                 <a:ea typeface="Arial" pitchFamily="34" charset="-122"/>
                 <a:cs typeface="Arial" pitchFamily="34" charset="-120"/>
               </a:rPr>
-              <a:t>Each pull request depends on the branch below it, but exposes only its own focused diff.</a:t>
-            </a:r>
-            <a:endParaRPr lang="en-US" sz="1600" dirty="0"/>
+              <a:t>The work stays connected, but each pull request becomes smaller and easier to understand.</a:t>
+            </a:r>
+            <a:endParaRPr lang="en-US" sz="1500" dirty="0"/>
           </a:p>
         </p:txBody>
       </p:sp>
@@ -2264,18 +2264,229 @@
         </p:nvSpPr>
         <p:spPr>
           <a:xfrm>
-            <a:off x="1301948" y="2016472"/>
-            <a:ext cx="1816001" cy="1549301"/>
+            <a:off x="482501" y="2009180"/>
+            <a:ext cx="2095054" cy="2286000"/>
           </a:xfrm>
           <a:prstGeom prst="roundRect">
             <a:avLst>
-              <a:gd name="adj" fmla="val 9837"/>
+              <a:gd name="adj" fmla="val 7880"/>
+            </a:avLst>
+          </a:prstGeom>
+          <a:solidFill>
+            <a:srgbClr val="2D1717"/>
+          </a:solidFill>
+          <a:ln w="19050">
+            <a:solidFill>
+              <a:srgbClr val="F85149"/>
+            </a:solidFill>
+          </a:ln>
+        </p:spPr>
+        <p:txBody>
+          <a:bodyPr wrap="square" rtlCol="0" anchor="ctr"/>
+          <a:lstStyle/>
+          <a:p>
+            <a:pPr indent="0" marL="0">
+              <a:buNone/>
+            </a:pPr>
+            <a:endParaRPr lang="en-US" dirty="0"/>
+          </a:p>
+        </p:txBody>
+      </p:sp>
+      <p:sp>
+        <p:nvSpPr>
+          <p:cNvPr id="6" name="Text 4"/>
+          <p:cNvSpPr/>
+          <p:nvPr/>
+        </p:nvSpPr>
+        <p:spPr>
+          <a:xfrm>
+            <a:off x="730151" y="2365772"/>
+            <a:ext cx="1631749" cy="158651"/>
+          </a:xfrm>
+          <a:prstGeom prst="rect">
+            <a:avLst/>
+          </a:prstGeom>
+          <a:noFill/>
+          <a:ln/>
+        </p:spPr>
+        <p:txBody>
+          <a:bodyPr wrap="square" lIns="0" tIns="0" rIns="0" bIns="0" rtlCol="0" anchor="t"/>
+          <a:lstStyle/>
+          <a:p>
+            <a:pPr algn="l" indent="0" marL="0">
+              <a:lnSpc>
+                <a:spcPts val="1250"/>
+              </a:lnSpc>
+              <a:spcAft>
+                <a:spcPts val="800"/>
+              </a:spcAft>
+              <a:buNone/>
+            </a:pPr>
+            <a:r>
+              <a:rPr lang="en-US" sz="1000" b="1" dirty="0">
+                <a:solidFill>
+                  <a:srgbClr val="FF7B72"/>
+                </a:solidFill>
+                <a:latin typeface="Arial" pitchFamily="34" charset="0"/>
+                <a:ea typeface="Arial" pitchFamily="34" charset="-122"/>
+                <a:cs typeface="Arial" pitchFamily="34" charset="-120"/>
+              </a:rPr>
+              <a:t>BEFORE</a:t>
+            </a:r>
+            <a:endParaRPr lang="en-US" sz="1000" dirty="0"/>
+          </a:p>
+        </p:txBody>
+      </p:sp>
+      <p:sp>
+        <p:nvSpPr>
+          <p:cNvPr id="7" name="Text 5"/>
+          <p:cNvSpPr/>
+          <p:nvPr/>
+        </p:nvSpPr>
+        <p:spPr>
+          <a:xfrm>
+            <a:off x="730151" y="2625923"/>
+            <a:ext cx="1631749" cy="590550"/>
+          </a:xfrm>
+          <a:prstGeom prst="rect">
+            <a:avLst/>
+          </a:prstGeom>
+          <a:noFill/>
+          <a:ln/>
+        </p:spPr>
+        <p:txBody>
+          <a:bodyPr wrap="square" lIns="0" tIns="0" rIns="0" bIns="0" rtlCol="0" anchor="t"/>
+          <a:lstStyle/>
+          <a:p>
+            <a:pPr algn="l" indent="0" marL="0">
+              <a:spcAft>
+                <a:spcPts val="1000"/>
+              </a:spcAft>
+              <a:buNone/>
+            </a:pPr>
+            <a:r>
+              <a:rPr lang="en-US" sz="2000" b="1" dirty="0">
+                <a:solidFill>
+                  <a:srgbClr val="F0F6FC"/>
+                </a:solidFill>
+                <a:latin typeface="Arial" pitchFamily="34" charset="0"/>
+                <a:ea typeface="Arial" pitchFamily="34" charset="-122"/>
+                <a:cs typeface="Arial" pitchFamily="34" charset="-120"/>
+              </a:rPr>
+              <a:t>One large feature</a:t>
+            </a:r>
+            <a:endParaRPr lang="en-US" sz="2000" dirty="0"/>
+          </a:p>
+        </p:txBody>
+      </p:sp>
+      <p:sp>
+        <p:nvSpPr>
+          <p:cNvPr id="8" name="Text 6"/>
+          <p:cNvSpPr/>
+          <p:nvPr/>
+        </p:nvSpPr>
+        <p:spPr>
+          <a:xfrm>
+            <a:off x="730151" y="3343424"/>
+            <a:ext cx="1631749" cy="595164"/>
+          </a:xfrm>
+          <a:prstGeom prst="rect">
+            <a:avLst/>
+          </a:prstGeom>
+          <a:noFill/>
+          <a:ln/>
+        </p:spPr>
+        <p:txBody>
+          <a:bodyPr wrap="square" lIns="0" tIns="0" rIns="0" bIns="0" rtlCol="0" anchor="t"/>
+          <a:lstStyle/>
+          <a:p>
+            <a:pPr algn="l" indent="0" marL="0">
+              <a:lnSpc>
+                <a:spcPts val="1562"/>
+              </a:lnSpc>
+              <a:buNone/>
+            </a:pPr>
+            <a:r>
+              <a:rPr lang="en-US" sz="1250" dirty="0">
+                <a:solidFill>
+                  <a:srgbClr val="FFC1BD"/>
+                </a:solidFill>
+                <a:latin typeface="Arial" pitchFamily="34" charset="0"/>
+                <a:ea typeface="Arial" pitchFamily="34" charset="-122"/>
+                <a:cs typeface="Arial" pitchFamily="34" charset="-120"/>
+              </a:rPr>
+              <a:t>Model + validation + tests arrive as one mixed review.</a:t>
+            </a:r>
+            <a:endParaRPr lang="en-US" sz="1250" dirty="0"/>
+          </a:p>
+        </p:txBody>
+      </p:sp>
+      <p:sp>
+        <p:nvSpPr>
+          <p:cNvPr id="9" name="Text 7"/>
+          <p:cNvSpPr/>
+          <p:nvPr/>
+        </p:nvSpPr>
+        <p:spPr>
+          <a:xfrm>
+            <a:off x="2825344" y="2937867"/>
+            <a:ext cx="623310" cy="428625"/>
+          </a:xfrm>
+          <a:prstGeom prst="rect">
+            <a:avLst/>
+          </a:prstGeom>
+          <a:noFill/>
+          <a:ln/>
+        </p:spPr>
+        <p:txBody>
+          <a:bodyPr wrap="square" lIns="0" tIns="0" rIns="0" bIns="0" rtlCol="0" anchor="t"/>
+          <a:lstStyle/>
+          <a:p>
+            <a:pPr algn="ctr" indent="0" marL="0">
+              <a:buNone/>
+            </a:pPr>
+            <a:r>
+              <a:rPr lang="en-US" sz="3000" dirty="0">
+                <a:solidFill>
+                  <a:srgbClr val="56D364"/>
+                </a:solidFill>
+                <a:latin typeface="Arial" pitchFamily="34" charset="0"/>
+                <a:ea typeface="Arial" pitchFamily="34" charset="-122"/>
+                <a:cs typeface="Arial" pitchFamily="34" charset="-120"/>
+              </a:rPr>
+              <a:t>→</a:t>
+            </a:r>
+            <a:endParaRPr lang="en-US" sz="3000" dirty="0"/>
+          </a:p>
+        </p:txBody>
+      </p:sp>
+      <p:sp>
+        <p:nvSpPr>
+          <p:cNvPr id="10" name="Text 8"/>
+          <p:cNvSpPr/>
+          <p:nvPr/>
+        </p:nvSpPr>
+        <p:spPr>
+          <a:xfrm>
+            <a:off x="4166443" y="1989981"/>
+            <a:ext cx="1745307" cy="609600"/>
+          </a:xfrm>
+          <a:prstGeom prst="roundRect">
+            <a:avLst>
+              <a:gd name="adj" fmla="val 16667"/>
             </a:avLst>
           </a:prstGeom>
           <a:solidFill>
             <a:srgbClr val="161B22"/>
           </a:solidFill>
           <a:ln/>
+          <a:effectLst>
+            <a:outerShdw sx="100000" sy="100000" kx="0" ky="0" algn="bl" rotWithShape="0" blurRad="88900" dist="38100" dir="5400000">
+              <a:srgbClr val="000000">
+                <a:alpha val="30000"/>
+              </a:srgbClr>
+            </a:outerShdw>
+          </a:effectLst>
         </p:spPr>
         <p:txBody>
           <a:bodyPr wrap="square" rtlCol="0" anchor="ctr"/>
@@ -2290,22 +2501,22 @@
       </p:sp>
       <p:sp>
         <p:nvSpPr>
-          <p:cNvPr id="6" name="Shape 4"/>
-          <p:cNvSpPr/>
-          <p:nvPr/>
-        </p:nvSpPr>
-        <p:spPr>
-          <a:xfrm>
-            <a:off x="1301948" y="2054572"/>
-            <a:ext cx="1816001" cy="0"/>
+          <p:cNvPr id="11" name="Shape 9"/>
+          <p:cNvSpPr/>
+          <p:nvPr/>
+        </p:nvSpPr>
+        <p:spPr>
+          <a:xfrm>
+            <a:off x="4166443" y="1999506"/>
+            <a:ext cx="1745307" cy="0"/>
           </a:xfrm>
           <a:prstGeom prst="line">
             <a:avLst/>
           </a:prstGeom>
           <a:noFill/>
-          <a:ln w="76200">
+          <a:ln w="19050">
             <a:solidFill>
-              <a:srgbClr val="58A6FF"/>
+              <a:srgbClr val="30363D"/>
             </a:solidFill>
             <a:prstDash val="solid"/>
           </a:ln>
@@ -2313,14 +2524,14 @@
       </p:sp>
       <p:sp>
         <p:nvSpPr>
-          <p:cNvPr id="7" name="Shape 5"/>
-          <p:cNvSpPr/>
-          <p:nvPr/>
-        </p:nvSpPr>
-        <p:spPr>
-          <a:xfrm>
-            <a:off x="3108424" y="2016472"/>
-            <a:ext cx="0" cy="1549301"/>
+          <p:cNvPr id="12" name="Shape 10"/>
+          <p:cNvSpPr/>
+          <p:nvPr/>
+        </p:nvSpPr>
+        <p:spPr>
+          <a:xfrm>
+            <a:off x="5902226" y="1989981"/>
+            <a:ext cx="0" cy="609600"/>
           </a:xfrm>
           <a:prstGeom prst="line">
             <a:avLst/>
@@ -2328,7 +2539,7 @@
           <a:noFill/>
           <a:ln w="19050">
             <a:solidFill>
-              <a:srgbClr val="58A6FF"/>
+              <a:srgbClr val="30363D"/>
             </a:solidFill>
             <a:prstDash val="solid"/>
           </a:ln>
@@ -2336,14 +2547,14 @@
       </p:sp>
       <p:sp>
         <p:nvSpPr>
-          <p:cNvPr id="8" name="Shape 6"/>
-          <p:cNvSpPr/>
-          <p:nvPr/>
-        </p:nvSpPr>
-        <p:spPr>
-          <a:xfrm>
-            <a:off x="1301948" y="3556248"/>
-            <a:ext cx="1816001" cy="0"/>
+          <p:cNvPr id="13" name="Shape 11"/>
+          <p:cNvSpPr/>
+          <p:nvPr/>
+        </p:nvSpPr>
+        <p:spPr>
+          <a:xfrm>
+            <a:off x="4166443" y="2590056"/>
+            <a:ext cx="1745307" cy="0"/>
           </a:xfrm>
           <a:prstGeom prst="line">
             <a:avLst/>
@@ -2351,7 +2562,7 @@
           <a:noFill/>
           <a:ln w="19050">
             <a:solidFill>
-              <a:srgbClr val="58A6FF"/>
+              <a:srgbClr val="30363D"/>
             </a:solidFill>
             <a:prstDash val="solid"/>
           </a:ln>
@@ -2359,231 +2570,14 @@
       </p:sp>
       <p:sp>
         <p:nvSpPr>
-          <p:cNvPr id="9" name="Shape 7"/>
-          <p:cNvSpPr/>
-          <p:nvPr/>
-        </p:nvSpPr>
-        <p:spPr>
-          <a:xfrm>
-            <a:off x="1311473" y="2016472"/>
-            <a:ext cx="0" cy="1549301"/>
-          </a:xfrm>
-          <a:prstGeom prst="line">
-            <a:avLst/>
-          </a:prstGeom>
-          <a:noFill/>
-          <a:ln w="19050">
-            <a:solidFill>
-              <a:srgbClr val="58A6FF"/>
-            </a:solidFill>
-            <a:prstDash val="solid"/>
-          </a:ln>
-        </p:spPr>
-      </p:sp>
-      <p:sp>
-        <p:nvSpPr>
-          <p:cNvPr id="10" name="Text 8"/>
-          <p:cNvSpPr/>
-          <p:nvPr/>
-        </p:nvSpPr>
-        <p:spPr>
-          <a:xfrm>
-            <a:off x="1511498" y="2283172"/>
-            <a:ext cx="1424839" cy="257175"/>
-          </a:xfrm>
-          <a:prstGeom prst="rect">
-            <a:avLst/>
-          </a:prstGeom>
-          <a:noFill/>
-          <a:ln/>
-        </p:spPr>
-        <p:txBody>
-          <a:bodyPr wrap="square" lIns="0" tIns="0" rIns="0" bIns="0" rtlCol="0" anchor="t"/>
-          <a:lstStyle/>
-          <a:p>
-            <a:pPr algn="l" indent="0" marL="0">
-              <a:spcAft>
-                <a:spcPts val="500"/>
-              </a:spcAft>
-              <a:buNone/>
-            </a:pPr>
-            <a:r>
-              <a:rPr lang="en-US" sz="1700" b="1" dirty="0">
-                <a:solidFill>
-                  <a:srgbClr val="F0F6FC"/>
-                </a:solidFill>
-                <a:latin typeface="Arial" pitchFamily="34" charset="0"/>
-                <a:ea typeface="Arial" pitchFamily="34" charset="-122"/>
-                <a:cs typeface="Arial" pitchFamily="34" charset="-120"/>
-              </a:rPr>
-              <a:t>PR #1</a:t>
-            </a:r>
-            <a:endParaRPr lang="en-US" sz="1700" dirty="0"/>
-          </a:p>
-        </p:txBody>
-      </p:sp>
-      <p:sp>
-        <p:nvSpPr>
-          <p:cNvPr id="11" name="Text 9"/>
-          <p:cNvSpPr/>
-          <p:nvPr/>
-        </p:nvSpPr>
-        <p:spPr>
-          <a:xfrm>
-            <a:off x="1511498" y="2603748"/>
-            <a:ext cx="1424839" cy="152400"/>
-          </a:xfrm>
-          <a:prstGeom prst="rect">
-            <a:avLst/>
-          </a:prstGeom>
-          <a:noFill/>
-          <a:ln/>
-        </p:spPr>
-        <p:txBody>
-          <a:bodyPr wrap="square" lIns="0" tIns="0" rIns="0" bIns="0" rtlCol="0" anchor="t"/>
-          <a:lstStyle/>
-          <a:p>
-            <a:pPr algn="l" indent="0" marL="0">
-              <a:buNone/>
-            </a:pPr>
-            <a:r>
-              <a:rPr lang="en-US" sz="1050" dirty="0">
-                <a:solidFill>
-                  <a:srgbClr val="8B949E"/>
-                </a:solidFill>
-                <a:latin typeface="Courier New" pitchFamily="34" charset="0"/>
-                <a:ea typeface="Courier New" pitchFamily="34" charset="-122"/>
-                <a:cs typeface="Courier New" pitchFamily="34" charset="-120"/>
-              </a:rPr>
-              <a:t>base: main</a:t>
-            </a:r>
-            <a:endParaRPr lang="en-US" sz="1050" dirty="0"/>
-          </a:p>
-        </p:txBody>
-      </p:sp>
-      <p:sp>
-        <p:nvSpPr>
-          <p:cNvPr id="12" name="Text 10"/>
-          <p:cNvSpPr/>
-          <p:nvPr/>
-        </p:nvSpPr>
-        <p:spPr>
-          <a:xfrm>
-            <a:off x="1511498" y="3184773"/>
-            <a:ext cx="1424839" cy="171450"/>
-          </a:xfrm>
-          <a:prstGeom prst="rect">
-            <a:avLst/>
-          </a:prstGeom>
-          <a:noFill/>
-          <a:ln/>
-        </p:spPr>
-        <p:txBody>
-          <a:bodyPr wrap="square" lIns="0" tIns="0" rIns="0" bIns="0" rtlCol="0" anchor="t"/>
-          <a:lstStyle/>
-          <a:p>
-            <a:pPr algn="l" indent="0" marL="0">
-              <a:spcBef>
-                <a:spcPts val="3375"/>
-              </a:spcBef>
-              <a:buNone/>
-            </a:pPr>
-            <a:r>
-              <a:rPr lang="en-US" sz="1200" dirty="0">
-                <a:solidFill>
-                  <a:srgbClr val="C9D1D9"/>
-                </a:solidFill>
-                <a:latin typeface="Arial" pitchFamily="34" charset="0"/>
-                <a:ea typeface="Arial" pitchFamily="34" charset="-122"/>
-                <a:cs typeface="Arial" pitchFamily="34" charset="-120"/>
-              </a:rPr>
-              <a:t>Task model</a:t>
-            </a:r>
-            <a:endParaRPr lang="en-US" sz="1200" dirty="0"/>
-          </a:p>
-        </p:txBody>
-      </p:sp>
-      <p:sp>
-        <p:nvSpPr>
-          <p:cNvPr id="13" name="Text 11"/>
-          <p:cNvSpPr/>
-          <p:nvPr/>
-        </p:nvSpPr>
-        <p:spPr>
-          <a:xfrm>
-            <a:off x="3229075" y="2610148"/>
-            <a:ext cx="323799" cy="361950"/>
-          </a:xfrm>
-          <a:prstGeom prst="rect">
-            <a:avLst/>
-          </a:prstGeom>
-          <a:noFill/>
-          <a:ln/>
-        </p:spPr>
-        <p:txBody>
-          <a:bodyPr wrap="square" lIns="0" tIns="0" rIns="0" bIns="0" rtlCol="0" anchor="t"/>
-          <a:lstStyle/>
-          <a:p>
-            <a:pPr algn="ctr" indent="0" marL="0">
-              <a:buNone/>
-            </a:pPr>
-            <a:r>
-              <a:rPr lang="en-US" sz="2500" dirty="0">
-                <a:solidFill>
-                  <a:srgbClr val="6E7681"/>
-                </a:solidFill>
-                <a:latin typeface="Arial" pitchFamily="34" charset="0"/>
-                <a:ea typeface="Arial" pitchFamily="34" charset="-122"/>
-                <a:cs typeface="Arial" pitchFamily="34" charset="-120"/>
-              </a:rPr>
-              <a:t>→</a:t>
-            </a:r>
-            <a:endParaRPr lang="en-US" sz="2500" dirty="0"/>
-          </a:p>
-        </p:txBody>
-      </p:sp>
-      <p:sp>
-        <p:nvSpPr>
-          <p:cNvPr id="14" name="Text 12"/>
-          <p:cNvSpPr/>
-          <p:nvPr/>
-        </p:nvSpPr>
-        <p:spPr>
-          <a:xfrm>
-            <a:off x="3664000" y="2016472"/>
-            <a:ext cx="1816001" cy="1549301"/>
-          </a:xfrm>
-          <a:prstGeom prst="roundRect">
-            <a:avLst>
-              <a:gd name="adj" fmla="val 9837"/>
-            </a:avLst>
-          </a:prstGeom>
-          <a:solidFill>
-            <a:srgbClr val="161B22"/>
-          </a:solidFill>
-          <a:ln/>
-        </p:spPr>
-        <p:txBody>
-          <a:bodyPr wrap="square" rtlCol="0" anchor="ctr"/>
-          <a:lstStyle/>
-          <a:p>
-            <a:pPr indent="0" marL="0">
-              <a:buNone/>
-            </a:pPr>
-            <a:endParaRPr lang="en-US" dirty="0"/>
-          </a:p>
-        </p:txBody>
-      </p:sp>
-      <p:sp>
-        <p:nvSpPr>
-          <p:cNvPr id="15" name="Shape 13"/>
-          <p:cNvSpPr/>
-          <p:nvPr/>
-        </p:nvSpPr>
-        <p:spPr>
-          <a:xfrm>
-            <a:off x="3664000" y="2054572"/>
-            <a:ext cx="1816001" cy="0"/>
+          <p:cNvPr id="14" name="Shape 12"/>
+          <p:cNvSpPr/>
+          <p:nvPr/>
+        </p:nvSpPr>
+        <p:spPr>
+          <a:xfrm>
+            <a:off x="4204543" y="1989981"/>
+            <a:ext cx="0" cy="609600"/>
           </a:xfrm>
           <a:prstGeom prst="line">
             <a:avLst/>
@@ -2599,14 +2593,131 @@
       </p:sp>
       <p:sp>
         <p:nvSpPr>
-          <p:cNvPr id="16" name="Shape 14"/>
-          <p:cNvSpPr/>
-          <p:nvPr/>
-        </p:nvSpPr>
-        <p:spPr>
-          <a:xfrm>
-            <a:off x="5470475" y="2016472"/>
-            <a:ext cx="0" cy="1549301"/>
+          <p:cNvPr id="15" name="Text 13"/>
+          <p:cNvSpPr/>
+          <p:nvPr/>
+        </p:nvSpPr>
+        <p:spPr>
+          <a:xfrm>
+            <a:off x="4407694" y="2190006"/>
+            <a:ext cx="403041" cy="209550"/>
+          </a:xfrm>
+          <a:prstGeom prst="rect">
+            <a:avLst/>
+          </a:prstGeom>
+          <a:noFill/>
+          <a:ln/>
+        </p:spPr>
+        <p:txBody>
+          <a:bodyPr wrap="square" lIns="0" tIns="0" rIns="0" bIns="0" rtlCol="0" anchor="t"/>
+          <a:lstStyle/>
+          <a:p>
+            <a:pPr algn="l" indent="0" marL="0">
+              <a:buNone/>
+            </a:pPr>
+            <a:r>
+              <a:rPr lang="en-US" sz="1400" b="1" dirty="0">
+                <a:solidFill>
+                  <a:srgbClr val="F0F6FC"/>
+                </a:solidFill>
+                <a:latin typeface="Arial" pitchFamily="34" charset="0"/>
+                <a:ea typeface="Arial" pitchFamily="34" charset="-122"/>
+                <a:cs typeface="Arial" pitchFamily="34" charset="-120"/>
+              </a:rPr>
+              <a:t>PR 3</a:t>
+            </a:r>
+            <a:endParaRPr lang="en-US" sz="1400" dirty="0"/>
+          </a:p>
+        </p:txBody>
+      </p:sp>
+      <p:sp>
+        <p:nvSpPr>
+          <p:cNvPr id="16" name="Text 14"/>
+          <p:cNvSpPr/>
+          <p:nvPr/>
+        </p:nvSpPr>
+        <p:spPr>
+          <a:xfrm>
+            <a:off x="5389066" y="2218581"/>
+            <a:ext cx="345356" cy="152400"/>
+          </a:xfrm>
+          <a:prstGeom prst="rect">
+            <a:avLst/>
+          </a:prstGeom>
+          <a:noFill/>
+          <a:ln/>
+        </p:spPr>
+        <p:txBody>
+          <a:bodyPr wrap="square" lIns="0" tIns="0" rIns="0" bIns="0" rtlCol="0" anchor="t"/>
+          <a:lstStyle/>
+          <a:p>
+            <a:pPr algn="l" indent="0" marL="0">
+              <a:buNone/>
+            </a:pPr>
+            <a:r>
+              <a:rPr lang="en-US" sz="1050" b="1" dirty="0">
+                <a:solidFill>
+                  <a:srgbClr val="7EE787"/>
+                </a:solidFill>
+                <a:latin typeface="Arial" pitchFamily="34" charset="0"/>
+                <a:ea typeface="Arial" pitchFamily="34" charset="-122"/>
+                <a:cs typeface="Arial" pitchFamily="34" charset="-120"/>
+              </a:rPr>
+              <a:t>Tests</a:t>
+            </a:r>
+            <a:endParaRPr lang="en-US" sz="1050" dirty="0"/>
+          </a:p>
+        </p:txBody>
+      </p:sp>
+      <p:sp>
+        <p:nvSpPr>
+          <p:cNvPr id="17" name="Text 15"/>
+          <p:cNvSpPr/>
+          <p:nvPr/>
+        </p:nvSpPr>
+        <p:spPr>
+          <a:xfrm>
+            <a:off x="3964930" y="2675781"/>
+            <a:ext cx="2148185" cy="609600"/>
+          </a:xfrm>
+          <a:prstGeom prst="roundRect">
+            <a:avLst>
+              <a:gd name="adj" fmla="val 16667"/>
+            </a:avLst>
+          </a:prstGeom>
+          <a:solidFill>
+            <a:srgbClr val="161B22"/>
+          </a:solidFill>
+          <a:ln/>
+          <a:effectLst>
+            <a:outerShdw sx="100000" sy="100000" kx="0" ky="0" algn="bl" rotWithShape="0" blurRad="88900" dist="38100" dir="5400000">
+              <a:srgbClr val="000000">
+                <a:alpha val="30000"/>
+              </a:srgbClr>
+            </a:outerShdw>
+          </a:effectLst>
+        </p:spPr>
+        <p:txBody>
+          <a:bodyPr wrap="square" rtlCol="0" anchor="ctr"/>
+          <a:lstStyle/>
+          <a:p>
+            <a:pPr indent="0" marL="0">
+              <a:buNone/>
+            </a:pPr>
+            <a:endParaRPr lang="en-US" dirty="0"/>
+          </a:p>
+        </p:txBody>
+      </p:sp>
+      <p:sp>
+        <p:nvSpPr>
+          <p:cNvPr id="18" name="Shape 16"/>
+          <p:cNvSpPr/>
+          <p:nvPr/>
+        </p:nvSpPr>
+        <p:spPr>
+          <a:xfrm>
+            <a:off x="3964930" y="2685306"/>
+            <a:ext cx="2148185" cy="0"/>
           </a:xfrm>
           <a:prstGeom prst="line">
             <a:avLst/>
@@ -2614,7 +2725,7 @@
           <a:noFill/>
           <a:ln w="19050">
             <a:solidFill>
-              <a:srgbClr val="3FB950"/>
+              <a:srgbClr val="30363D"/>
             </a:solidFill>
             <a:prstDash val="solid"/>
           </a:ln>
@@ -2622,14 +2733,14 @@
       </p:sp>
       <p:sp>
         <p:nvSpPr>
-          <p:cNvPr id="17" name="Shape 15"/>
-          <p:cNvSpPr/>
-          <p:nvPr/>
-        </p:nvSpPr>
-        <p:spPr>
-          <a:xfrm>
-            <a:off x="3664000" y="3556248"/>
-            <a:ext cx="1816001" cy="0"/>
+          <p:cNvPr id="19" name="Shape 17"/>
+          <p:cNvSpPr/>
+          <p:nvPr/>
+        </p:nvSpPr>
+        <p:spPr>
+          <a:xfrm>
+            <a:off x="6103590" y="2675781"/>
+            <a:ext cx="0" cy="609600"/>
           </a:xfrm>
           <a:prstGeom prst="line">
             <a:avLst/>
@@ -2637,7 +2748,7 @@
           <a:noFill/>
           <a:ln w="19050">
             <a:solidFill>
-              <a:srgbClr val="3FB950"/>
+              <a:srgbClr val="30363D"/>
             </a:solidFill>
             <a:prstDash val="solid"/>
           </a:ln>
@@ -2645,14 +2756,14 @@
       </p:sp>
       <p:sp>
         <p:nvSpPr>
-          <p:cNvPr id="18" name="Shape 16"/>
-          <p:cNvSpPr/>
-          <p:nvPr/>
-        </p:nvSpPr>
-        <p:spPr>
-          <a:xfrm>
-            <a:off x="3673525" y="2016472"/>
-            <a:ext cx="0" cy="1549301"/>
+          <p:cNvPr id="20" name="Shape 18"/>
+          <p:cNvSpPr/>
+          <p:nvPr/>
+        </p:nvSpPr>
+        <p:spPr>
+          <a:xfrm>
+            <a:off x="3964930" y="3275856"/>
+            <a:ext cx="2148185" cy="0"/>
           </a:xfrm>
           <a:prstGeom prst="line">
             <a:avLst/>
@@ -2660,7 +2771,7 @@
           <a:noFill/>
           <a:ln w="19050">
             <a:solidFill>
-              <a:srgbClr val="3FB950"/>
+              <a:srgbClr val="30363D"/>
             </a:solidFill>
             <a:prstDash val="solid"/>
           </a:ln>
@@ -2668,208 +2779,14 @@
       </p:sp>
       <p:sp>
         <p:nvSpPr>
-          <p:cNvPr id="19" name="Text 17"/>
-          <p:cNvSpPr/>
-          <p:nvPr/>
-        </p:nvSpPr>
-        <p:spPr>
-          <a:xfrm>
-            <a:off x="3873550" y="2283172"/>
-            <a:ext cx="1424839" cy="257175"/>
-          </a:xfrm>
-          <a:prstGeom prst="rect">
-            <a:avLst/>
-          </a:prstGeom>
-          <a:noFill/>
-          <a:ln/>
-        </p:spPr>
-        <p:txBody>
-          <a:bodyPr wrap="square" lIns="0" tIns="0" rIns="0" bIns="0" rtlCol="0" anchor="t"/>
-          <a:lstStyle/>
-          <a:p>
-            <a:pPr algn="l" indent="0" marL="0">
-              <a:spcAft>
-                <a:spcPts val="500"/>
-              </a:spcAft>
-              <a:buNone/>
-            </a:pPr>
-            <a:r>
-              <a:rPr lang="en-US" sz="1700" b="1" dirty="0">
-                <a:solidFill>
-                  <a:srgbClr val="F0F6FC"/>
-                </a:solidFill>
-                <a:latin typeface="Arial" pitchFamily="34" charset="0"/>
-                <a:ea typeface="Arial" pitchFamily="34" charset="-122"/>
-                <a:cs typeface="Arial" pitchFamily="34" charset="-120"/>
-              </a:rPr>
-              <a:t>PR #2</a:t>
-            </a:r>
-            <a:endParaRPr lang="en-US" sz="1700" dirty="0"/>
-          </a:p>
-        </p:txBody>
-      </p:sp>
-      <p:sp>
-        <p:nvSpPr>
-          <p:cNvPr id="20" name="Text 18"/>
-          <p:cNvSpPr/>
-          <p:nvPr/>
-        </p:nvSpPr>
-        <p:spPr>
-          <a:xfrm>
-            <a:off x="3873550" y="2603748"/>
-            <a:ext cx="1424839" cy="152400"/>
-          </a:xfrm>
-          <a:prstGeom prst="rect">
-            <a:avLst/>
-          </a:prstGeom>
-          <a:noFill/>
-          <a:ln/>
-        </p:spPr>
-        <p:txBody>
-          <a:bodyPr wrap="square" lIns="0" tIns="0" rIns="0" bIns="0" rtlCol="0" anchor="t"/>
-          <a:lstStyle/>
-          <a:p>
-            <a:pPr algn="l" indent="0" marL="0">
-              <a:buNone/>
-            </a:pPr>
-            <a:r>
-              <a:rPr lang="en-US" sz="1050" dirty="0">
-                <a:solidFill>
-                  <a:srgbClr val="8B949E"/>
-                </a:solidFill>
-                <a:latin typeface="Courier New" pitchFamily="34" charset="0"/>
-                <a:ea typeface="Courier New" pitchFamily="34" charset="-122"/>
-                <a:cs typeface="Courier New" pitchFamily="34" charset="-120"/>
-              </a:rPr>
-              <a:t>base: PR #1</a:t>
-            </a:r>
-            <a:endParaRPr lang="en-US" sz="1050" dirty="0"/>
-          </a:p>
-        </p:txBody>
-      </p:sp>
-      <p:sp>
-        <p:nvSpPr>
-          <p:cNvPr id="21" name="Text 19"/>
-          <p:cNvSpPr/>
-          <p:nvPr/>
-        </p:nvSpPr>
-        <p:spPr>
-          <a:xfrm>
-            <a:off x="3873550" y="3184773"/>
-            <a:ext cx="1424839" cy="171450"/>
-          </a:xfrm>
-          <a:prstGeom prst="rect">
-            <a:avLst/>
-          </a:prstGeom>
-          <a:noFill/>
-          <a:ln/>
-        </p:spPr>
-        <p:txBody>
-          <a:bodyPr wrap="square" lIns="0" tIns="0" rIns="0" bIns="0" rtlCol="0" anchor="t"/>
-          <a:lstStyle/>
-          <a:p>
-            <a:pPr algn="l" indent="0" marL="0">
-              <a:spcBef>
-                <a:spcPts val="3375"/>
-              </a:spcBef>
-              <a:buNone/>
-            </a:pPr>
-            <a:r>
-              <a:rPr lang="en-US" sz="1200" dirty="0">
-                <a:solidFill>
-                  <a:srgbClr val="C9D1D9"/>
-                </a:solidFill>
-                <a:latin typeface="Arial" pitchFamily="34" charset="0"/>
-                <a:ea typeface="Arial" pitchFamily="34" charset="-122"/>
-                <a:cs typeface="Arial" pitchFamily="34" charset="-120"/>
-              </a:rPr>
-              <a:t>Validation</a:t>
-            </a:r>
-            <a:endParaRPr lang="en-US" sz="1200" dirty="0"/>
-          </a:p>
-        </p:txBody>
-      </p:sp>
-      <p:sp>
-        <p:nvSpPr>
-          <p:cNvPr id="22" name="Text 20"/>
-          <p:cNvSpPr/>
-          <p:nvPr/>
-        </p:nvSpPr>
-        <p:spPr>
-          <a:xfrm>
-            <a:off x="5591126" y="2610148"/>
-            <a:ext cx="323799" cy="361950"/>
-          </a:xfrm>
-          <a:prstGeom prst="rect">
-            <a:avLst/>
-          </a:prstGeom>
-          <a:noFill/>
-          <a:ln/>
-        </p:spPr>
-        <p:txBody>
-          <a:bodyPr wrap="square" lIns="0" tIns="0" rIns="0" bIns="0" rtlCol="0" anchor="t"/>
-          <a:lstStyle/>
-          <a:p>
-            <a:pPr algn="ctr" indent="0" marL="0">
-              <a:buNone/>
-            </a:pPr>
-            <a:r>
-              <a:rPr lang="en-US" sz="2500" dirty="0">
-                <a:solidFill>
-                  <a:srgbClr val="6E7681"/>
-                </a:solidFill>
-                <a:latin typeface="Arial" pitchFamily="34" charset="0"/>
-                <a:ea typeface="Arial" pitchFamily="34" charset="-122"/>
-                <a:cs typeface="Arial" pitchFamily="34" charset="-120"/>
-              </a:rPr>
-              <a:t>→</a:t>
-            </a:r>
-            <a:endParaRPr lang="en-US" sz="2500" dirty="0"/>
-          </a:p>
-        </p:txBody>
-      </p:sp>
-      <p:sp>
-        <p:nvSpPr>
-          <p:cNvPr id="23" name="Text 21"/>
-          <p:cNvSpPr/>
-          <p:nvPr/>
-        </p:nvSpPr>
-        <p:spPr>
-          <a:xfrm>
-            <a:off x="6026051" y="2016472"/>
-            <a:ext cx="1816001" cy="1549301"/>
-          </a:xfrm>
-          <a:prstGeom prst="roundRect">
-            <a:avLst>
-              <a:gd name="adj" fmla="val 9837"/>
-            </a:avLst>
-          </a:prstGeom>
-          <a:solidFill>
-            <a:srgbClr val="161B22"/>
-          </a:solidFill>
-          <a:ln/>
-        </p:spPr>
-        <p:txBody>
-          <a:bodyPr wrap="square" rtlCol="0" anchor="ctr"/>
-          <a:lstStyle/>
-          <a:p>
-            <a:pPr indent="0" marL="0">
-              <a:buNone/>
-            </a:pPr>
-            <a:endParaRPr lang="en-US" dirty="0"/>
-          </a:p>
-        </p:txBody>
-      </p:sp>
-      <p:sp>
-        <p:nvSpPr>
-          <p:cNvPr id="24" name="Shape 22"/>
-          <p:cNvSpPr/>
-          <p:nvPr/>
-        </p:nvSpPr>
-        <p:spPr>
-          <a:xfrm>
-            <a:off x="6026051" y="2054572"/>
-            <a:ext cx="1816001" cy="0"/>
+          <p:cNvPr id="21" name="Shape 19"/>
+          <p:cNvSpPr/>
+          <p:nvPr/>
+        </p:nvSpPr>
+        <p:spPr>
+          <a:xfrm>
+            <a:off x="4003030" y="2675781"/>
+            <a:ext cx="0" cy="609600"/>
           </a:xfrm>
           <a:prstGeom prst="line">
             <a:avLst/>
@@ -2885,20 +2802,206 @@
       </p:sp>
       <p:sp>
         <p:nvSpPr>
+          <p:cNvPr id="22" name="Text 20"/>
+          <p:cNvSpPr/>
+          <p:nvPr/>
+        </p:nvSpPr>
+        <p:spPr>
+          <a:xfrm>
+            <a:off x="4206180" y="2875806"/>
+            <a:ext cx="403041" cy="209550"/>
+          </a:xfrm>
+          <a:prstGeom prst="rect">
+            <a:avLst/>
+          </a:prstGeom>
+          <a:noFill/>
+          <a:ln/>
+        </p:spPr>
+        <p:txBody>
+          <a:bodyPr wrap="square" lIns="0" tIns="0" rIns="0" bIns="0" rtlCol="0" anchor="t"/>
+          <a:lstStyle/>
+          <a:p>
+            <a:pPr algn="l" indent="0" marL="0">
+              <a:buNone/>
+            </a:pPr>
+            <a:r>
+              <a:rPr lang="en-US" sz="1400" b="1" dirty="0">
+                <a:solidFill>
+                  <a:srgbClr val="F0F6FC"/>
+                </a:solidFill>
+                <a:latin typeface="Arial" pitchFamily="34" charset="0"/>
+                <a:ea typeface="Arial" pitchFamily="34" charset="-122"/>
+                <a:cs typeface="Arial" pitchFamily="34" charset="-120"/>
+              </a:rPr>
+              <a:t>PR 2</a:t>
+            </a:r>
+            <a:endParaRPr lang="en-US" sz="1400" dirty="0"/>
+          </a:p>
+        </p:txBody>
+      </p:sp>
+      <p:sp>
+        <p:nvSpPr>
+          <p:cNvPr id="23" name="Text 21"/>
+          <p:cNvSpPr/>
+          <p:nvPr/>
+        </p:nvSpPr>
+        <p:spPr>
+          <a:xfrm>
+            <a:off x="5299174" y="2904381"/>
+            <a:ext cx="642437" cy="152400"/>
+          </a:xfrm>
+          <a:prstGeom prst="rect">
+            <a:avLst/>
+          </a:prstGeom>
+          <a:noFill/>
+          <a:ln/>
+        </p:spPr>
+        <p:txBody>
+          <a:bodyPr wrap="square" lIns="0" tIns="0" rIns="0" bIns="0" rtlCol="0" anchor="t"/>
+          <a:lstStyle/>
+          <a:p>
+            <a:pPr algn="l" indent="0" marL="0">
+              <a:buNone/>
+            </a:pPr>
+            <a:r>
+              <a:rPr lang="en-US" sz="1050" b="1" dirty="0">
+                <a:solidFill>
+                  <a:srgbClr val="7EE787"/>
+                </a:solidFill>
+                <a:latin typeface="Arial" pitchFamily="34" charset="0"/>
+                <a:ea typeface="Arial" pitchFamily="34" charset="-122"/>
+                <a:cs typeface="Arial" pitchFamily="34" charset="-120"/>
+              </a:rPr>
+              <a:t>Validation</a:t>
+            </a:r>
+            <a:endParaRPr lang="en-US" sz="1050" dirty="0"/>
+          </a:p>
+        </p:txBody>
+      </p:sp>
+      <p:sp>
+        <p:nvSpPr>
+          <p:cNvPr id="24" name="Text 22"/>
+          <p:cNvSpPr/>
+          <p:nvPr/>
+        </p:nvSpPr>
+        <p:spPr>
+          <a:xfrm>
+            <a:off x="3763566" y="3361581"/>
+            <a:ext cx="2550914" cy="609600"/>
+          </a:xfrm>
+          <a:prstGeom prst="roundRect">
+            <a:avLst>
+              <a:gd name="adj" fmla="val 16667"/>
+            </a:avLst>
+          </a:prstGeom>
+          <a:solidFill>
+            <a:srgbClr val="161B22"/>
+          </a:solidFill>
+          <a:ln/>
+          <a:effectLst>
+            <a:outerShdw sx="100000" sy="100000" kx="0" ky="0" algn="bl" rotWithShape="0" blurRad="88900" dist="38100" dir="5400000">
+              <a:srgbClr val="000000">
+                <a:alpha val="30000"/>
+              </a:srgbClr>
+            </a:outerShdw>
+          </a:effectLst>
+        </p:spPr>
+        <p:txBody>
+          <a:bodyPr wrap="square" rtlCol="0" anchor="ctr"/>
+          <a:lstStyle/>
+          <a:p>
+            <a:pPr indent="0" marL="0">
+              <a:buNone/>
+            </a:pPr>
+            <a:endParaRPr lang="en-US" dirty="0"/>
+          </a:p>
+        </p:txBody>
+      </p:sp>
+      <p:sp>
+        <p:nvSpPr>
           <p:cNvPr id="25" name="Shape 23"/>
           <p:cNvSpPr/>
           <p:nvPr/>
         </p:nvSpPr>
         <p:spPr>
           <a:xfrm>
-            <a:off x="7832527" y="2016472"/>
-            <a:ext cx="0" cy="1549301"/>
+            <a:off x="3763566" y="3371106"/>
+            <a:ext cx="2550914" cy="0"/>
           </a:xfrm>
           <a:prstGeom prst="line">
             <a:avLst/>
           </a:prstGeom>
           <a:noFill/>
           <a:ln w="19050">
+            <a:solidFill>
+              <a:srgbClr val="30363D"/>
+            </a:solidFill>
+            <a:prstDash val="solid"/>
+          </a:ln>
+        </p:spPr>
+      </p:sp>
+      <p:sp>
+        <p:nvSpPr>
+          <p:cNvPr id="26" name="Shape 24"/>
+          <p:cNvSpPr/>
+          <p:nvPr/>
+        </p:nvSpPr>
+        <p:spPr>
+          <a:xfrm>
+            <a:off x="6304955" y="3361581"/>
+            <a:ext cx="0" cy="609600"/>
+          </a:xfrm>
+          <a:prstGeom prst="line">
+            <a:avLst/>
+          </a:prstGeom>
+          <a:noFill/>
+          <a:ln w="19050">
+            <a:solidFill>
+              <a:srgbClr val="30363D"/>
+            </a:solidFill>
+            <a:prstDash val="solid"/>
+          </a:ln>
+        </p:spPr>
+      </p:sp>
+      <p:sp>
+        <p:nvSpPr>
+          <p:cNvPr id="27" name="Shape 25"/>
+          <p:cNvSpPr/>
+          <p:nvPr/>
+        </p:nvSpPr>
+        <p:spPr>
+          <a:xfrm>
+            <a:off x="3763566" y="3961656"/>
+            <a:ext cx="2550914" cy="0"/>
+          </a:xfrm>
+          <a:prstGeom prst="line">
+            <a:avLst/>
+          </a:prstGeom>
+          <a:noFill/>
+          <a:ln w="19050">
+            <a:solidFill>
+              <a:srgbClr val="30363D"/>
+            </a:solidFill>
+            <a:prstDash val="solid"/>
+          </a:ln>
+        </p:spPr>
+      </p:sp>
+      <p:sp>
+        <p:nvSpPr>
+          <p:cNvPr id="28" name="Shape 26"/>
+          <p:cNvSpPr/>
+          <p:nvPr/>
+        </p:nvSpPr>
+        <p:spPr>
+          <a:xfrm>
+            <a:off x="3801666" y="3361581"/>
+            <a:ext cx="0" cy="609600"/>
+          </a:xfrm>
+          <a:prstGeom prst="line">
+            <a:avLst/>
+          </a:prstGeom>
+          <a:noFill/>
+          <a:ln w="76200">
             <a:solidFill>
               <a:srgbClr val="3FB950"/>
             </a:solidFill>
@@ -2908,20 +3011,222 @@
       </p:sp>
       <p:sp>
         <p:nvSpPr>
-          <p:cNvPr id="26" name="Shape 24"/>
-          <p:cNvSpPr/>
-          <p:nvPr/>
-        </p:nvSpPr>
-        <p:spPr>
-          <a:xfrm>
-            <a:off x="6026051" y="3556248"/>
-            <a:ext cx="1816001" cy="0"/>
+          <p:cNvPr id="29" name="Text 27"/>
+          <p:cNvSpPr/>
+          <p:nvPr/>
+        </p:nvSpPr>
+        <p:spPr>
+          <a:xfrm>
+            <a:off x="4004816" y="3561606"/>
+            <a:ext cx="403041" cy="209550"/>
+          </a:xfrm>
+          <a:prstGeom prst="rect">
+            <a:avLst/>
+          </a:prstGeom>
+          <a:noFill/>
+          <a:ln/>
+        </p:spPr>
+        <p:txBody>
+          <a:bodyPr wrap="square" lIns="0" tIns="0" rIns="0" bIns="0" rtlCol="0" anchor="t"/>
+          <a:lstStyle/>
+          <a:p>
+            <a:pPr algn="l" indent="0" marL="0">
+              <a:buNone/>
+            </a:pPr>
+            <a:r>
+              <a:rPr lang="en-US" sz="1400" b="1" dirty="0">
+                <a:solidFill>
+                  <a:srgbClr val="F0F6FC"/>
+                </a:solidFill>
+                <a:latin typeface="Arial" pitchFamily="34" charset="0"/>
+                <a:ea typeface="Arial" pitchFamily="34" charset="-122"/>
+                <a:cs typeface="Arial" pitchFamily="34" charset="-120"/>
+              </a:rPr>
+              <a:t>PR 1</a:t>
+            </a:r>
+            <a:endParaRPr lang="en-US" sz="1400" dirty="0"/>
+          </a:p>
+        </p:txBody>
+      </p:sp>
+      <p:sp>
+        <p:nvSpPr>
+          <p:cNvPr id="30" name="Text 28"/>
+          <p:cNvSpPr/>
+          <p:nvPr/>
+        </p:nvSpPr>
+        <p:spPr>
+          <a:xfrm>
+            <a:off x="5745063" y="3590181"/>
+            <a:ext cx="393022" cy="152400"/>
+          </a:xfrm>
+          <a:prstGeom prst="rect">
+            <a:avLst/>
+          </a:prstGeom>
+          <a:noFill/>
+          <a:ln/>
+        </p:spPr>
+        <p:txBody>
+          <a:bodyPr wrap="square" lIns="0" tIns="0" rIns="0" bIns="0" rtlCol="0" anchor="t"/>
+          <a:lstStyle/>
+          <a:p>
+            <a:pPr algn="l" indent="0" marL="0">
+              <a:buNone/>
+            </a:pPr>
+            <a:r>
+              <a:rPr lang="en-US" sz="1050" b="1" dirty="0">
+                <a:solidFill>
+                  <a:srgbClr val="7EE787"/>
+                </a:solidFill>
+                <a:latin typeface="Arial" pitchFamily="34" charset="0"/>
+                <a:ea typeface="Arial" pitchFamily="34" charset="-122"/>
+                <a:cs typeface="Arial" pitchFamily="34" charset="-120"/>
+              </a:rPr>
+              <a:t>Model</a:t>
+            </a:r>
+            <a:endParaRPr lang="en-US" sz="1050" dirty="0"/>
+          </a:p>
+        </p:txBody>
+      </p:sp>
+      <p:sp>
+        <p:nvSpPr>
+          <p:cNvPr id="31" name="Text 29"/>
+          <p:cNvSpPr/>
+          <p:nvPr/>
+        </p:nvSpPr>
+        <p:spPr>
+          <a:xfrm>
+            <a:off x="3696444" y="4072682"/>
+            <a:ext cx="2685306" cy="317450"/>
+          </a:xfrm>
+          <a:prstGeom prst="rect">
+            <a:avLst/>
+          </a:prstGeom>
+          <a:solidFill>
+            <a:srgbClr val="111D2E"/>
+          </a:solidFill>
+          <a:ln/>
+        </p:spPr>
+        <p:txBody>
+          <a:bodyPr wrap="square" rtlCol="0" anchor="ctr"/>
+          <a:lstStyle/>
+          <a:p>
+            <a:pPr indent="0" marL="0">
+              <a:buNone/>
+            </a:pPr>
+            <a:endParaRPr lang="en-US" dirty="0"/>
+          </a:p>
+        </p:txBody>
+      </p:sp>
+      <p:sp>
+        <p:nvSpPr>
+          <p:cNvPr id="32" name="Shape 30"/>
+          <p:cNvSpPr/>
+          <p:nvPr/>
+        </p:nvSpPr>
+        <p:spPr>
+          <a:xfrm>
+            <a:off x="3696444" y="4091732"/>
+            <a:ext cx="2685306" cy="0"/>
           </a:xfrm>
           <a:prstGeom prst="line">
             <a:avLst/>
           </a:prstGeom>
           <a:noFill/>
-          <a:ln w="19050">
+          <a:ln w="38100">
+            <a:solidFill>
+              <a:srgbClr val="58A6FF"/>
+            </a:solidFill>
+            <a:prstDash val="solid"/>
+          </a:ln>
+        </p:spPr>
+      </p:sp>
+      <p:sp>
+        <p:nvSpPr>
+          <p:cNvPr id="33" name="Text 31"/>
+          <p:cNvSpPr/>
+          <p:nvPr/>
+        </p:nvSpPr>
+        <p:spPr>
+          <a:xfrm>
+            <a:off x="4876800" y="4178945"/>
+            <a:ext cx="330934" cy="142875"/>
+          </a:xfrm>
+          <a:prstGeom prst="rect">
+            <a:avLst/>
+          </a:prstGeom>
+          <a:noFill/>
+          <a:ln/>
+        </p:spPr>
+        <p:txBody>
+          <a:bodyPr wrap="square" lIns="0" tIns="0" rIns="0" bIns="0" rtlCol="0" anchor="t"/>
+          <a:lstStyle/>
+          <a:p>
+            <a:pPr algn="l" indent="0" marL="0">
+              <a:buNone/>
+            </a:pPr>
+            <a:r>
+              <a:rPr lang="en-US" sz="1000" b="1" dirty="0">
+                <a:solidFill>
+                  <a:srgbClr val="79C0FF"/>
+                </a:solidFill>
+                <a:latin typeface="Arial" pitchFamily="34" charset="0"/>
+                <a:ea typeface="Arial" pitchFamily="34" charset="-122"/>
+                <a:cs typeface="Arial" pitchFamily="34" charset="-120"/>
+              </a:rPr>
+              <a:t>MAIN</a:t>
+            </a:r>
+            <a:endParaRPr lang="en-US" sz="1000" dirty="0"/>
+          </a:p>
+        </p:txBody>
+      </p:sp>
+      <p:sp>
+        <p:nvSpPr>
+          <p:cNvPr id="34" name="Text 32"/>
+          <p:cNvSpPr/>
+          <p:nvPr/>
+        </p:nvSpPr>
+        <p:spPr>
+          <a:xfrm>
+            <a:off x="6635651" y="1749177"/>
+            <a:ext cx="2025848" cy="806648"/>
+          </a:xfrm>
+          <a:prstGeom prst="roundRect">
+            <a:avLst>
+              <a:gd name="adj" fmla="val 9446"/>
+            </a:avLst>
+          </a:prstGeom>
+          <a:solidFill>
+            <a:srgbClr val="122117"/>
+          </a:solidFill>
+          <a:ln/>
+        </p:spPr>
+        <p:txBody>
+          <a:bodyPr wrap="square" rtlCol="0" anchor="ctr"/>
+          <a:lstStyle/>
+          <a:p>
+            <a:pPr indent="0" marL="0">
+              <a:buNone/>
+            </a:pPr>
+            <a:endParaRPr lang="en-US" dirty="0"/>
+          </a:p>
+        </p:txBody>
+      </p:sp>
+      <p:sp>
+        <p:nvSpPr>
+          <p:cNvPr id="35" name="Shape 33"/>
+          <p:cNvSpPr/>
+          <p:nvPr/>
+        </p:nvSpPr>
+        <p:spPr>
+          <a:xfrm>
+            <a:off x="6659463" y="1749177"/>
+            <a:ext cx="0" cy="806648"/>
+          </a:xfrm>
+          <a:prstGeom prst="line">
+            <a:avLst/>
+          </a:prstGeom>
+          <a:noFill/>
+          <a:ln w="47625">
             <a:solidFill>
               <a:srgbClr val="3FB950"/>
             </a:solidFill>
@@ -2931,20 +3236,136 @@
       </p:sp>
       <p:sp>
         <p:nvSpPr>
-          <p:cNvPr id="27" name="Shape 25"/>
-          <p:cNvSpPr/>
-          <p:nvPr/>
-        </p:nvSpPr>
-        <p:spPr>
-          <a:xfrm>
-            <a:off x="6035576" y="2016472"/>
-            <a:ext cx="0" cy="1549301"/>
+          <p:cNvPr id="36" name="Text 34"/>
+          <p:cNvSpPr/>
+          <p:nvPr/>
+        </p:nvSpPr>
+        <p:spPr>
+          <a:xfrm>
+            <a:off x="6822877" y="1876127"/>
+            <a:ext cx="1733002" cy="200025"/>
+          </a:xfrm>
+          <a:prstGeom prst="rect">
+            <a:avLst/>
+          </a:prstGeom>
+          <a:noFill/>
+          <a:ln/>
+        </p:spPr>
+        <p:txBody>
+          <a:bodyPr wrap="square" lIns="0" tIns="0" rIns="0" bIns="0" rtlCol="0" anchor="t"/>
+          <a:lstStyle/>
+          <a:p>
+            <a:pPr algn="l" indent="0" marL="0">
+              <a:spcAft>
+                <a:spcPts val="300"/>
+              </a:spcAft>
+              <a:buNone/>
+            </a:pPr>
+            <a:r>
+              <a:rPr lang="en-US" sz="1300" b="1" dirty="0">
+                <a:solidFill>
+                  <a:srgbClr val="56D364"/>
+                </a:solidFill>
+                <a:latin typeface="Arial" pitchFamily="34" charset="0"/>
+                <a:ea typeface="Arial" pitchFamily="34" charset="-122"/>
+                <a:cs typeface="Arial" pitchFamily="34" charset="-120"/>
+              </a:rPr>
+              <a:t>Small reviews</a:t>
+            </a:r>
+            <a:endParaRPr lang="en-US" sz="1300" dirty="0"/>
+          </a:p>
+        </p:txBody>
+      </p:sp>
+      <p:sp>
+        <p:nvSpPr>
+          <p:cNvPr id="37" name="Text 35"/>
+          <p:cNvSpPr/>
+          <p:nvPr/>
+        </p:nvSpPr>
+        <p:spPr>
+          <a:xfrm>
+            <a:off x="6822877" y="2114252"/>
+            <a:ext cx="1733002" cy="314623"/>
+          </a:xfrm>
+          <a:prstGeom prst="rect">
+            <a:avLst/>
+          </a:prstGeom>
+          <a:noFill/>
+          <a:ln/>
+        </p:spPr>
+        <p:txBody>
+          <a:bodyPr wrap="square" lIns="0" tIns="0" rIns="0" bIns="0" rtlCol="0" anchor="t"/>
+          <a:lstStyle/>
+          <a:p>
+            <a:pPr algn="l" indent="0" marL="0">
+              <a:lnSpc>
+                <a:spcPts val="1239"/>
+              </a:lnSpc>
+              <a:buNone/>
+            </a:pPr>
+            <a:r>
+              <a:rPr lang="en-US" sz="1050" dirty="0">
+                <a:solidFill>
+                  <a:srgbClr val="C9D1D9"/>
+                </a:solidFill>
+                <a:latin typeface="Arial" pitchFamily="34" charset="0"/>
+                <a:ea typeface="Arial" pitchFamily="34" charset="-122"/>
+                <a:cs typeface="Arial" pitchFamily="34" charset="-120"/>
+              </a:rPr>
+              <a:t>Each layer exposes only its focused change.</a:t>
+            </a:r>
+            <a:endParaRPr lang="en-US" sz="1050" dirty="0"/>
+          </a:p>
+        </p:txBody>
+      </p:sp>
+      <p:sp>
+        <p:nvSpPr>
+          <p:cNvPr id="38" name="Text 36"/>
+          <p:cNvSpPr/>
+          <p:nvPr/>
+        </p:nvSpPr>
+        <p:spPr>
+          <a:xfrm>
+            <a:off x="6635651" y="2670125"/>
+            <a:ext cx="2025848" cy="963960"/>
+          </a:xfrm>
+          <a:prstGeom prst="roundRect">
+            <a:avLst>
+              <a:gd name="adj" fmla="val 7905"/>
+            </a:avLst>
+          </a:prstGeom>
+          <a:solidFill>
+            <a:srgbClr val="122117"/>
+          </a:solidFill>
+          <a:ln/>
+        </p:spPr>
+        <p:txBody>
+          <a:bodyPr wrap="square" rtlCol="0" anchor="ctr"/>
+          <a:lstStyle/>
+          <a:p>
+            <a:pPr indent="0" marL="0">
+              <a:buNone/>
+            </a:pPr>
+            <a:endParaRPr lang="en-US" dirty="0"/>
+          </a:p>
+        </p:txBody>
+      </p:sp>
+      <p:sp>
+        <p:nvSpPr>
+          <p:cNvPr id="39" name="Shape 37"/>
+          <p:cNvSpPr/>
+          <p:nvPr/>
+        </p:nvSpPr>
+        <p:spPr>
+          <a:xfrm>
+            <a:off x="6659463" y="2670125"/>
+            <a:ext cx="0" cy="963960"/>
           </a:xfrm>
           <a:prstGeom prst="line">
             <a:avLst/>
           </a:prstGeom>
           <a:noFill/>
-          <a:ln w="19050">
+          <a:ln w="47625">
             <a:solidFill>
               <a:srgbClr val="3FB950"/>
             </a:solidFill>
@@ -2954,14 +3375,14 @@
       </p:sp>
       <p:sp>
         <p:nvSpPr>
-          <p:cNvPr id="28" name="Text 26"/>
-          <p:cNvSpPr/>
-          <p:nvPr/>
-        </p:nvSpPr>
-        <p:spPr>
-          <a:xfrm>
-            <a:off x="6235601" y="2283172"/>
-            <a:ext cx="1424839" cy="257175"/>
+          <p:cNvPr id="40" name="Text 38"/>
+          <p:cNvSpPr/>
+          <p:nvPr/>
+        </p:nvSpPr>
+        <p:spPr>
+          <a:xfrm>
+            <a:off x="6822877" y="2797076"/>
+            <a:ext cx="1733002" cy="200025"/>
           </a:xfrm>
           <a:prstGeom prst="rect">
             <a:avLst/>
@@ -2975,35 +3396,35 @@
           <a:p>
             <a:pPr algn="l" indent="0" marL="0">
               <a:spcAft>
-                <a:spcPts val="500"/>
+                <a:spcPts val="300"/>
               </a:spcAft>
               <a:buNone/>
             </a:pPr>
             <a:r>
-              <a:rPr lang="en-US" sz="1700" b="1" dirty="0">
-                <a:solidFill>
-                  <a:srgbClr val="F0F6FC"/>
+              <a:rPr lang="en-US" sz="1300" b="1" dirty="0">
+                <a:solidFill>
+                  <a:srgbClr val="56D364"/>
                 </a:solidFill>
                 <a:latin typeface="Arial" pitchFamily="34" charset="0"/>
                 <a:ea typeface="Arial" pitchFamily="34" charset="-122"/>
                 <a:cs typeface="Arial" pitchFamily="34" charset="-120"/>
               </a:rPr>
-              <a:t>PR #3</a:t>
-            </a:r>
-            <a:endParaRPr lang="en-US" sz="1700" dirty="0"/>
-          </a:p>
-        </p:txBody>
-      </p:sp>
-      <p:sp>
-        <p:nvSpPr>
-          <p:cNvPr id="29" name="Text 27"/>
-          <p:cNvSpPr/>
-          <p:nvPr/>
-        </p:nvSpPr>
-        <p:spPr>
-          <a:xfrm>
-            <a:off x="6235601" y="2603748"/>
-            <a:ext cx="1424839" cy="152400"/>
+              <a:t>Continuous progress</a:t>
+            </a:r>
+            <a:endParaRPr lang="en-US" sz="1300" dirty="0"/>
+          </a:p>
+        </p:txBody>
+      </p:sp>
+      <p:sp>
+        <p:nvSpPr>
+          <p:cNvPr id="41" name="Text 39"/>
+          <p:cNvSpPr/>
+          <p:nvPr/>
+        </p:nvSpPr>
+        <p:spPr>
+          <a:xfrm>
+            <a:off x="6822877" y="3035201"/>
+            <a:ext cx="1733002" cy="471934"/>
           </a:xfrm>
           <a:prstGeom prst="rect">
             <a:avLst/>
@@ -3016,52 +3437,13 @@
           <a:lstStyle/>
           <a:p>
             <a:pPr algn="l" indent="0" marL="0">
+              <a:lnSpc>
+                <a:spcPts val="1239"/>
+              </a:lnSpc>
               <a:buNone/>
             </a:pPr>
             <a:r>
               <a:rPr lang="en-US" sz="1050" dirty="0">
-                <a:solidFill>
-                  <a:srgbClr val="8B949E"/>
-                </a:solidFill>
-                <a:latin typeface="Courier New" pitchFamily="34" charset="0"/>
-                <a:ea typeface="Courier New" pitchFamily="34" charset="-122"/>
-                <a:cs typeface="Courier New" pitchFamily="34" charset="-120"/>
-              </a:rPr>
-              <a:t>base: PR #2</a:t>
-            </a:r>
-            <a:endParaRPr lang="en-US" sz="1050" dirty="0"/>
-          </a:p>
-        </p:txBody>
-      </p:sp>
-      <p:sp>
-        <p:nvSpPr>
-          <p:cNvPr id="30" name="Text 28"/>
-          <p:cNvSpPr/>
-          <p:nvPr/>
-        </p:nvSpPr>
-        <p:spPr>
-          <a:xfrm>
-            <a:off x="6235601" y="3184773"/>
-            <a:ext cx="1424839" cy="171450"/>
-          </a:xfrm>
-          <a:prstGeom prst="rect">
-            <a:avLst/>
-          </a:prstGeom>
-          <a:noFill/>
-          <a:ln/>
-        </p:spPr>
-        <p:txBody>
-          <a:bodyPr wrap="square" lIns="0" tIns="0" rIns="0" bIns="0" rtlCol="0" anchor="t"/>
-          <a:lstStyle/>
-          <a:p>
-            <a:pPr algn="l" indent="0" marL="0">
-              <a:spcBef>
-                <a:spcPts val="3375"/>
-              </a:spcBef>
-              <a:buNone/>
-            </a:pPr>
-            <a:r>
-              <a:rPr lang="en-US" sz="1200" dirty="0">
                 <a:solidFill>
                   <a:srgbClr val="C9D1D9"/>
                 </a:solidFill>
@@ -3069,58 +3451,77 @@
                 <a:ea typeface="Arial" pitchFamily="34" charset="-122"/>
                 <a:cs typeface="Arial" pitchFamily="34" charset="-120"/>
               </a:rPr>
-              <a:t>Tests</a:t>
-            </a:r>
-            <a:endParaRPr lang="en-US" sz="1200" dirty="0"/>
-          </a:p>
-        </p:txBody>
-      </p:sp>
-      <p:sp>
-        <p:nvSpPr>
-          <p:cNvPr id="31" name="Text 29"/>
-          <p:cNvSpPr/>
-          <p:nvPr/>
-        </p:nvSpPr>
-        <p:spPr>
-          <a:xfrm>
-            <a:off x="482501" y="4105424"/>
-            <a:ext cx="2624733" cy="641152"/>
+              <a:t>Dependent work can continue before lower layers merge.</a:t>
+            </a:r>
+            <a:endParaRPr lang="en-US" sz="1050" dirty="0"/>
+          </a:p>
+        </p:txBody>
+      </p:sp>
+      <p:sp>
+        <p:nvSpPr>
+          <p:cNvPr id="42" name="Text 40"/>
+          <p:cNvSpPr/>
+          <p:nvPr/>
+        </p:nvSpPr>
+        <p:spPr>
+          <a:xfrm>
+            <a:off x="6635651" y="3748385"/>
+            <a:ext cx="2025848" cy="806648"/>
           </a:xfrm>
           <a:prstGeom prst="roundRect">
             <a:avLst>
-              <a:gd name="adj" fmla="val 15847"/>
+              <a:gd name="adj" fmla="val 9446"/>
             </a:avLst>
           </a:prstGeom>
           <a:solidFill>
             <a:srgbClr val="122117"/>
           </a:solidFill>
-          <a:ln w="9525">
+          <a:ln/>
+        </p:spPr>
+        <p:txBody>
+          <a:bodyPr wrap="square" rtlCol="0" anchor="ctr"/>
+          <a:lstStyle/>
+          <a:p>
+            <a:pPr indent="0" marL="0">
+              <a:buNone/>
+            </a:pPr>
+            <a:endParaRPr lang="en-US" dirty="0"/>
+          </a:p>
+        </p:txBody>
+      </p:sp>
+      <p:sp>
+        <p:nvSpPr>
+          <p:cNvPr id="43" name="Shape 41"/>
+          <p:cNvSpPr/>
+          <p:nvPr/>
+        </p:nvSpPr>
+        <p:spPr>
+          <a:xfrm>
+            <a:off x="6659463" y="3748385"/>
+            <a:ext cx="0" cy="806648"/>
+          </a:xfrm>
+          <a:prstGeom prst="line">
+            <a:avLst/>
+          </a:prstGeom>
+          <a:noFill/>
+          <a:ln w="47625">
             <a:solidFill>
-              <a:srgbClr val="238636"/>
+              <a:srgbClr val="3FB950"/>
             </a:solidFill>
+            <a:prstDash val="solid"/>
           </a:ln>
         </p:spPr>
-        <p:txBody>
-          <a:bodyPr wrap="square" rtlCol="0" anchor="ctr"/>
-          <a:lstStyle/>
-          <a:p>
-            <a:pPr indent="0" marL="0">
-              <a:buNone/>
-            </a:pPr>
-            <a:endParaRPr lang="en-US" dirty="0"/>
-          </a:p>
-        </p:txBody>
-      </p:sp>
-      <p:sp>
-        <p:nvSpPr>
-          <p:cNvPr id="32" name="Text 30"/>
-          <p:cNvSpPr/>
-          <p:nvPr/>
-        </p:nvSpPr>
-        <p:spPr>
-          <a:xfrm>
-            <a:off x="644426" y="4241899"/>
-            <a:ext cx="2346900" cy="368201"/>
+      </p:sp>
+      <p:sp>
+        <p:nvSpPr>
+          <p:cNvPr id="44" name="Text 42"/>
+          <p:cNvSpPr/>
+          <p:nvPr/>
+        </p:nvSpPr>
+        <p:spPr>
+          <a:xfrm>
+            <a:off x="6822877" y="3875336"/>
+            <a:ext cx="1733002" cy="200025"/>
           </a:xfrm>
           <a:prstGeom prst="rect">
             <a:avLst/>
@@ -3133,13 +3534,13 @@
           <a:lstStyle/>
           <a:p>
             <a:pPr algn="l" indent="0" marL="0">
-              <a:lnSpc>
-                <a:spcPts val="1450"/>
-              </a:lnSpc>
-              <a:buNone/>
-            </a:pPr>
-            <a:r>
-              <a:rPr lang="en-US" sz="1250" b="1" dirty="0">
+              <a:spcAft>
+                <a:spcPts val="300"/>
+              </a:spcAft>
+              <a:buNone/>
+            </a:pPr>
+            <a:r>
+              <a:rPr lang="en-US" sz="1300" b="1" dirty="0">
                 <a:solidFill>
                   <a:srgbClr val="56D364"/>
                 </a:solidFill>
@@ -3147,243 +3548,51 @@
                 <a:ea typeface="Arial" pitchFamily="34" charset="-122"/>
                 <a:cs typeface="Arial" pitchFamily="34" charset="-120"/>
               </a:rPr>
-              <a:t>Developers keep moving</a:t>
-            </a:r>
+              <a:t>Shared context</a:t>
+            </a:r>
+            <a:endParaRPr lang="en-US" sz="1300" dirty="0"/>
+          </a:p>
+        </p:txBody>
+      </p:sp>
+      <p:sp>
+        <p:nvSpPr>
+          <p:cNvPr id="45" name="Text 43"/>
+          <p:cNvSpPr/>
+          <p:nvPr/>
+        </p:nvSpPr>
+        <p:spPr>
+          <a:xfrm>
+            <a:off x="6822877" y="4113461"/>
+            <a:ext cx="1733002" cy="314623"/>
+          </a:xfrm>
+          <a:prstGeom prst="rect">
+            <a:avLst/>
+          </a:prstGeom>
+          <a:noFill/>
+          <a:ln/>
+        </p:spPr>
+        <p:txBody>
+          <a:bodyPr wrap="square" lIns="0" tIns="0" rIns="0" bIns="0" rtlCol="0" anchor="t"/>
+          <a:lstStyle/>
+          <a:p>
             <a:pPr algn="l" indent="0" marL="0">
               <a:lnSpc>
-                <a:spcPts val="1450"/>
+                <a:spcPts val="1239"/>
               </a:lnSpc>
               <a:buNone/>
             </a:pPr>
-            <a:endParaRPr lang="en-US" sz="1250" dirty="0"/>
-          </a:p>
-          <a:p>
-            <a:pPr algn="l" indent="0" marL="0">
-              <a:lnSpc>
-                <a:spcPts val="1450"/>
-              </a:lnSpc>
-              <a:buNone/>
-            </a:pPr>
-            <a:r>
-              <a:rPr lang="en-US" sz="1250" dirty="0">
-                <a:solidFill>
-                  <a:srgbClr val="D2F4D5"/>
+            <a:r>
+              <a:rPr lang="en-US" sz="1050" dirty="0">
+                <a:solidFill>
+                  <a:srgbClr val="C9D1D9"/>
                 </a:solidFill>
                 <a:latin typeface="Arial" pitchFamily="34" charset="0"/>
                 <a:ea typeface="Arial" pitchFamily="34" charset="-122"/>
                 <a:cs typeface="Arial" pitchFamily="34" charset="-120"/>
               </a:rPr>
-              <a:t>on dependent work</a:t>
-            </a:r>
-            <a:endParaRPr lang="en-US" sz="1250" dirty="0"/>
-          </a:p>
-        </p:txBody>
-      </p:sp>
-      <p:sp>
-        <p:nvSpPr>
-          <p:cNvPr id="33" name="Text 31"/>
-          <p:cNvSpPr/>
-          <p:nvPr/>
-        </p:nvSpPr>
-        <p:spPr>
-          <a:xfrm>
-            <a:off x="3259634" y="4105424"/>
-            <a:ext cx="2624733" cy="641152"/>
-          </a:xfrm>
-          <a:prstGeom prst="roundRect">
-            <a:avLst>
-              <a:gd name="adj" fmla="val 15847"/>
-            </a:avLst>
-          </a:prstGeom>
-          <a:solidFill>
-            <a:srgbClr val="122117"/>
-          </a:solidFill>
-          <a:ln w="9525">
-            <a:solidFill>
-              <a:srgbClr val="238636"/>
-            </a:solidFill>
-          </a:ln>
-        </p:spPr>
-        <p:txBody>
-          <a:bodyPr wrap="square" rtlCol="0" anchor="ctr"/>
-          <a:lstStyle/>
-          <a:p>
-            <a:pPr indent="0" marL="0">
-              <a:buNone/>
-            </a:pPr>
-            <a:endParaRPr lang="en-US" dirty="0"/>
-          </a:p>
-        </p:txBody>
-      </p:sp>
-      <p:sp>
-        <p:nvSpPr>
-          <p:cNvPr id="34" name="Text 32"/>
-          <p:cNvSpPr/>
-          <p:nvPr/>
-        </p:nvSpPr>
-        <p:spPr>
-          <a:xfrm>
-            <a:off x="3421559" y="4241899"/>
-            <a:ext cx="2346900" cy="368201"/>
-          </a:xfrm>
-          <a:prstGeom prst="rect">
-            <a:avLst/>
-          </a:prstGeom>
-          <a:noFill/>
-          <a:ln/>
-        </p:spPr>
-        <p:txBody>
-          <a:bodyPr wrap="square" lIns="0" tIns="0" rIns="0" bIns="0" rtlCol="0" anchor="t"/>
-          <a:lstStyle/>
-          <a:p>
-            <a:pPr algn="l" indent="0" marL="0">
-              <a:lnSpc>
-                <a:spcPts val="1450"/>
-              </a:lnSpc>
-              <a:buNone/>
-            </a:pPr>
-            <a:r>
-              <a:rPr lang="en-US" sz="1250" b="1" dirty="0">
-                <a:solidFill>
-                  <a:srgbClr val="56D364"/>
-                </a:solidFill>
-                <a:latin typeface="Arial" pitchFamily="34" charset="0"/>
-                <a:ea typeface="Arial" pitchFamily="34" charset="-122"/>
-                <a:cs typeface="Arial" pitchFamily="34" charset="-120"/>
-              </a:rPr>
-              <a:t>Reviewers see less</a:t>
-            </a:r>
-            <a:pPr algn="l" indent="0" marL="0">
-              <a:lnSpc>
-                <a:spcPts val="1450"/>
-              </a:lnSpc>
-              <a:buNone/>
-            </a:pPr>
-            <a:endParaRPr lang="en-US" sz="1250" dirty="0"/>
-          </a:p>
-          <a:p>
-            <a:pPr algn="l" indent="0" marL="0">
-              <a:lnSpc>
-                <a:spcPts val="1450"/>
-              </a:lnSpc>
-              <a:buNone/>
-            </a:pPr>
-            <a:r>
-              <a:rPr lang="en-US" sz="1250" dirty="0">
-                <a:solidFill>
-                  <a:srgbClr val="D2F4D5"/>
-                </a:solidFill>
-                <a:latin typeface="Arial" pitchFamily="34" charset="0"/>
-                <a:ea typeface="Arial" pitchFamily="34" charset="-122"/>
-                <a:cs typeface="Arial" pitchFamily="34" charset="-120"/>
-              </a:rPr>
-              <a:t>in each focused diff</a:t>
-            </a:r>
-            <a:endParaRPr lang="en-US" sz="1250" dirty="0"/>
-          </a:p>
-        </p:txBody>
-      </p:sp>
-      <p:sp>
-        <p:nvSpPr>
-          <p:cNvPr id="35" name="Text 33"/>
-          <p:cNvSpPr/>
-          <p:nvPr/>
-        </p:nvSpPr>
-        <p:spPr>
-          <a:xfrm>
-            <a:off x="6036766" y="4105424"/>
-            <a:ext cx="2624733" cy="641152"/>
-          </a:xfrm>
-          <a:prstGeom prst="roundRect">
-            <a:avLst>
-              <a:gd name="adj" fmla="val 15847"/>
-            </a:avLst>
-          </a:prstGeom>
-          <a:solidFill>
-            <a:srgbClr val="122117"/>
-          </a:solidFill>
-          <a:ln w="9525">
-            <a:solidFill>
-              <a:srgbClr val="238636"/>
-            </a:solidFill>
-          </a:ln>
-        </p:spPr>
-        <p:txBody>
-          <a:bodyPr wrap="square" rtlCol="0" anchor="ctr"/>
-          <a:lstStyle/>
-          <a:p>
-            <a:pPr indent="0" marL="0">
-              <a:buNone/>
-            </a:pPr>
-            <a:endParaRPr lang="en-US" dirty="0"/>
-          </a:p>
-        </p:txBody>
-      </p:sp>
-      <p:sp>
-        <p:nvSpPr>
-          <p:cNvPr id="36" name="Text 34"/>
-          <p:cNvSpPr/>
-          <p:nvPr/>
-        </p:nvSpPr>
-        <p:spPr>
-          <a:xfrm>
-            <a:off x="6198691" y="4241899"/>
-            <a:ext cx="2346900" cy="368201"/>
-          </a:xfrm>
-          <a:prstGeom prst="rect">
-            <a:avLst/>
-          </a:prstGeom>
-          <a:noFill/>
-          <a:ln/>
-        </p:spPr>
-        <p:txBody>
-          <a:bodyPr wrap="square" lIns="0" tIns="0" rIns="0" bIns="0" rtlCol="0" anchor="t"/>
-          <a:lstStyle/>
-          <a:p>
-            <a:pPr algn="l" indent="0" marL="0">
-              <a:lnSpc>
-                <a:spcPts val="1450"/>
-              </a:lnSpc>
-              <a:buNone/>
-            </a:pPr>
-            <a:r>
-              <a:rPr lang="en-US" sz="1250" b="1" dirty="0">
-                <a:solidFill>
-                  <a:srgbClr val="56D364"/>
-                </a:solidFill>
-                <a:latin typeface="Arial" pitchFamily="34" charset="0"/>
-                <a:ea typeface="Arial" pitchFamily="34" charset="-122"/>
-                <a:cs typeface="Arial" pitchFamily="34" charset="-120"/>
-              </a:rPr>
-              <a:t>GitHub keeps context</a:t>
-            </a:r>
-            <a:pPr algn="l" indent="0" marL="0">
-              <a:lnSpc>
-                <a:spcPts val="1450"/>
-              </a:lnSpc>
-              <a:buNone/>
-            </a:pPr>
-            <a:endParaRPr lang="en-US" sz="1250" dirty="0"/>
-          </a:p>
-          <a:p>
-            <a:pPr algn="l" indent="0" marL="0">
-              <a:lnSpc>
-                <a:spcPts val="1450"/>
-              </a:lnSpc>
-              <a:buNone/>
-            </a:pPr>
-            <a:r>
-              <a:rPr lang="en-US" sz="1250" dirty="0">
-                <a:solidFill>
-                  <a:srgbClr val="D2F4D5"/>
-                </a:solidFill>
-                <a:latin typeface="Arial" pitchFamily="34" charset="0"/>
-                <a:ea typeface="Arial" pitchFamily="34" charset="-122"/>
-                <a:cs typeface="Arial" pitchFamily="34" charset="-120"/>
-              </a:rPr>
-              <a:t>with the stack map</a:t>
-            </a:r>
-            <a:endParaRPr lang="en-US" sz="1250" dirty="0"/>
+              <a:t>GitHub keeps the layers connected as one stack.</a:t>
+            </a:r>
+            <a:endParaRPr lang="en-US" sz="1050" dirty="0"/>
           </a:p>
         </p:txBody>
       </p:sp>

</xml_diff>

<commit_message>
docs: brand and verify stacked PR deck
</commit_message>
<xml_diff>
--- a/github-stacked-prs.pptx
+++ b/github-stacked-prs.pptx
@@ -2095,6 +2095,107 @@
           </a:p>
         </p:txBody>
       </p:sp>
+      <p:sp>
+        <p:nvSpPr>
+          <p:cNvPr id="32" name="Shape 30"/>
+          <p:cNvSpPr/>
+          <p:nvPr/>
+        </p:nvSpPr>
+        <p:spPr>
+          <a:xfrm>
+            <a:off x="7708392" y="146304"/>
+            <a:ext cx="1078992" cy="283464"/>
+          </a:xfrm>
+          <a:prstGeom prst="roundRect">
+            <a:avLst>
+              <a:gd name="adj" fmla="val 19355"/>
+            </a:avLst>
+          </a:prstGeom>
+          <a:solidFill>
+            <a:srgbClr val="1A5D2A"/>
+          </a:solidFill>
+          <a:ln w="12700">
+            <a:solidFill>
+              <a:srgbClr val="2EA043"/>
+            </a:solidFill>
+            <a:prstDash val="solid"/>
+          </a:ln>
+        </p:spPr>
+      </p:sp>
+      <p:sp>
+        <p:nvSpPr>
+          <p:cNvPr id="33" name="Text 31">
+            <a:hlinkClick r:id="rId1" tooltip=""/>
+          </p:cNvPr>
+          <p:cNvSpPr/>
+          <p:nvPr/>
+        </p:nvSpPr>
+        <p:spPr>
+          <a:xfrm>
+            <a:off x="7708392" y="146304"/>
+            <a:ext cx="1078992" cy="283464"/>
+          </a:xfrm>
+          <a:prstGeom prst="rect">
+            <a:avLst/>
+          </a:prstGeom>
+          <a:noFill/>
+          <a:ln/>
+        </p:spPr>
+        <p:txBody>
+          <a:bodyPr wrap="square" lIns="0" tIns="0" rIns="0" bIns="0" rtlCol="0" anchor="ctr"/>
+          <a:lstStyle/>
+          <a:p>
+            <a:pPr algn="ctr" indent="0" marL="0">
+              <a:buNone/>
+            </a:pPr>
+            <a:r>
+              <a:rPr lang="en-US" sz="1050" b="1" u="sng" dirty="0">
+                <a:solidFill>
+                  <a:srgbClr val="FFFFFF"/>
+                </a:solidFill>
+                <a:latin typeface="Arial" pitchFamily="34" charset="0"/>
+                <a:ea typeface="Arial" pitchFamily="34" charset="-122"/>
+                <a:cs typeface="Arial" pitchFamily="34" charset="-120"/>
+                <a:hlinkClick r:id="rId1" invalidUrl="" action="" tgtFrame="" tooltip="" history="1" highlightClick="0" endSnd="0">
+                  <a:extLst>
+                    <a:ext uri="{A12FA001-AC4F-418D-AE19-62706E023703}">
+                      <ahyp:hlinkClr xmlns:ahyp="http://schemas.microsoft.com/office/drawing/2018/hyperlinkcolor" val="tx"/>
+                    </a:ext>
+                  </a:extLst>
+                </a:hlinkClick>
+              </a:rPr>
+              <a:t>gh.io/stacks</a:t>
+            </a:r>
+            <a:endParaRPr lang="en-US" sz="1050" dirty="0"/>
+          </a:p>
+        </p:txBody>
+      </p:sp>
+      <p:pic>
+        <p:nvPicPr>
+          <p:cNvPr id="34" name="Image 0" descr="/root/projects/work/gh-stack-demo/slides/github-invertocat.png">
+            <a:hlinkClick r:id="rId3" tooltip=""/>
+          </p:cNvPr>
+          <p:cNvPicPr>
+            <a:picLocks noChangeAspect="1"/>
+          </p:cNvPicPr>
+          <p:nvPr/>
+        </p:nvPicPr>
+        <p:blipFill>
+          <a:blip r:embed="rId2"/>
+          <a:stretch>
+            <a:fillRect/>
+          </a:stretch>
+        </p:blipFill>
+        <p:spPr>
+          <a:xfrm>
+            <a:off x="8622792" y="4626864"/>
+            <a:ext cx="301752" cy="301752"/>
+          </a:xfrm>
+          <a:prstGeom prst="rect">
+            <a:avLst/>
+          </a:prstGeom>
+        </p:spPr>
+      </p:pic>
     </p:spTree>
   </p:cSld>
   <p:clrMapOvr>
@@ -2178,7 +2279,7 @@
         <p:spPr>
           <a:xfrm>
             <a:off x="482501" y="584150"/>
-            <a:ext cx="8342578" cy="383084"/>
+            <a:ext cx="8342578" cy="766167"/>
           </a:xfrm>
           <a:prstGeom prst="rect">
             <a:avLst/>
@@ -2205,7 +2306,7 @@
                 <a:ea typeface="Arial" pitchFamily="34" charset="-122"/>
                 <a:cs typeface="Arial" pitchFamily="34" charset="-120"/>
               </a:rPr>
-              <a:t>Turn one large change into reviewable layers</a:t>
+              <a:t>Turn one large pull request into reviewable layers</a:t>
             </a:r>
             <a:endParaRPr lang="en-US" sz="2900" dirty="0"/>
           </a:p>
@@ -2219,7 +2320,7 @@
         </p:nvSpPr>
         <p:spPr>
           <a:xfrm>
-            <a:off x="482501" y="1043434"/>
+            <a:off x="482501" y="1426518"/>
             <a:ext cx="8342578" cy="219075"/>
           </a:xfrm>
           <a:prstGeom prst="rect">
@@ -2264,7 +2365,7 @@
         </p:nvSpPr>
         <p:spPr>
           <a:xfrm>
-            <a:off x="482501" y="2009180"/>
+            <a:off x="482501" y="2200721"/>
             <a:ext cx="2095054" cy="2286000"/>
           </a:xfrm>
           <a:prstGeom prst="roundRect">
@@ -2300,7 +2401,7 @@
         </p:nvSpPr>
         <p:spPr>
           <a:xfrm>
-            <a:off x="730151" y="2365772"/>
+            <a:off x="730151" y="2557314"/>
             <a:ext cx="1631749" cy="158651"/>
           </a:xfrm>
           <a:prstGeom prst="rect">
@@ -2345,7 +2446,7 @@
         </p:nvSpPr>
         <p:spPr>
           <a:xfrm>
-            <a:off x="730151" y="2625923"/>
+            <a:off x="730151" y="2817465"/>
             <a:ext cx="1631749" cy="590550"/>
           </a:xfrm>
           <a:prstGeom prst="rect">
@@ -2373,7 +2474,7 @@
                 <a:ea typeface="Arial" pitchFamily="34" charset="-122"/>
                 <a:cs typeface="Arial" pitchFamily="34" charset="-120"/>
               </a:rPr>
-              <a:t>One large feature</a:t>
+              <a:t>One large pull request</a:t>
             </a:r>
             <a:endParaRPr lang="en-US" sz="2000" dirty="0"/>
           </a:p>
@@ -2387,7 +2488,7 @@
         </p:nvSpPr>
         <p:spPr>
           <a:xfrm>
-            <a:off x="730151" y="3343424"/>
+            <a:off x="730151" y="3534966"/>
             <a:ext cx="1631749" cy="595164"/>
           </a:xfrm>
           <a:prstGeom prst="rect">
@@ -2429,7 +2530,7 @@
         </p:nvSpPr>
         <p:spPr>
           <a:xfrm>
-            <a:off x="2825344" y="2937867"/>
+            <a:off x="2825344" y="3129409"/>
             <a:ext cx="623310" cy="428625"/>
           </a:xfrm>
           <a:prstGeom prst="rect">
@@ -2468,7 +2569,7 @@
         </p:nvSpPr>
         <p:spPr>
           <a:xfrm>
-            <a:off x="4166443" y="1989981"/>
+            <a:off x="4166443" y="2181523"/>
             <a:ext cx="1745307" cy="609600"/>
           </a:xfrm>
           <a:prstGeom prst="roundRect">
@@ -2507,7 +2608,7 @@
         </p:nvSpPr>
         <p:spPr>
           <a:xfrm>
-            <a:off x="4166443" y="1999506"/>
+            <a:off x="4166443" y="2191048"/>
             <a:ext cx="1745307" cy="0"/>
           </a:xfrm>
           <a:prstGeom prst="line">
@@ -2530,7 +2631,7 @@
         </p:nvSpPr>
         <p:spPr>
           <a:xfrm>
-            <a:off x="5902226" y="1989981"/>
+            <a:off x="5902226" y="2181523"/>
             <a:ext cx="0" cy="609600"/>
           </a:xfrm>
           <a:prstGeom prst="line">
@@ -2553,7 +2654,7 @@
         </p:nvSpPr>
         <p:spPr>
           <a:xfrm>
-            <a:off x="4166443" y="2590056"/>
+            <a:off x="4166443" y="2781598"/>
             <a:ext cx="1745307" cy="0"/>
           </a:xfrm>
           <a:prstGeom prst="line">
@@ -2576,7 +2677,7 @@
         </p:nvSpPr>
         <p:spPr>
           <a:xfrm>
-            <a:off x="4204543" y="1989981"/>
+            <a:off x="4204543" y="2181523"/>
             <a:ext cx="0" cy="609600"/>
           </a:xfrm>
           <a:prstGeom prst="line">
@@ -2599,7 +2700,7 @@
         </p:nvSpPr>
         <p:spPr>
           <a:xfrm>
-            <a:off x="4407694" y="2190006"/>
+            <a:off x="4407694" y="2381548"/>
             <a:ext cx="403041" cy="209550"/>
           </a:xfrm>
           <a:prstGeom prst="rect">
@@ -2638,7 +2739,7 @@
         </p:nvSpPr>
         <p:spPr>
           <a:xfrm>
-            <a:off x="5389066" y="2218581"/>
+            <a:off x="5389066" y="2410123"/>
             <a:ext cx="345356" cy="152400"/>
           </a:xfrm>
           <a:prstGeom prst="rect">
@@ -2677,7 +2778,7 @@
         </p:nvSpPr>
         <p:spPr>
           <a:xfrm>
-            <a:off x="3964930" y="2675781"/>
+            <a:off x="3964930" y="2867323"/>
             <a:ext cx="2148185" cy="609600"/>
           </a:xfrm>
           <a:prstGeom prst="roundRect">
@@ -2716,7 +2817,7 @@
         </p:nvSpPr>
         <p:spPr>
           <a:xfrm>
-            <a:off x="3964930" y="2685306"/>
+            <a:off x="3964930" y="2876848"/>
             <a:ext cx="2148185" cy="0"/>
           </a:xfrm>
           <a:prstGeom prst="line">
@@ -2739,7 +2840,7 @@
         </p:nvSpPr>
         <p:spPr>
           <a:xfrm>
-            <a:off x="6103590" y="2675781"/>
+            <a:off x="6103590" y="2867323"/>
             <a:ext cx="0" cy="609600"/>
           </a:xfrm>
           <a:prstGeom prst="line">
@@ -2762,7 +2863,7 @@
         </p:nvSpPr>
         <p:spPr>
           <a:xfrm>
-            <a:off x="3964930" y="3275856"/>
+            <a:off x="3964930" y="3467398"/>
             <a:ext cx="2148185" cy="0"/>
           </a:xfrm>
           <a:prstGeom prst="line">
@@ -2785,7 +2886,7 @@
         </p:nvSpPr>
         <p:spPr>
           <a:xfrm>
-            <a:off x="4003030" y="2675781"/>
+            <a:off x="4003030" y="2867323"/>
             <a:ext cx="0" cy="609600"/>
           </a:xfrm>
           <a:prstGeom prst="line">
@@ -2808,7 +2909,7 @@
         </p:nvSpPr>
         <p:spPr>
           <a:xfrm>
-            <a:off x="4206180" y="2875806"/>
+            <a:off x="4206180" y="3067348"/>
             <a:ext cx="403041" cy="209550"/>
           </a:xfrm>
           <a:prstGeom prst="rect">
@@ -2847,7 +2948,7 @@
         </p:nvSpPr>
         <p:spPr>
           <a:xfrm>
-            <a:off x="5299174" y="2904381"/>
+            <a:off x="5299174" y="3095923"/>
             <a:ext cx="642437" cy="152400"/>
           </a:xfrm>
           <a:prstGeom prst="rect">
@@ -2886,7 +2987,7 @@
         </p:nvSpPr>
         <p:spPr>
           <a:xfrm>
-            <a:off x="3763566" y="3361581"/>
+            <a:off x="3763566" y="3553123"/>
             <a:ext cx="2550914" cy="609600"/>
           </a:xfrm>
           <a:prstGeom prst="roundRect">
@@ -2925,7 +3026,7 @@
         </p:nvSpPr>
         <p:spPr>
           <a:xfrm>
-            <a:off x="3763566" y="3371106"/>
+            <a:off x="3763566" y="3562648"/>
             <a:ext cx="2550914" cy="0"/>
           </a:xfrm>
           <a:prstGeom prst="line">
@@ -2948,7 +3049,7 @@
         </p:nvSpPr>
         <p:spPr>
           <a:xfrm>
-            <a:off x="6304955" y="3361581"/>
+            <a:off x="6304955" y="3553123"/>
             <a:ext cx="0" cy="609600"/>
           </a:xfrm>
           <a:prstGeom prst="line">
@@ -2971,7 +3072,7 @@
         </p:nvSpPr>
         <p:spPr>
           <a:xfrm>
-            <a:off x="3763566" y="3961656"/>
+            <a:off x="3763566" y="4153198"/>
             <a:ext cx="2550914" cy="0"/>
           </a:xfrm>
           <a:prstGeom prst="line">
@@ -2994,7 +3095,7 @@
         </p:nvSpPr>
         <p:spPr>
           <a:xfrm>
-            <a:off x="3801666" y="3361581"/>
+            <a:off x="3801666" y="3553123"/>
             <a:ext cx="0" cy="609600"/>
           </a:xfrm>
           <a:prstGeom prst="line">
@@ -3017,7 +3118,7 @@
         </p:nvSpPr>
         <p:spPr>
           <a:xfrm>
-            <a:off x="4004816" y="3561606"/>
+            <a:off x="4004816" y="3753148"/>
             <a:ext cx="403041" cy="209550"/>
           </a:xfrm>
           <a:prstGeom prst="rect">
@@ -3056,7 +3157,7 @@
         </p:nvSpPr>
         <p:spPr>
           <a:xfrm>
-            <a:off x="5745063" y="3590181"/>
+            <a:off x="5745063" y="3781723"/>
             <a:ext cx="393022" cy="152400"/>
           </a:xfrm>
           <a:prstGeom prst="rect">
@@ -3095,7 +3196,7 @@
         </p:nvSpPr>
         <p:spPr>
           <a:xfrm>
-            <a:off x="3696444" y="4072682"/>
+            <a:off x="3696444" y="4264223"/>
             <a:ext cx="2685306" cy="317450"/>
           </a:xfrm>
           <a:prstGeom prst="rect">
@@ -3125,7 +3226,7 @@
         </p:nvSpPr>
         <p:spPr>
           <a:xfrm>
-            <a:off x="3696444" y="4091732"/>
+            <a:off x="3696444" y="4283273"/>
             <a:ext cx="2685306" cy="0"/>
           </a:xfrm>
           <a:prstGeom prst="line">
@@ -3148,7 +3249,7 @@
         </p:nvSpPr>
         <p:spPr>
           <a:xfrm>
-            <a:off x="4876800" y="4178945"/>
+            <a:off x="4876800" y="4370487"/>
             <a:ext cx="330934" cy="142875"/>
           </a:xfrm>
           <a:prstGeom prst="rect">
@@ -3187,7 +3288,7 @@
         </p:nvSpPr>
         <p:spPr>
           <a:xfrm>
-            <a:off x="6635651" y="1749177"/>
+            <a:off x="6635651" y="1940719"/>
             <a:ext cx="2025848" cy="806648"/>
           </a:xfrm>
           <a:prstGeom prst="roundRect">
@@ -3219,7 +3320,7 @@
         </p:nvSpPr>
         <p:spPr>
           <a:xfrm>
-            <a:off x="6659463" y="1749177"/>
+            <a:off x="6659463" y="1940719"/>
             <a:ext cx="0" cy="806648"/>
           </a:xfrm>
           <a:prstGeom prst="line">
@@ -3242,7 +3343,7 @@
         </p:nvSpPr>
         <p:spPr>
           <a:xfrm>
-            <a:off x="6822877" y="1876127"/>
+            <a:off x="6822877" y="2067669"/>
             <a:ext cx="1733002" cy="200025"/>
           </a:xfrm>
           <a:prstGeom prst="rect">
@@ -3284,7 +3385,7 @@
         </p:nvSpPr>
         <p:spPr>
           <a:xfrm>
-            <a:off x="6822877" y="2114252"/>
+            <a:off x="6822877" y="2305794"/>
             <a:ext cx="1733002" cy="314623"/>
           </a:xfrm>
           <a:prstGeom prst="rect">
@@ -3326,7 +3427,7 @@
         </p:nvSpPr>
         <p:spPr>
           <a:xfrm>
-            <a:off x="6635651" y="2670125"/>
+            <a:off x="6635651" y="2861667"/>
             <a:ext cx="2025848" cy="963960"/>
           </a:xfrm>
           <a:prstGeom prst="roundRect">
@@ -3358,7 +3459,7 @@
         </p:nvSpPr>
         <p:spPr>
           <a:xfrm>
-            <a:off x="6659463" y="2670125"/>
+            <a:off x="6659463" y="2861667"/>
             <a:ext cx="0" cy="963960"/>
           </a:xfrm>
           <a:prstGeom prst="line">
@@ -3381,7 +3482,7 @@
         </p:nvSpPr>
         <p:spPr>
           <a:xfrm>
-            <a:off x="6822877" y="2797076"/>
+            <a:off x="6822877" y="2988618"/>
             <a:ext cx="1733002" cy="200025"/>
           </a:xfrm>
           <a:prstGeom prst="rect">
@@ -3423,7 +3524,7 @@
         </p:nvSpPr>
         <p:spPr>
           <a:xfrm>
-            <a:off x="6822877" y="3035201"/>
+            <a:off x="6822877" y="3226743"/>
             <a:ext cx="1733002" cy="471934"/>
           </a:xfrm>
           <a:prstGeom prst="rect">
@@ -3465,7 +3566,7 @@
         </p:nvSpPr>
         <p:spPr>
           <a:xfrm>
-            <a:off x="6635651" y="3748385"/>
+            <a:off x="6635651" y="3939927"/>
             <a:ext cx="2025848" cy="806648"/>
           </a:xfrm>
           <a:prstGeom prst="roundRect">
@@ -3497,7 +3598,7 @@
         </p:nvSpPr>
         <p:spPr>
           <a:xfrm>
-            <a:off x="6659463" y="3748385"/>
+            <a:off x="6659463" y="3939927"/>
             <a:ext cx="0" cy="806648"/>
           </a:xfrm>
           <a:prstGeom prst="line">
@@ -3520,7 +3621,7 @@
         </p:nvSpPr>
         <p:spPr>
           <a:xfrm>
-            <a:off x="6822877" y="3875336"/>
+            <a:off x="6822877" y="4066877"/>
             <a:ext cx="1733002" cy="200025"/>
           </a:xfrm>
           <a:prstGeom prst="rect">
@@ -3562,7 +3663,7 @@
         </p:nvSpPr>
         <p:spPr>
           <a:xfrm>
-            <a:off x="6822877" y="4113461"/>
+            <a:off x="6822877" y="4305002"/>
             <a:ext cx="1733002" cy="314623"/>
           </a:xfrm>
           <a:prstGeom prst="rect">
@@ -3596,6 +3697,107 @@
           </a:p>
         </p:txBody>
       </p:sp>
+      <p:sp>
+        <p:nvSpPr>
+          <p:cNvPr id="46" name="Shape 44"/>
+          <p:cNvSpPr/>
+          <p:nvPr/>
+        </p:nvSpPr>
+        <p:spPr>
+          <a:xfrm>
+            <a:off x="7708392" y="146304"/>
+            <a:ext cx="1078992" cy="283464"/>
+          </a:xfrm>
+          <a:prstGeom prst="roundRect">
+            <a:avLst>
+              <a:gd name="adj" fmla="val 19355"/>
+            </a:avLst>
+          </a:prstGeom>
+          <a:solidFill>
+            <a:srgbClr val="1A5D2A"/>
+          </a:solidFill>
+          <a:ln w="12700">
+            <a:solidFill>
+              <a:srgbClr val="2EA043"/>
+            </a:solidFill>
+            <a:prstDash val="solid"/>
+          </a:ln>
+        </p:spPr>
+      </p:sp>
+      <p:sp>
+        <p:nvSpPr>
+          <p:cNvPr id="47" name="Text 45">
+            <a:hlinkClick r:id="rId1" tooltip=""/>
+          </p:cNvPr>
+          <p:cNvSpPr/>
+          <p:nvPr/>
+        </p:nvSpPr>
+        <p:spPr>
+          <a:xfrm>
+            <a:off x="7708392" y="146304"/>
+            <a:ext cx="1078992" cy="283464"/>
+          </a:xfrm>
+          <a:prstGeom prst="rect">
+            <a:avLst/>
+          </a:prstGeom>
+          <a:noFill/>
+          <a:ln/>
+        </p:spPr>
+        <p:txBody>
+          <a:bodyPr wrap="square" lIns="0" tIns="0" rIns="0" bIns="0" rtlCol="0" anchor="ctr"/>
+          <a:lstStyle/>
+          <a:p>
+            <a:pPr algn="ctr" indent="0" marL="0">
+              <a:buNone/>
+            </a:pPr>
+            <a:r>
+              <a:rPr lang="en-US" sz="1050" b="1" u="sng" dirty="0">
+                <a:solidFill>
+                  <a:srgbClr val="FFFFFF"/>
+                </a:solidFill>
+                <a:latin typeface="Arial" pitchFamily="34" charset="0"/>
+                <a:ea typeface="Arial" pitchFamily="34" charset="-122"/>
+                <a:cs typeface="Arial" pitchFamily="34" charset="-120"/>
+                <a:hlinkClick r:id="rId1" invalidUrl="" action="" tgtFrame="" tooltip="" history="1" highlightClick="0" endSnd="0">
+                  <a:extLst>
+                    <a:ext uri="{A12FA001-AC4F-418D-AE19-62706E023703}">
+                      <ahyp:hlinkClr xmlns:ahyp="http://schemas.microsoft.com/office/drawing/2018/hyperlinkcolor" val="tx"/>
+                    </a:ext>
+                  </a:extLst>
+                </a:hlinkClick>
+              </a:rPr>
+              <a:t>gh.io/stacks</a:t>
+            </a:r>
+            <a:endParaRPr lang="en-US" sz="1050" dirty="0"/>
+          </a:p>
+        </p:txBody>
+      </p:sp>
+      <p:pic>
+        <p:nvPicPr>
+          <p:cNvPr id="48" name="Image 0" descr="/root/projects/work/gh-stack-demo/slides/github-invertocat.png">
+            <a:hlinkClick r:id="rId3" tooltip=""/>
+          </p:cNvPr>
+          <p:cNvPicPr>
+            <a:picLocks noChangeAspect="1"/>
+          </p:cNvPicPr>
+          <p:nvPr/>
+        </p:nvPicPr>
+        <p:blipFill>
+          <a:blip r:embed="rId2"/>
+          <a:stretch>
+            <a:fillRect/>
+          </a:stretch>
+        </p:blipFill>
+        <p:spPr>
+          <a:xfrm>
+            <a:off x="8622792" y="4626864"/>
+            <a:ext cx="301752" cy="301752"/>
+          </a:xfrm>
+          <a:prstGeom prst="rect">
+            <a:avLst/>
+          </a:prstGeom>
+        </p:spPr>
+      </p:pic>
     </p:spTree>
   </p:cSld>
   <p:clrMapOvr>
@@ -4587,7 +4789,7 @@
                 <a:ea typeface="Arial" pitchFamily="34" charset="-122"/>
                 <a:cs typeface="Arial" pitchFamily="34" charset="-120"/>
               </a:rPr>
-              <a:t>Navigate focused diffs, update dependents, then merge bottom to top.</a:t>
+              <a:t>Review focused diffs, update dependent layers, then land all or part of the stack.</a:t>
             </a:r>
             <a:endParaRPr lang="en-US" sz="1150" dirty="0"/>
           </a:p>
@@ -4797,6 +4999,107 @@
           </a:p>
         </p:txBody>
       </p:sp>
+      <p:sp>
+        <p:nvSpPr>
+          <p:cNvPr id="31" name="Shape 29"/>
+          <p:cNvSpPr/>
+          <p:nvPr/>
+        </p:nvSpPr>
+        <p:spPr>
+          <a:xfrm>
+            <a:off x="7708392" y="146304"/>
+            <a:ext cx="1078992" cy="283464"/>
+          </a:xfrm>
+          <a:prstGeom prst="roundRect">
+            <a:avLst>
+              <a:gd name="adj" fmla="val 19355"/>
+            </a:avLst>
+          </a:prstGeom>
+          <a:solidFill>
+            <a:srgbClr val="1A5D2A"/>
+          </a:solidFill>
+          <a:ln w="12700">
+            <a:solidFill>
+              <a:srgbClr val="2EA043"/>
+            </a:solidFill>
+            <a:prstDash val="solid"/>
+          </a:ln>
+        </p:spPr>
+      </p:sp>
+      <p:sp>
+        <p:nvSpPr>
+          <p:cNvPr id="32" name="Text 30">
+            <a:hlinkClick r:id="rId1" tooltip=""/>
+          </p:cNvPr>
+          <p:cNvSpPr/>
+          <p:nvPr/>
+        </p:nvSpPr>
+        <p:spPr>
+          <a:xfrm>
+            <a:off x="7708392" y="146304"/>
+            <a:ext cx="1078992" cy="283464"/>
+          </a:xfrm>
+          <a:prstGeom prst="rect">
+            <a:avLst/>
+          </a:prstGeom>
+          <a:noFill/>
+          <a:ln/>
+        </p:spPr>
+        <p:txBody>
+          <a:bodyPr wrap="square" lIns="0" tIns="0" rIns="0" bIns="0" rtlCol="0" anchor="ctr"/>
+          <a:lstStyle/>
+          <a:p>
+            <a:pPr algn="ctr" indent="0" marL="0">
+              <a:buNone/>
+            </a:pPr>
+            <a:r>
+              <a:rPr lang="en-US" sz="1050" b="1" u="sng" dirty="0">
+                <a:solidFill>
+                  <a:srgbClr val="FFFFFF"/>
+                </a:solidFill>
+                <a:latin typeface="Arial" pitchFamily="34" charset="0"/>
+                <a:ea typeface="Arial" pitchFamily="34" charset="-122"/>
+                <a:cs typeface="Arial" pitchFamily="34" charset="-120"/>
+                <a:hlinkClick r:id="rId1" invalidUrl="" action="" tgtFrame="" tooltip="" history="1" highlightClick="0" endSnd="0">
+                  <a:extLst>
+                    <a:ext uri="{A12FA001-AC4F-418D-AE19-62706E023703}">
+                      <ahyp:hlinkClr xmlns:ahyp="http://schemas.microsoft.com/office/drawing/2018/hyperlinkcolor" val="tx"/>
+                    </a:ext>
+                  </a:extLst>
+                </a:hlinkClick>
+              </a:rPr>
+              <a:t>gh.io/stacks</a:t>
+            </a:r>
+            <a:endParaRPr lang="en-US" sz="1050" dirty="0"/>
+          </a:p>
+        </p:txBody>
+      </p:sp>
+      <p:pic>
+        <p:nvPicPr>
+          <p:cNvPr id="33" name="Image 0" descr="/root/projects/work/gh-stack-demo/slides/github-invertocat.png">
+            <a:hlinkClick r:id="rId3" tooltip=""/>
+          </p:cNvPr>
+          <p:cNvPicPr>
+            <a:picLocks noChangeAspect="1"/>
+          </p:cNvPicPr>
+          <p:nvPr/>
+        </p:nvPicPr>
+        <p:blipFill>
+          <a:blip r:embed="rId2"/>
+          <a:stretch>
+            <a:fillRect/>
+          </a:stretch>
+        </p:blipFill>
+        <p:spPr>
+          <a:xfrm>
+            <a:off x="8622792" y="4626864"/>
+            <a:ext cx="301752" cy="301752"/>
+          </a:xfrm>
+          <a:prstGeom prst="rect">
+            <a:avLst/>
+          </a:prstGeom>
+        </p:spPr>
+      </p:pic>
     </p:spTree>
   </p:cSld>
   <p:clrMapOvr>

</xml_diff>

<commit_message>
docs: refine stacked PR deck branding and layers
</commit_message>
<xml_diff>
--- a/github-stacked-prs.pptx
+++ b/github-stacked-prs.pptx
@@ -2103,7 +2103,7 @@
         </p:nvSpPr>
         <p:spPr>
           <a:xfrm>
-            <a:off x="7708392" y="146304"/>
+            <a:off x="7479792" y="146304"/>
             <a:ext cx="1078992" cy="283464"/>
           </a:xfrm>
           <a:prstGeom prst="roundRect">
@@ -2132,7 +2132,7 @@
         </p:nvSpPr>
         <p:spPr>
           <a:xfrm>
-            <a:off x="7708392" y="146304"/>
+            <a:off x="7479792" y="146304"/>
             <a:ext cx="1078992" cy="283464"/>
           </a:xfrm>
           <a:prstGeom prst="rect">
@@ -2188,7 +2188,7 @@
         </p:blipFill>
         <p:spPr>
           <a:xfrm>
-            <a:off x="8622792" y="4626864"/>
+            <a:off x="8668512" y="137160"/>
             <a:ext cx="301752" cy="301752"/>
           </a:xfrm>
           <a:prstGeom prst="rect">
@@ -2569,8 +2569,8 @@
         </p:nvSpPr>
         <p:spPr>
           <a:xfrm>
-            <a:off x="4166443" y="2181523"/>
-            <a:ext cx="1745307" cy="609600"/>
+            <a:off x="3763566" y="2181523"/>
+            <a:ext cx="2550914" cy="609600"/>
           </a:xfrm>
           <a:prstGeom prst="roundRect">
             <a:avLst>
@@ -2608,8 +2608,8 @@
         </p:nvSpPr>
         <p:spPr>
           <a:xfrm>
-            <a:off x="4166443" y="2191048"/>
-            <a:ext cx="1745307" cy="0"/>
+            <a:off x="3763566" y="2191048"/>
+            <a:ext cx="2550914" cy="0"/>
           </a:xfrm>
           <a:prstGeom prst="line">
             <a:avLst/>
@@ -2631,7 +2631,7 @@
         </p:nvSpPr>
         <p:spPr>
           <a:xfrm>
-            <a:off x="5902226" y="2181523"/>
+            <a:off x="6304955" y="2181523"/>
             <a:ext cx="0" cy="609600"/>
           </a:xfrm>
           <a:prstGeom prst="line">
@@ -2654,8 +2654,8 @@
         </p:nvSpPr>
         <p:spPr>
           <a:xfrm>
-            <a:off x="4166443" y="2781598"/>
-            <a:ext cx="1745307" cy="0"/>
+            <a:off x="3763566" y="2781598"/>
+            <a:ext cx="2550914" cy="0"/>
           </a:xfrm>
           <a:prstGeom prst="line">
             <a:avLst/>
@@ -2677,7 +2677,7 @@
         </p:nvSpPr>
         <p:spPr>
           <a:xfrm>
-            <a:off x="4204543" y="2181523"/>
+            <a:off x="3801666" y="2181523"/>
             <a:ext cx="0" cy="609600"/>
           </a:xfrm>
           <a:prstGeom prst="line">
@@ -2700,7 +2700,7 @@
         </p:nvSpPr>
         <p:spPr>
           <a:xfrm>
-            <a:off x="4407694" y="2381548"/>
+            <a:off x="4004816" y="2381548"/>
             <a:ext cx="403041" cy="209550"/>
           </a:xfrm>
           <a:prstGeom prst="rect">
@@ -2739,7 +2739,7 @@
         </p:nvSpPr>
         <p:spPr>
           <a:xfrm>
-            <a:off x="5389066" y="2410123"/>
+            <a:off x="5791795" y="2410123"/>
             <a:ext cx="345356" cy="152400"/>
           </a:xfrm>
           <a:prstGeom prst="rect">
@@ -2778,8 +2778,8 @@
         </p:nvSpPr>
         <p:spPr>
           <a:xfrm>
-            <a:off x="3964930" y="2867323"/>
-            <a:ext cx="2148185" cy="609600"/>
+            <a:off x="3763566" y="2867323"/>
+            <a:ext cx="2550914" cy="609600"/>
           </a:xfrm>
           <a:prstGeom prst="roundRect">
             <a:avLst>
@@ -2817,8 +2817,8 @@
         </p:nvSpPr>
         <p:spPr>
           <a:xfrm>
-            <a:off x="3964930" y="2876848"/>
-            <a:ext cx="2148185" cy="0"/>
+            <a:off x="3763566" y="2876848"/>
+            <a:ext cx="2550914" cy="0"/>
           </a:xfrm>
           <a:prstGeom prst="line">
             <a:avLst/>
@@ -2840,7 +2840,7 @@
         </p:nvSpPr>
         <p:spPr>
           <a:xfrm>
-            <a:off x="6103590" y="2867323"/>
+            <a:off x="6304955" y="2867323"/>
             <a:ext cx="0" cy="609600"/>
           </a:xfrm>
           <a:prstGeom prst="line">
@@ -2863,8 +2863,8 @@
         </p:nvSpPr>
         <p:spPr>
           <a:xfrm>
-            <a:off x="3964930" y="3467398"/>
-            <a:ext cx="2148185" cy="0"/>
+            <a:off x="3763566" y="3467398"/>
+            <a:ext cx="2550914" cy="0"/>
           </a:xfrm>
           <a:prstGeom prst="line">
             <a:avLst/>
@@ -2886,7 +2886,7 @@
         </p:nvSpPr>
         <p:spPr>
           <a:xfrm>
-            <a:off x="4003030" y="2867323"/>
+            <a:off x="3801666" y="2867323"/>
             <a:ext cx="0" cy="609600"/>
           </a:xfrm>
           <a:prstGeom prst="line">
@@ -2909,7 +2909,7 @@
         </p:nvSpPr>
         <p:spPr>
           <a:xfrm>
-            <a:off x="4206180" y="3067348"/>
+            <a:off x="4004816" y="3067348"/>
             <a:ext cx="403041" cy="209550"/>
           </a:xfrm>
           <a:prstGeom prst="rect">
@@ -2948,7 +2948,7 @@
         </p:nvSpPr>
         <p:spPr>
           <a:xfrm>
-            <a:off x="5299174" y="3095923"/>
+            <a:off x="5500539" y="3095923"/>
             <a:ext cx="642437" cy="152400"/>
           </a:xfrm>
           <a:prstGeom prst="rect">
@@ -3705,7 +3705,7 @@
         </p:nvSpPr>
         <p:spPr>
           <a:xfrm>
-            <a:off x="7708392" y="146304"/>
+            <a:off x="7479792" y="146304"/>
             <a:ext cx="1078992" cy="283464"/>
           </a:xfrm>
           <a:prstGeom prst="roundRect">
@@ -3734,7 +3734,7 @@
         </p:nvSpPr>
         <p:spPr>
           <a:xfrm>
-            <a:off x="7708392" y="146304"/>
+            <a:off x="7479792" y="146304"/>
             <a:ext cx="1078992" cy="283464"/>
           </a:xfrm>
           <a:prstGeom prst="rect">
@@ -3790,7 +3790,7 @@
         </p:blipFill>
         <p:spPr>
           <a:xfrm>
-            <a:off x="8622792" y="4626864"/>
+            <a:off x="8668512" y="137160"/>
             <a:ext cx="301752" cy="301752"/>
           </a:xfrm>
           <a:prstGeom prst="rect">
@@ -5007,7 +5007,7 @@
         </p:nvSpPr>
         <p:spPr>
           <a:xfrm>
-            <a:off x="7708392" y="146304"/>
+            <a:off x="7479792" y="146304"/>
             <a:ext cx="1078992" cy="283464"/>
           </a:xfrm>
           <a:prstGeom prst="roundRect">
@@ -5036,7 +5036,7 @@
         </p:nvSpPr>
         <p:spPr>
           <a:xfrm>
-            <a:off x="7708392" y="146304"/>
+            <a:off x="7479792" y="146304"/>
             <a:ext cx="1078992" cy="283464"/>
           </a:xfrm>
           <a:prstGeom prst="rect">
@@ -5092,7 +5092,7 @@
         </p:blipFill>
         <p:spPr>
           <a:xfrm>
-            <a:off x="8622792" y="4626864"/>
+            <a:off x="8668512" y="137160"/>
             <a:ext cx="301752" cy="301752"/>
           </a:xfrm>
           <a:prstGeom prst="rect">

</xml_diff>

<commit_message>
docs: add real stacked PR terminal workflow
</commit_message>
<xml_diff>
--- a/github-stacked-prs.pptx
+++ b/github-stacked-prs.pptx
@@ -12,6 +12,7 @@
     <p:sldId id="256" r:id="rId3"/>
     <p:sldId id="257" r:id="rId4"/>
     <p:sldId id="258" r:id="rId5"/>
+    <p:sldId id="260" r:id="rId11"/>
   </p:sldIdLst>
   <p:sldSz cx="9144000" cy="5143500" type="screen16x9"/>
   <p:notesSz cx="5143500" cy="9144000"/>
@@ -6066,7 +6067,7 @@
                   <a:ea typeface="Courier New" pitchFamily="34" charset="-122"/>
                   <a:cs typeface="Courier New" pitchFamily="34" charset="-120"/>
                 </a:rPr>
-                <a:t>gh stack rebase</a:t>
+                <a:t>gh stack sync</a:t>
               </a:r>
               <a:endParaRPr lang="en-US" sz="1050" dirty="0"/>
             </a:p>
@@ -6694,6 +6695,1694 @@
 </p:sld>
 </file>
 
+<file path=ppt/slides/slide5.xml><?xml version="1.0" encoding="utf-8"?>
+<p:sld xmlns:a="http://schemas.openxmlformats.org/drawingml/2006/main" xmlns:r="http://schemas.openxmlformats.org/officeDocument/2006/relationships" xmlns:p="http://schemas.openxmlformats.org/presentationml/2006/main">
+  <p:cSld name="Slide 1">
+    <p:bg>
+      <p:bgPr>
+        <a:solidFill>
+          <a:srgbClr val="0D1117"/>
+        </a:solidFill>
+      </p:bgPr>
+    </p:bg>
+    <p:spTree>
+      <p:nvGrpSpPr>
+        <p:cNvPr id="1" name=""/>
+        <p:cNvGrpSpPr/>
+        <p:nvPr/>
+      </p:nvGrpSpPr>
+      <p:grpSpPr>
+        <a:xfrm>
+          <a:off x="0" y="0"/>
+          <a:ext cx="0" cy="0"/>
+          <a:chOff x="0" y="0"/>
+          <a:chExt cx="0" cy="0"/>
+        </a:xfrm>
+      </p:grpSpPr>
+      <p:sp>
+        <p:nvSpPr>
+          <p:cNvPr id="2" name="Text 0"/>
+          <p:cNvSpPr/>
+          <p:nvPr/>
+        </p:nvSpPr>
+        <p:spPr>
+          <a:xfrm>
+            <a:off x="482501" y="355550"/>
+            <a:ext cx="8342578" cy="152400"/>
+          </a:xfrm>
+          <a:prstGeom prst="rect">
+            <a:avLst/>
+          </a:prstGeom>
+          <a:noFill/>
+          <a:ln/>
+        </p:spPr>
+        <p:txBody>
+          <a:bodyPr wrap="square" lIns="0" tIns="0" rIns="0" bIns="0" rtlCol="0" anchor="t"/>
+          <a:lstStyle/>
+          <a:p>
+            <a:pPr algn="l" indent="0" marL="0">
+              <a:spcAft>
+                <a:spcPts val="600"/>
+              </a:spcAft>
+              <a:buNone/>
+            </a:pPr>
+            <a:r>
+              <a:rPr lang="en-US" sz="1100" b="1" dirty="0">
+                <a:solidFill>
+                  <a:srgbClr val="58A6FF"/>
+                </a:solidFill>
+                <a:latin typeface="Arial" pitchFamily="34" charset="0"/>
+                <a:ea typeface="Arial" pitchFamily="34" charset="-122"/>
+                <a:cs typeface="Arial" pitchFamily="34" charset="-120"/>
+              </a:rPr>
+              <a:t>A REAL STACK, START TO FINISH</a:t>
+            </a:r>
+            <a:endParaRPr lang="en-US" sz="1100" dirty="0"/>
+          </a:p>
+        </p:txBody>
+      </p:sp>
+      <p:sp>
+        <p:nvSpPr>
+          <p:cNvPr id="3" name="Text 1"/>
+          <p:cNvSpPr/>
+          <p:nvPr/>
+        </p:nvSpPr>
+        <p:spPr>
+          <a:xfrm>
+            <a:off x="482501" y="584150"/>
+            <a:ext cx="8342578" cy="373261"/>
+          </a:xfrm>
+          <a:prstGeom prst="rect">
+            <a:avLst/>
+          </a:prstGeom>
+          <a:noFill/>
+          <a:ln/>
+        </p:spPr>
+        <p:txBody>
+          <a:bodyPr wrap="square" lIns="0" tIns="0" rIns="0" bIns="0" rtlCol="0" anchor="t"/>
+          <a:lstStyle/>
+          <a:p>
+            <a:pPr algn="l" indent="0" marL="0">
+              <a:lnSpc>
+                <a:spcPts val="2940"/>
+              </a:lnSpc>
+              <a:buNone/>
+            </a:pPr>
+            <a:r>
+              <a:rPr lang="en-US" sz="2800" b="1" dirty="0">
+                <a:solidFill>
+                  <a:srgbClr val="F0F6FC"/>
+                </a:solidFill>
+                <a:latin typeface="Arial" pitchFamily="34" charset="0"/>
+                <a:ea typeface="Arial" pitchFamily="34" charset="-122"/>
+                <a:cs typeface="Arial" pitchFamily="34" charset="-120"/>
+              </a:rPr>
+              <a:t>Create three stacked pull requests</a:t>
+            </a:r>
+            <a:endParaRPr lang="en-US" sz="2800" dirty="0"/>
+          </a:p>
+        </p:txBody>
+      </p:sp>
+      <p:sp>
+        <p:nvSpPr>
+          <p:cNvPr id="4" name="Text 2"/>
+          <p:cNvSpPr/>
+          <p:nvPr/>
+        </p:nvSpPr>
+        <p:spPr>
+          <a:xfrm>
+            <a:off x="482501" y="1033611"/>
+            <a:ext cx="8342578" cy="209550"/>
+          </a:xfrm>
+          <a:prstGeom prst="rect">
+            <a:avLst/>
+          </a:prstGeom>
+          <a:noFill/>
+          <a:ln/>
+        </p:spPr>
+        <p:txBody>
+          <a:bodyPr wrap="square" lIns="0" tIns="0" rIns="0" bIns="0" rtlCol="0" anchor="t"/>
+          <a:lstStyle/>
+          <a:p>
+            <a:pPr algn="l" indent="0" marL="0">
+              <a:spcBef>
+                <a:spcPts val="600"/>
+              </a:spcBef>
+              <a:spcAft>
+                <a:spcPts val="1500"/>
+              </a:spcAft>
+              <a:buNone/>
+            </a:pPr>
+            <a:r>
+              <a:rPr lang="en-US" sz="1400" dirty="0">
+                <a:solidFill>
+                  <a:srgbClr val="B1BAC4"/>
+                </a:solidFill>
+                <a:latin typeface="Arial" pitchFamily="34" charset="0"/>
+                <a:ea typeface="Arial" pitchFamily="34" charset="-122"/>
+                <a:cs typeface="Arial" pitchFamily="34" charset="-120"/>
+              </a:rPr>
+              <a:t>Run this inside a clean repository with an authenticated GitHub CLI and a configured remote.</a:t>
+            </a:r>
+            <a:endParaRPr lang="en-US" sz="1400" dirty="0"/>
+          </a:p>
+        </p:txBody>
+      </p:sp>
+      <p:sp>
+        <p:nvSpPr>
+          <p:cNvPr id="5" name="Text 3"/>
+          <p:cNvSpPr/>
+          <p:nvPr/>
+        </p:nvSpPr>
+        <p:spPr>
+          <a:xfrm>
+            <a:off x="482501" y="1433661"/>
+            <a:ext cx="8178998" cy="3074938"/>
+          </a:xfrm>
+          <a:prstGeom prst="roundRect">
+            <a:avLst>
+              <a:gd name="adj" fmla="val 4130"/>
+            </a:avLst>
+          </a:prstGeom>
+          <a:solidFill>
+            <a:srgbClr val="010409"/>
+          </a:solidFill>
+          <a:ln w="19050">
+            <a:solidFill>
+              <a:srgbClr val="30363D"/>
+            </a:solidFill>
+          </a:ln>
+        </p:spPr>
+        <p:txBody>
+          <a:bodyPr wrap="square" rtlCol="0" anchor="ctr"/>
+          <a:lstStyle/>
+          <a:p>
+            <a:pPr indent="0" marL="0">
+              <a:buNone/>
+            </a:pPr>
+            <a:endParaRPr lang="en-US" dirty="0"/>
+          </a:p>
+        </p:txBody>
+      </p:sp>
+      <p:sp>
+        <p:nvSpPr>
+          <p:cNvPr id="6" name="Text 4"/>
+          <p:cNvSpPr/>
+          <p:nvPr/>
+        </p:nvSpPr>
+        <p:spPr>
+          <a:xfrm>
+            <a:off x="501551" y="1452711"/>
+            <a:ext cx="8140898" cy="355550"/>
+          </a:xfrm>
+          <a:prstGeom prst="rect">
+            <a:avLst/>
+          </a:prstGeom>
+          <a:solidFill>
+            <a:srgbClr val="161B22"/>
+          </a:solidFill>
+          <a:ln/>
+        </p:spPr>
+        <p:txBody>
+          <a:bodyPr wrap="square" rtlCol="0" anchor="ctr"/>
+          <a:lstStyle/>
+          <a:p>
+            <a:pPr indent="0" marL="0">
+              <a:buNone/>
+            </a:pPr>
+            <a:endParaRPr lang="en-US" dirty="0"/>
+          </a:p>
+        </p:txBody>
+      </p:sp>
+      <p:sp>
+        <p:nvSpPr>
+          <p:cNvPr id="7" name="Shape 5"/>
+          <p:cNvSpPr/>
+          <p:nvPr/>
+        </p:nvSpPr>
+        <p:spPr>
+          <a:xfrm>
+            <a:off x="501551" y="1803499"/>
+            <a:ext cx="8140898" cy="0"/>
+          </a:xfrm>
+          <a:prstGeom prst="line">
+            <a:avLst/>
+          </a:prstGeom>
+          <a:noFill/>
+          <a:ln w="9525">
+            <a:solidFill>
+              <a:srgbClr val="30363D"/>
+            </a:solidFill>
+            <a:prstDash val="solid"/>
+          </a:ln>
+        </p:spPr>
+      </p:sp>
+      <p:sp>
+        <p:nvSpPr>
+          <p:cNvPr id="8" name="Text 6"/>
+          <p:cNvSpPr/>
+          <p:nvPr/>
+        </p:nvSpPr>
+        <p:spPr>
+          <a:xfrm>
+            <a:off x="641152" y="1581299"/>
+            <a:ext cx="88850" cy="88850"/>
+          </a:xfrm>
+          <a:prstGeom prst="roundRect">
+            <a:avLst>
+              <a:gd name="adj" fmla="val 1029150"/>
+            </a:avLst>
+          </a:prstGeom>
+          <a:solidFill>
+            <a:srgbClr val="FF7B72"/>
+          </a:solidFill>
+          <a:ln/>
+        </p:spPr>
+        <p:txBody>
+          <a:bodyPr wrap="square" rtlCol="0" anchor="ctr"/>
+          <a:lstStyle/>
+          <a:p>
+            <a:pPr indent="0" marL="0">
+              <a:buNone/>
+            </a:pPr>
+            <a:endParaRPr lang="en-US" dirty="0"/>
+          </a:p>
+        </p:txBody>
+      </p:sp>
+      <p:sp>
+        <p:nvSpPr>
+          <p:cNvPr id="9" name="Text 7"/>
+          <p:cNvSpPr/>
+          <p:nvPr/>
+        </p:nvSpPr>
+        <p:spPr>
+          <a:xfrm>
+            <a:off x="806202" y="1581299"/>
+            <a:ext cx="88850" cy="88850"/>
+          </a:xfrm>
+          <a:prstGeom prst="roundRect">
+            <a:avLst>
+              <a:gd name="adj" fmla="val 1029150"/>
+            </a:avLst>
+          </a:prstGeom>
+          <a:solidFill>
+            <a:srgbClr val="D29922"/>
+          </a:solidFill>
+          <a:ln/>
+        </p:spPr>
+        <p:txBody>
+          <a:bodyPr wrap="square" rtlCol="0" anchor="ctr"/>
+          <a:lstStyle/>
+          <a:p>
+            <a:pPr indent="0" marL="0">
+              <a:buNone/>
+            </a:pPr>
+            <a:endParaRPr lang="en-US" dirty="0"/>
+          </a:p>
+        </p:txBody>
+      </p:sp>
+      <p:sp>
+        <p:nvSpPr>
+          <p:cNvPr id="10" name="Text 8"/>
+          <p:cNvSpPr/>
+          <p:nvPr/>
+        </p:nvSpPr>
+        <p:spPr>
+          <a:xfrm>
+            <a:off x="971252" y="1581299"/>
+            <a:ext cx="88850" cy="88850"/>
+          </a:xfrm>
+          <a:prstGeom prst="roundRect">
+            <a:avLst>
+              <a:gd name="adj" fmla="val 1029150"/>
+            </a:avLst>
+          </a:prstGeom>
+          <a:solidFill>
+            <a:srgbClr val="3FB950"/>
+          </a:solidFill>
+          <a:ln/>
+        </p:spPr>
+        <p:txBody>
+          <a:bodyPr wrap="square" rtlCol="0" anchor="ctr"/>
+          <a:lstStyle/>
+          <a:p>
+            <a:pPr indent="0" marL="0">
+              <a:buNone/>
+            </a:pPr>
+            <a:endParaRPr lang="en-US" dirty="0"/>
+          </a:p>
+        </p:txBody>
+      </p:sp>
+      <p:sp>
+        <p:nvSpPr>
+          <p:cNvPr id="11" name="Text 9"/>
+          <p:cNvSpPr/>
+          <p:nvPr/>
+        </p:nvSpPr>
+        <p:spPr>
+          <a:xfrm>
+            <a:off x="4238923" y="1554212"/>
+            <a:ext cx="1106960" cy="142875"/>
+          </a:xfrm>
+          <a:prstGeom prst="rect">
+            <a:avLst/>
+          </a:prstGeom>
+          <a:noFill/>
+          <a:ln/>
+        </p:spPr>
+        <p:txBody>
+          <a:bodyPr wrap="square" lIns="0" tIns="0" rIns="0" bIns="0" rtlCol="0" anchor="t"/>
+          <a:lstStyle/>
+          <a:p>
+            <a:pPr algn="l" indent="0" marL="0">
+              <a:buNone/>
+            </a:pPr>
+            <a:r>
+              <a:rPr lang="en-US" sz="950" dirty="0">
+                <a:solidFill>
+                  <a:srgbClr val="8B949E"/>
+                </a:solidFill>
+                <a:latin typeface="Courier New" pitchFamily="34" charset="0"/>
+                <a:ea typeface="Courier New" pitchFamily="34" charset="-122"/>
+                <a:cs typeface="Courier New" pitchFamily="34" charset="-120"/>
+              </a:rPr>
+              <a:t>task-api — bash</a:t>
+            </a:r>
+            <a:endParaRPr lang="en-US" sz="950" dirty="0"/>
+          </a:p>
+        </p:txBody>
+      </p:sp>
+      <p:sp>
+        <p:nvSpPr>
+          <p:cNvPr id="12" name="Text 10"/>
+          <p:cNvSpPr/>
+          <p:nvPr/>
+        </p:nvSpPr>
+        <p:spPr>
+          <a:xfrm>
+            <a:off x="704701" y="1947863"/>
+            <a:ext cx="3679746" cy="158353"/>
+          </a:xfrm>
+          <a:prstGeom prst="rect">
+            <a:avLst/>
+          </a:prstGeom>
+          <a:noFill/>
+          <a:ln/>
+        </p:spPr>
+        <p:txBody>
+          <a:bodyPr wrap="square" lIns="0" tIns="0" rIns="0" bIns="0" rtlCol="0" anchor="t"/>
+          <a:lstStyle/>
+          <a:p>
+            <a:pPr algn="l" indent="0" marL="0">
+              <a:lnSpc>
+                <a:spcPts val="1248"/>
+              </a:lnSpc>
+              <a:spcAft>
+                <a:spcPts val="200"/>
+              </a:spcAft>
+              <a:buNone/>
+            </a:pPr>
+            <a:r>
+              <a:rPr lang="en-US" sz="960" dirty="0">
+                <a:solidFill>
+                  <a:srgbClr val="8B949E"/>
+                </a:solidFill>
+                <a:latin typeface="Courier New" pitchFamily="34" charset="0"/>
+                <a:ea typeface="Courier New" pitchFamily="34" charset="-122"/>
+                <a:cs typeface="Courier New" pitchFamily="34" charset="-120"/>
+              </a:rPr>
+              <a:t># Install once</a:t>
+            </a:r>
+            <a:endParaRPr lang="en-US" sz="960" dirty="0"/>
+          </a:p>
+        </p:txBody>
+      </p:sp>
+      <p:sp>
+        <p:nvSpPr>
+          <p:cNvPr id="13" name="Text 11"/>
+          <p:cNvSpPr/>
+          <p:nvPr/>
+        </p:nvSpPr>
+        <p:spPr>
+          <a:xfrm>
+            <a:off x="704701" y="2131516"/>
+            <a:ext cx="3679746" cy="158353"/>
+          </a:xfrm>
+          <a:prstGeom prst="rect">
+            <a:avLst/>
+          </a:prstGeom>
+          <a:noFill/>
+          <a:ln/>
+        </p:spPr>
+        <p:txBody>
+          <a:bodyPr wrap="square" lIns="0" tIns="0" rIns="0" bIns="0" rtlCol="0" anchor="t"/>
+          <a:lstStyle/>
+          <a:p>
+            <a:pPr algn="l" indent="0" marL="0">
+              <a:lnSpc>
+                <a:spcPts val="1248"/>
+              </a:lnSpc>
+              <a:spcAft>
+                <a:spcPts val="200"/>
+              </a:spcAft>
+              <a:buNone/>
+            </a:pPr>
+            <a:r>
+              <a:rPr lang="en-US" sz="960" dirty="0">
+                <a:solidFill>
+                  <a:srgbClr val="79C0FF"/>
+                </a:solidFill>
+                <a:latin typeface="Courier New" pitchFamily="34" charset="0"/>
+                <a:ea typeface="Courier New" pitchFamily="34" charset="-122"/>
+                <a:cs typeface="Courier New" pitchFamily="34" charset="-120"/>
+              </a:rPr>
+              <a:t>$ gh extension install github/gh-stack</a:t>
+            </a:r>
+            <a:endParaRPr lang="en-US" sz="960" dirty="0"/>
+          </a:p>
+        </p:txBody>
+      </p:sp>
+      <p:sp>
+        <p:nvSpPr>
+          <p:cNvPr id="14" name="Text 12"/>
+          <p:cNvSpPr/>
+          <p:nvPr/>
+        </p:nvSpPr>
+        <p:spPr>
+          <a:xfrm>
+            <a:off x="704701" y="2315170"/>
+            <a:ext cx="3679746" cy="158353"/>
+          </a:xfrm>
+          <a:prstGeom prst="rect">
+            <a:avLst/>
+          </a:prstGeom>
+          <a:noFill/>
+          <a:ln/>
+        </p:spPr>
+        <p:txBody>
+          <a:bodyPr wrap="square" lIns="0" tIns="0" rIns="0" bIns="0" rtlCol="0" anchor="t"/>
+          <a:lstStyle/>
+          <a:p>
+            <a:pPr algn="l" indent="0" marL="0">
+              <a:lnSpc>
+                <a:spcPts val="1248"/>
+              </a:lnSpc>
+              <a:spcAft>
+                <a:spcPts val="200"/>
+              </a:spcAft>
+              <a:buNone/>
+            </a:pPr>
+            <a:r>
+              <a:rPr lang="en-US" sz="960" dirty="0">
+                <a:solidFill>
+                  <a:srgbClr val="8B949E"/>
+                </a:solidFill>
+                <a:latin typeface="Courier New" pitchFamily="34" charset="0"/>
+                <a:ea typeface="Courier New" pitchFamily="34" charset="-122"/>
+                <a:cs typeface="Courier New" pitchFamily="34" charset="-120"/>
+              </a:rPr>
+              <a:t># Layer 1: model</a:t>
+            </a:r>
+            <a:endParaRPr lang="en-US" sz="960" dirty="0"/>
+          </a:p>
+        </p:txBody>
+      </p:sp>
+      <p:sp>
+        <p:nvSpPr>
+          <p:cNvPr id="15" name="Text 13"/>
+          <p:cNvSpPr/>
+          <p:nvPr/>
+        </p:nvSpPr>
+        <p:spPr>
+          <a:xfrm>
+            <a:off x="704701" y="2498824"/>
+            <a:ext cx="3679746" cy="158353"/>
+          </a:xfrm>
+          <a:prstGeom prst="rect">
+            <a:avLst/>
+          </a:prstGeom>
+          <a:noFill/>
+          <a:ln/>
+        </p:spPr>
+        <p:txBody>
+          <a:bodyPr wrap="square" lIns="0" tIns="0" rIns="0" bIns="0" rtlCol="0" anchor="t"/>
+          <a:lstStyle/>
+          <a:p>
+            <a:pPr algn="l" indent="0" marL="0">
+              <a:lnSpc>
+                <a:spcPts val="1248"/>
+              </a:lnSpc>
+              <a:spcAft>
+                <a:spcPts val="200"/>
+              </a:spcAft>
+              <a:buNone/>
+            </a:pPr>
+            <a:r>
+              <a:rPr lang="en-US" sz="960" dirty="0">
+                <a:solidFill>
+                  <a:srgbClr val="79C0FF"/>
+                </a:solidFill>
+                <a:latin typeface="Courier New" pitchFamily="34" charset="0"/>
+                <a:ea typeface="Courier New" pitchFamily="34" charset="-122"/>
+                <a:cs typeface="Courier New" pitchFamily="34" charset="-120"/>
+              </a:rPr>
+              <a:t>$ gh stack init feature/task-model</a:t>
+            </a:r>
+            <a:endParaRPr lang="en-US" sz="960" dirty="0"/>
+          </a:p>
+        </p:txBody>
+      </p:sp>
+      <p:sp>
+        <p:nvSpPr>
+          <p:cNvPr id="16" name="Text 14"/>
+          <p:cNvSpPr/>
+          <p:nvPr/>
+        </p:nvSpPr>
+        <p:spPr>
+          <a:xfrm>
+            <a:off x="704701" y="2682478"/>
+            <a:ext cx="3679746" cy="158353"/>
+          </a:xfrm>
+          <a:prstGeom prst="rect">
+            <a:avLst/>
+          </a:prstGeom>
+          <a:noFill/>
+          <a:ln/>
+        </p:spPr>
+        <p:txBody>
+          <a:bodyPr wrap="square" lIns="0" tIns="0" rIns="0" bIns="0" rtlCol="0" anchor="t"/>
+          <a:lstStyle/>
+          <a:p>
+            <a:pPr algn="l" indent="0" marL="0">
+              <a:lnSpc>
+                <a:spcPts val="1248"/>
+              </a:lnSpc>
+              <a:spcAft>
+                <a:spcPts val="200"/>
+              </a:spcAft>
+              <a:buNone/>
+            </a:pPr>
+            <a:r>
+              <a:rPr lang="en-US" sz="960" dirty="0">
+                <a:solidFill>
+                  <a:srgbClr val="8B949E"/>
+                </a:solidFill>
+                <a:latin typeface="Courier New" pitchFamily="34" charset="0"/>
+                <a:ea typeface="Courier New" pitchFamily="34" charset="-122"/>
+                <a:cs typeface="Courier New" pitchFamily="34" charset="-120"/>
+              </a:rPr>
+              <a:t># edit src/model.js</a:t>
+            </a:r>
+            <a:endParaRPr lang="en-US" sz="960" dirty="0"/>
+          </a:p>
+        </p:txBody>
+      </p:sp>
+      <p:sp>
+        <p:nvSpPr>
+          <p:cNvPr id="17" name="Text 15"/>
+          <p:cNvSpPr/>
+          <p:nvPr/>
+        </p:nvSpPr>
+        <p:spPr>
+          <a:xfrm>
+            <a:off x="704701" y="2866132"/>
+            <a:ext cx="3679746" cy="158353"/>
+          </a:xfrm>
+          <a:prstGeom prst="rect">
+            <a:avLst/>
+          </a:prstGeom>
+          <a:noFill/>
+          <a:ln/>
+        </p:spPr>
+        <p:txBody>
+          <a:bodyPr wrap="square" lIns="0" tIns="0" rIns="0" bIns="0" rtlCol="0" anchor="t"/>
+          <a:lstStyle/>
+          <a:p>
+            <a:pPr algn="l" indent="0" marL="0">
+              <a:lnSpc>
+                <a:spcPts val="1248"/>
+              </a:lnSpc>
+              <a:spcAft>
+                <a:spcPts val="200"/>
+              </a:spcAft>
+              <a:buNone/>
+            </a:pPr>
+            <a:r>
+              <a:rPr lang="en-US" sz="960" dirty="0">
+                <a:solidFill>
+                  <a:srgbClr val="79C0FF"/>
+                </a:solidFill>
+                <a:latin typeface="Courier New" pitchFamily="34" charset="0"/>
+                <a:ea typeface="Courier New" pitchFamily="34" charset="-122"/>
+                <a:cs typeface="Courier New" pitchFamily="34" charset="-120"/>
+              </a:rPr>
+              <a:t>$ git add src/model.js</a:t>
+            </a:r>
+            <a:endParaRPr lang="en-US" sz="960" dirty="0"/>
+          </a:p>
+        </p:txBody>
+      </p:sp>
+      <p:sp>
+        <p:nvSpPr>
+          <p:cNvPr id="18" name="Text 16"/>
+          <p:cNvSpPr/>
+          <p:nvPr/>
+        </p:nvSpPr>
+        <p:spPr>
+          <a:xfrm>
+            <a:off x="704701" y="3049786"/>
+            <a:ext cx="3679746" cy="158353"/>
+          </a:xfrm>
+          <a:prstGeom prst="rect">
+            <a:avLst/>
+          </a:prstGeom>
+          <a:noFill/>
+          <a:ln/>
+        </p:spPr>
+        <p:txBody>
+          <a:bodyPr wrap="square" lIns="0" tIns="0" rIns="0" bIns="0" rtlCol="0" anchor="t"/>
+          <a:lstStyle/>
+          <a:p>
+            <a:pPr algn="l" indent="0" marL="0">
+              <a:lnSpc>
+                <a:spcPts val="1248"/>
+              </a:lnSpc>
+              <a:spcAft>
+                <a:spcPts val="200"/>
+              </a:spcAft>
+              <a:buNone/>
+            </a:pPr>
+            <a:r>
+              <a:rPr lang="en-US" sz="960" dirty="0">
+                <a:solidFill>
+                  <a:srgbClr val="79C0FF"/>
+                </a:solidFill>
+                <a:latin typeface="Courier New" pitchFamily="34" charset="0"/>
+                <a:ea typeface="Courier New" pitchFamily="34" charset="-122"/>
+                <a:cs typeface="Courier New" pitchFamily="34" charset="-120"/>
+              </a:rPr>
+              <a:t>$ git commit -m "feat: add task model"</a:t>
+            </a:r>
+            <a:endParaRPr lang="en-US" sz="960" dirty="0"/>
+          </a:p>
+        </p:txBody>
+      </p:sp>
+      <p:sp>
+        <p:nvSpPr>
+          <p:cNvPr id="19" name="Text 17"/>
+          <p:cNvSpPr/>
+          <p:nvPr/>
+        </p:nvSpPr>
+        <p:spPr>
+          <a:xfrm>
+            <a:off x="704701" y="3233440"/>
+            <a:ext cx="3679746" cy="158353"/>
+          </a:xfrm>
+          <a:prstGeom prst="rect">
+            <a:avLst/>
+          </a:prstGeom>
+          <a:noFill/>
+          <a:ln/>
+        </p:spPr>
+        <p:txBody>
+          <a:bodyPr wrap="square" lIns="0" tIns="0" rIns="0" bIns="0" rtlCol="0" anchor="t"/>
+          <a:lstStyle/>
+          <a:p>
+            <a:pPr algn="l" indent="0" marL="0">
+              <a:lnSpc>
+                <a:spcPts val="1248"/>
+              </a:lnSpc>
+              <a:spcAft>
+                <a:spcPts val="200"/>
+              </a:spcAft>
+              <a:buNone/>
+            </a:pPr>
+            <a:r>
+              <a:rPr lang="en-US" sz="960" dirty="0">
+                <a:solidFill>
+                  <a:srgbClr val="8B949E"/>
+                </a:solidFill>
+                <a:latin typeface="Courier New" pitchFamily="34" charset="0"/>
+                <a:ea typeface="Courier New" pitchFamily="34" charset="-122"/>
+                <a:cs typeface="Courier New" pitchFamily="34" charset="-120"/>
+              </a:rPr>
+              <a:t># Layer 2: API</a:t>
+            </a:r>
+            <a:endParaRPr lang="en-US" sz="960" dirty="0"/>
+          </a:p>
+        </p:txBody>
+      </p:sp>
+      <p:sp>
+        <p:nvSpPr>
+          <p:cNvPr id="20" name="Text 18"/>
+          <p:cNvSpPr/>
+          <p:nvPr/>
+        </p:nvSpPr>
+        <p:spPr>
+          <a:xfrm>
+            <a:off x="704701" y="3417094"/>
+            <a:ext cx="3679746" cy="158353"/>
+          </a:xfrm>
+          <a:prstGeom prst="rect">
+            <a:avLst/>
+          </a:prstGeom>
+          <a:noFill/>
+          <a:ln/>
+        </p:spPr>
+        <p:txBody>
+          <a:bodyPr wrap="square" lIns="0" tIns="0" rIns="0" bIns="0" rtlCol="0" anchor="t"/>
+          <a:lstStyle/>
+          <a:p>
+            <a:pPr algn="l" indent="0" marL="0">
+              <a:lnSpc>
+                <a:spcPts val="1248"/>
+              </a:lnSpc>
+              <a:spcAft>
+                <a:spcPts val="200"/>
+              </a:spcAft>
+              <a:buNone/>
+            </a:pPr>
+            <a:r>
+              <a:rPr lang="en-US" sz="960" dirty="0">
+                <a:solidFill>
+                  <a:srgbClr val="79C0FF"/>
+                </a:solidFill>
+                <a:latin typeface="Courier New" pitchFamily="34" charset="0"/>
+                <a:ea typeface="Courier New" pitchFamily="34" charset="-122"/>
+                <a:cs typeface="Courier New" pitchFamily="34" charset="-120"/>
+              </a:rPr>
+              <a:t>$ gh stack add feature/task-api</a:t>
+            </a:r>
+            <a:endParaRPr lang="en-US" sz="960" dirty="0"/>
+          </a:p>
+        </p:txBody>
+      </p:sp>
+      <p:sp>
+        <p:nvSpPr>
+          <p:cNvPr id="21" name="Text 19"/>
+          <p:cNvSpPr/>
+          <p:nvPr/>
+        </p:nvSpPr>
+        <p:spPr>
+          <a:xfrm>
+            <a:off x="704701" y="3600748"/>
+            <a:ext cx="3679746" cy="158353"/>
+          </a:xfrm>
+          <a:prstGeom prst="rect">
+            <a:avLst/>
+          </a:prstGeom>
+          <a:noFill/>
+          <a:ln/>
+        </p:spPr>
+        <p:txBody>
+          <a:bodyPr wrap="square" lIns="0" tIns="0" rIns="0" bIns="0" rtlCol="0" anchor="t"/>
+          <a:lstStyle/>
+          <a:p>
+            <a:pPr algn="l" indent="0" marL="0">
+              <a:lnSpc>
+                <a:spcPts val="1248"/>
+              </a:lnSpc>
+              <a:spcAft>
+                <a:spcPts val="200"/>
+              </a:spcAft>
+              <a:buNone/>
+            </a:pPr>
+            <a:r>
+              <a:rPr lang="en-US" sz="960" dirty="0">
+                <a:solidFill>
+                  <a:srgbClr val="8B949E"/>
+                </a:solidFill>
+                <a:latin typeface="Courier New" pitchFamily="34" charset="0"/>
+                <a:ea typeface="Courier New" pitchFamily="34" charset="-122"/>
+                <a:cs typeface="Courier New" pitchFamily="34" charset="-120"/>
+              </a:rPr>
+              <a:t># edit src/api.js</a:t>
+            </a:r>
+            <a:endParaRPr lang="en-US" sz="960" dirty="0"/>
+          </a:p>
+        </p:txBody>
+      </p:sp>
+      <p:sp>
+        <p:nvSpPr>
+          <p:cNvPr id="22" name="Text 20"/>
+          <p:cNvSpPr/>
+          <p:nvPr/>
+        </p:nvSpPr>
+        <p:spPr>
+          <a:xfrm>
+            <a:off x="704701" y="3784402"/>
+            <a:ext cx="3679746" cy="158353"/>
+          </a:xfrm>
+          <a:prstGeom prst="rect">
+            <a:avLst/>
+          </a:prstGeom>
+          <a:noFill/>
+          <a:ln/>
+        </p:spPr>
+        <p:txBody>
+          <a:bodyPr wrap="square" lIns="0" tIns="0" rIns="0" bIns="0" rtlCol="0" anchor="t"/>
+          <a:lstStyle/>
+          <a:p>
+            <a:pPr algn="l" indent="0" marL="0">
+              <a:lnSpc>
+                <a:spcPts val="1248"/>
+              </a:lnSpc>
+              <a:spcAft>
+                <a:spcPts val="200"/>
+              </a:spcAft>
+              <a:buNone/>
+            </a:pPr>
+            <a:r>
+              <a:rPr lang="en-US" sz="960" dirty="0">
+                <a:solidFill>
+                  <a:srgbClr val="79C0FF"/>
+                </a:solidFill>
+                <a:latin typeface="Courier New" pitchFamily="34" charset="0"/>
+                <a:ea typeface="Courier New" pitchFamily="34" charset="-122"/>
+                <a:cs typeface="Courier New" pitchFamily="34" charset="-120"/>
+              </a:rPr>
+              <a:t>$ git add src/api.js</a:t>
+            </a:r>
+            <a:endParaRPr lang="en-US" sz="960" dirty="0"/>
+          </a:p>
+        </p:txBody>
+      </p:sp>
+      <p:sp>
+        <p:nvSpPr>
+          <p:cNvPr id="23" name="Text 21"/>
+          <p:cNvSpPr/>
+          <p:nvPr/>
+        </p:nvSpPr>
+        <p:spPr>
+          <a:xfrm>
+            <a:off x="704701" y="3968055"/>
+            <a:ext cx="3679746" cy="158353"/>
+          </a:xfrm>
+          <a:prstGeom prst="rect">
+            <a:avLst/>
+          </a:prstGeom>
+          <a:noFill/>
+          <a:ln/>
+        </p:spPr>
+        <p:txBody>
+          <a:bodyPr wrap="square" lIns="0" tIns="0" rIns="0" bIns="0" rtlCol="0" anchor="t"/>
+          <a:lstStyle/>
+          <a:p>
+            <a:pPr algn="l" indent="0" marL="0">
+              <a:lnSpc>
+                <a:spcPts val="1248"/>
+              </a:lnSpc>
+              <a:spcAft>
+                <a:spcPts val="200"/>
+              </a:spcAft>
+              <a:buNone/>
+            </a:pPr>
+            <a:r>
+              <a:rPr lang="en-US" sz="960" dirty="0">
+                <a:solidFill>
+                  <a:srgbClr val="79C0FF"/>
+                </a:solidFill>
+                <a:latin typeface="Courier New" pitchFamily="34" charset="0"/>
+                <a:ea typeface="Courier New" pitchFamily="34" charset="-122"/>
+                <a:cs typeface="Courier New" pitchFamily="34" charset="-120"/>
+              </a:rPr>
+              <a:t>$ git commit -m "feat: add task API"</a:t>
+            </a:r>
+            <a:endParaRPr lang="en-US" sz="960" dirty="0"/>
+          </a:p>
+        </p:txBody>
+      </p:sp>
+      <p:sp>
+        <p:nvSpPr>
+          <p:cNvPr id="24" name="Text 22"/>
+          <p:cNvSpPr/>
+          <p:nvPr/>
+        </p:nvSpPr>
+        <p:spPr>
+          <a:xfrm>
+            <a:off x="4566196" y="1947863"/>
+            <a:ext cx="11757" cy="2402086"/>
+          </a:xfrm>
+          <a:prstGeom prst="rect">
+            <a:avLst/>
+          </a:prstGeom>
+          <a:solidFill>
+            <a:srgbClr val="21262D"/>
+          </a:solidFill>
+          <a:ln/>
+        </p:spPr>
+        <p:txBody>
+          <a:bodyPr wrap="square" rtlCol="0" anchor="ctr"/>
+          <a:lstStyle/>
+          <a:p>
+            <a:pPr indent="0" marL="0">
+              <a:buNone/>
+            </a:pPr>
+            <a:endParaRPr lang="en-US" dirty="0"/>
+          </a:p>
+        </p:txBody>
+      </p:sp>
+      <p:sp>
+        <p:nvSpPr>
+          <p:cNvPr id="25" name="Text 23"/>
+          <p:cNvSpPr/>
+          <p:nvPr/>
+        </p:nvSpPr>
+        <p:spPr>
+          <a:xfrm>
+            <a:off x="4831854" y="1947863"/>
+            <a:ext cx="3679594" cy="158353"/>
+          </a:xfrm>
+          <a:prstGeom prst="rect">
+            <a:avLst/>
+          </a:prstGeom>
+          <a:noFill/>
+          <a:ln/>
+        </p:spPr>
+        <p:txBody>
+          <a:bodyPr wrap="square" lIns="0" tIns="0" rIns="0" bIns="0" rtlCol="0" anchor="t"/>
+          <a:lstStyle/>
+          <a:p>
+            <a:pPr algn="l" indent="0" marL="0">
+              <a:lnSpc>
+                <a:spcPts val="1248"/>
+              </a:lnSpc>
+              <a:spcAft>
+                <a:spcPts val="200"/>
+              </a:spcAft>
+              <a:buNone/>
+            </a:pPr>
+            <a:r>
+              <a:rPr lang="en-US" sz="960" dirty="0">
+                <a:solidFill>
+                  <a:srgbClr val="8B949E"/>
+                </a:solidFill>
+                <a:latin typeface="Courier New" pitchFamily="34" charset="0"/>
+                <a:ea typeface="Courier New" pitchFamily="34" charset="-122"/>
+                <a:cs typeface="Courier New" pitchFamily="34" charset="-120"/>
+              </a:rPr>
+              <a:t># Layer 3: tests</a:t>
+            </a:r>
+            <a:endParaRPr lang="en-US" sz="960" dirty="0"/>
+          </a:p>
+        </p:txBody>
+      </p:sp>
+      <p:sp>
+        <p:nvSpPr>
+          <p:cNvPr id="26" name="Text 24"/>
+          <p:cNvSpPr/>
+          <p:nvPr/>
+        </p:nvSpPr>
+        <p:spPr>
+          <a:xfrm>
+            <a:off x="4831854" y="2131516"/>
+            <a:ext cx="3679594" cy="158353"/>
+          </a:xfrm>
+          <a:prstGeom prst="rect">
+            <a:avLst/>
+          </a:prstGeom>
+          <a:noFill/>
+          <a:ln/>
+        </p:spPr>
+        <p:txBody>
+          <a:bodyPr wrap="square" lIns="0" tIns="0" rIns="0" bIns="0" rtlCol="0" anchor="t"/>
+          <a:lstStyle/>
+          <a:p>
+            <a:pPr algn="l" indent="0" marL="0">
+              <a:lnSpc>
+                <a:spcPts val="1248"/>
+              </a:lnSpc>
+              <a:spcAft>
+                <a:spcPts val="200"/>
+              </a:spcAft>
+              <a:buNone/>
+            </a:pPr>
+            <a:r>
+              <a:rPr lang="en-US" sz="960" dirty="0">
+                <a:solidFill>
+                  <a:srgbClr val="79C0FF"/>
+                </a:solidFill>
+                <a:latin typeface="Courier New" pitchFamily="34" charset="0"/>
+                <a:ea typeface="Courier New" pitchFamily="34" charset="-122"/>
+                <a:cs typeface="Courier New" pitchFamily="34" charset="-120"/>
+              </a:rPr>
+              <a:t>$ gh stack add test/task-api</a:t>
+            </a:r>
+            <a:endParaRPr lang="en-US" sz="960" dirty="0"/>
+          </a:p>
+        </p:txBody>
+      </p:sp>
+      <p:sp>
+        <p:nvSpPr>
+          <p:cNvPr id="27" name="Text 25"/>
+          <p:cNvSpPr/>
+          <p:nvPr/>
+        </p:nvSpPr>
+        <p:spPr>
+          <a:xfrm>
+            <a:off x="4831854" y="2315170"/>
+            <a:ext cx="3679594" cy="158353"/>
+          </a:xfrm>
+          <a:prstGeom prst="rect">
+            <a:avLst/>
+          </a:prstGeom>
+          <a:noFill/>
+          <a:ln/>
+        </p:spPr>
+        <p:txBody>
+          <a:bodyPr wrap="square" lIns="0" tIns="0" rIns="0" bIns="0" rtlCol="0" anchor="t"/>
+          <a:lstStyle/>
+          <a:p>
+            <a:pPr algn="l" indent="0" marL="0">
+              <a:lnSpc>
+                <a:spcPts val="1248"/>
+              </a:lnSpc>
+              <a:spcAft>
+                <a:spcPts val="200"/>
+              </a:spcAft>
+              <a:buNone/>
+            </a:pPr>
+            <a:r>
+              <a:rPr lang="en-US" sz="960" dirty="0">
+                <a:solidFill>
+                  <a:srgbClr val="8B949E"/>
+                </a:solidFill>
+                <a:latin typeface="Courier New" pitchFamily="34" charset="0"/>
+                <a:ea typeface="Courier New" pitchFamily="34" charset="-122"/>
+                <a:cs typeface="Courier New" pitchFamily="34" charset="-120"/>
+              </a:rPr>
+              <a:t># edit test/api.test.js</a:t>
+            </a:r>
+            <a:endParaRPr lang="en-US" sz="960" dirty="0"/>
+          </a:p>
+        </p:txBody>
+      </p:sp>
+      <p:sp>
+        <p:nvSpPr>
+          <p:cNvPr id="28" name="Text 26"/>
+          <p:cNvSpPr/>
+          <p:nvPr/>
+        </p:nvSpPr>
+        <p:spPr>
+          <a:xfrm>
+            <a:off x="4831854" y="2498824"/>
+            <a:ext cx="3679594" cy="158353"/>
+          </a:xfrm>
+          <a:prstGeom prst="rect">
+            <a:avLst/>
+          </a:prstGeom>
+          <a:noFill/>
+          <a:ln/>
+        </p:spPr>
+        <p:txBody>
+          <a:bodyPr wrap="square" lIns="0" tIns="0" rIns="0" bIns="0" rtlCol="0" anchor="t"/>
+          <a:lstStyle/>
+          <a:p>
+            <a:pPr algn="l" indent="0" marL="0">
+              <a:lnSpc>
+                <a:spcPts val="1248"/>
+              </a:lnSpc>
+              <a:spcAft>
+                <a:spcPts val="200"/>
+              </a:spcAft>
+              <a:buNone/>
+            </a:pPr>
+            <a:r>
+              <a:rPr lang="en-US" sz="960" dirty="0">
+                <a:solidFill>
+                  <a:srgbClr val="79C0FF"/>
+                </a:solidFill>
+                <a:latin typeface="Courier New" pitchFamily="34" charset="0"/>
+                <a:ea typeface="Courier New" pitchFamily="34" charset="-122"/>
+                <a:cs typeface="Courier New" pitchFamily="34" charset="-120"/>
+              </a:rPr>
+              <a:t>$ git add test/api.test.js</a:t>
+            </a:r>
+            <a:endParaRPr lang="en-US" sz="960" dirty="0"/>
+          </a:p>
+        </p:txBody>
+      </p:sp>
+      <p:sp>
+        <p:nvSpPr>
+          <p:cNvPr id="29" name="Text 27"/>
+          <p:cNvSpPr/>
+          <p:nvPr/>
+        </p:nvSpPr>
+        <p:spPr>
+          <a:xfrm>
+            <a:off x="4831854" y="2682478"/>
+            <a:ext cx="3679594" cy="158353"/>
+          </a:xfrm>
+          <a:prstGeom prst="rect">
+            <a:avLst/>
+          </a:prstGeom>
+          <a:noFill/>
+          <a:ln/>
+        </p:spPr>
+        <p:txBody>
+          <a:bodyPr wrap="square" lIns="0" tIns="0" rIns="0" bIns="0" rtlCol="0" anchor="t"/>
+          <a:lstStyle/>
+          <a:p>
+            <a:pPr algn="l" indent="0" marL="0">
+              <a:lnSpc>
+                <a:spcPts val="1248"/>
+              </a:lnSpc>
+              <a:spcAft>
+                <a:spcPts val="200"/>
+              </a:spcAft>
+              <a:buNone/>
+            </a:pPr>
+            <a:r>
+              <a:rPr lang="en-US" sz="960" dirty="0">
+                <a:solidFill>
+                  <a:srgbClr val="79C0FF"/>
+                </a:solidFill>
+                <a:latin typeface="Courier New" pitchFamily="34" charset="0"/>
+                <a:ea typeface="Courier New" pitchFamily="34" charset="-122"/>
+                <a:cs typeface="Courier New" pitchFamily="34" charset="-120"/>
+              </a:rPr>
+              <a:t>$ git commit -m "test: cover task API"</a:t>
+            </a:r>
+            <a:endParaRPr lang="en-US" sz="960" dirty="0"/>
+          </a:p>
+        </p:txBody>
+      </p:sp>
+      <p:sp>
+        <p:nvSpPr>
+          <p:cNvPr id="30" name="Text 28"/>
+          <p:cNvSpPr/>
+          <p:nvPr/>
+        </p:nvSpPr>
+        <p:spPr>
+          <a:xfrm>
+            <a:off x="4831854" y="2866132"/>
+            <a:ext cx="3679594" cy="158353"/>
+          </a:xfrm>
+          <a:prstGeom prst="rect">
+            <a:avLst/>
+          </a:prstGeom>
+          <a:noFill/>
+          <a:ln/>
+        </p:spPr>
+        <p:txBody>
+          <a:bodyPr wrap="square" lIns="0" tIns="0" rIns="0" bIns="0" rtlCol="0" anchor="t"/>
+          <a:lstStyle/>
+          <a:p>
+            <a:pPr algn="l" indent="0" marL="0">
+              <a:lnSpc>
+                <a:spcPts val="1248"/>
+              </a:lnSpc>
+              <a:spcAft>
+                <a:spcPts val="200"/>
+              </a:spcAft>
+              <a:buNone/>
+            </a:pPr>
+            <a:r>
+              <a:rPr lang="en-US" sz="960" dirty="0">
+                <a:solidFill>
+                  <a:srgbClr val="8B949E"/>
+                </a:solidFill>
+                <a:latin typeface="Courier New" pitchFamily="34" charset="0"/>
+                <a:ea typeface="Courier New" pitchFamily="34" charset="-122"/>
+                <a:cs typeface="Courier New" pitchFamily="34" charset="-120"/>
+              </a:rPr>
+              <a:t># Inspect, then create all three PRs</a:t>
+            </a:r>
+            <a:endParaRPr lang="en-US" sz="960" dirty="0"/>
+          </a:p>
+        </p:txBody>
+      </p:sp>
+      <p:sp>
+        <p:nvSpPr>
+          <p:cNvPr id="31" name="Text 29"/>
+          <p:cNvSpPr/>
+          <p:nvPr/>
+        </p:nvSpPr>
+        <p:spPr>
+          <a:xfrm>
+            <a:off x="4831854" y="3049786"/>
+            <a:ext cx="3679594" cy="158353"/>
+          </a:xfrm>
+          <a:prstGeom prst="rect">
+            <a:avLst/>
+          </a:prstGeom>
+          <a:noFill/>
+          <a:ln/>
+        </p:spPr>
+        <p:txBody>
+          <a:bodyPr wrap="square" lIns="0" tIns="0" rIns="0" bIns="0" rtlCol="0" anchor="t"/>
+          <a:lstStyle/>
+          <a:p>
+            <a:pPr algn="l" indent="0" marL="0">
+              <a:lnSpc>
+                <a:spcPts val="1248"/>
+              </a:lnSpc>
+              <a:spcAft>
+                <a:spcPts val="200"/>
+              </a:spcAft>
+              <a:buNone/>
+            </a:pPr>
+            <a:r>
+              <a:rPr lang="en-US" sz="960" dirty="0">
+                <a:solidFill>
+                  <a:srgbClr val="79C0FF"/>
+                </a:solidFill>
+                <a:latin typeface="Courier New" pitchFamily="34" charset="0"/>
+                <a:ea typeface="Courier New" pitchFamily="34" charset="-122"/>
+                <a:cs typeface="Courier New" pitchFamily="34" charset="-120"/>
+              </a:rPr>
+              <a:t>$ gh stack view</a:t>
+            </a:r>
+            <a:endParaRPr lang="en-US" sz="960" dirty="0"/>
+          </a:p>
+        </p:txBody>
+      </p:sp>
+      <p:sp>
+        <p:nvSpPr>
+          <p:cNvPr id="32" name="Text 30"/>
+          <p:cNvSpPr/>
+          <p:nvPr/>
+        </p:nvSpPr>
+        <p:spPr>
+          <a:xfrm>
+            <a:off x="4831854" y="3233440"/>
+            <a:ext cx="3679594" cy="158353"/>
+          </a:xfrm>
+          <a:prstGeom prst="rect">
+            <a:avLst/>
+          </a:prstGeom>
+          <a:noFill/>
+          <a:ln/>
+        </p:spPr>
+        <p:txBody>
+          <a:bodyPr wrap="square" lIns="0" tIns="0" rIns="0" bIns="0" rtlCol="0" anchor="t"/>
+          <a:lstStyle/>
+          <a:p>
+            <a:pPr algn="l" indent="0" marL="0">
+              <a:lnSpc>
+                <a:spcPts val="1248"/>
+              </a:lnSpc>
+              <a:spcAft>
+                <a:spcPts val="200"/>
+              </a:spcAft>
+              <a:buNone/>
+            </a:pPr>
+            <a:r>
+              <a:rPr lang="en-US" sz="960" dirty="0">
+                <a:solidFill>
+                  <a:srgbClr val="79C0FF"/>
+                </a:solidFill>
+                <a:latin typeface="Courier New" pitchFamily="34" charset="0"/>
+                <a:ea typeface="Courier New" pitchFamily="34" charset="-122"/>
+                <a:cs typeface="Courier New" pitchFamily="34" charset="-120"/>
+              </a:rPr>
+              <a:t>$ gh stack submit</a:t>
+            </a:r>
+            <a:endParaRPr lang="en-US" sz="960" dirty="0"/>
+          </a:p>
+        </p:txBody>
+      </p:sp>
+      <p:sp>
+        <p:nvSpPr>
+          <p:cNvPr id="33" name="Text 31"/>
+          <p:cNvSpPr/>
+          <p:nvPr/>
+        </p:nvSpPr>
+        <p:spPr>
+          <a:xfrm>
+            <a:off x="4831854" y="3417094"/>
+            <a:ext cx="3679594" cy="158353"/>
+          </a:xfrm>
+          <a:prstGeom prst="rect">
+            <a:avLst/>
+          </a:prstGeom>
+          <a:noFill/>
+          <a:ln/>
+        </p:spPr>
+        <p:txBody>
+          <a:bodyPr wrap="square" lIns="0" tIns="0" rIns="0" bIns="0" rtlCol="0" anchor="t"/>
+          <a:lstStyle/>
+          <a:p>
+            <a:pPr algn="l" indent="0" marL="0">
+              <a:lnSpc>
+                <a:spcPts val="1248"/>
+              </a:lnSpc>
+              <a:spcAft>
+                <a:spcPts val="200"/>
+              </a:spcAft>
+              <a:buNone/>
+            </a:pPr>
+            <a:r>
+              <a:rPr lang="en-US" sz="960" dirty="0">
+                <a:solidFill>
+                  <a:srgbClr val="8B949E"/>
+                </a:solidFill>
+                <a:latin typeface="Courier New" pitchFamily="34" charset="0"/>
+                <a:ea typeface="Courier New" pitchFamily="34" charset="-122"/>
+                <a:cs typeface="Courier New" pitchFamily="34" charset="-120"/>
+              </a:rPr>
+              <a:t># submit pushes, opens PRs, and links the stack</a:t>
+            </a:r>
+            <a:endParaRPr lang="en-US" sz="960" dirty="0"/>
+          </a:p>
+        </p:txBody>
+      </p:sp>
+      <p:sp>
+        <p:nvSpPr>
+          <p:cNvPr id="34" name="Text 32"/>
+          <p:cNvSpPr/>
+          <p:nvPr/>
+        </p:nvSpPr>
+        <p:spPr>
+          <a:xfrm>
+            <a:off x="4831854" y="3600748"/>
+            <a:ext cx="3679594" cy="158353"/>
+          </a:xfrm>
+          <a:prstGeom prst="rect">
+            <a:avLst/>
+          </a:prstGeom>
+          <a:noFill/>
+          <a:ln/>
+        </p:spPr>
+        <p:txBody>
+          <a:bodyPr wrap="square" lIns="0" tIns="0" rIns="0" bIns="0" rtlCol="0" anchor="t"/>
+          <a:lstStyle/>
+          <a:p>
+            <a:pPr algn="l" indent="0" marL="0">
+              <a:lnSpc>
+                <a:spcPts val="1248"/>
+              </a:lnSpc>
+              <a:spcAft>
+                <a:spcPts val="200"/>
+              </a:spcAft>
+              <a:buNone/>
+            </a:pPr>
+            <a:r>
+              <a:rPr lang="en-US" sz="960" dirty="0">
+                <a:solidFill>
+                  <a:srgbClr val="8B949E"/>
+                </a:solidFill>
+                <a:latin typeface="Courier New" pitchFamily="34" charset="0"/>
+                <a:ea typeface="Courier New" pitchFamily="34" charset="-122"/>
+                <a:cs typeface="Courier New" pitchFamily="34" charset="-120"/>
+              </a:rPr>
+              <a:t># Later: update and land the stack</a:t>
+            </a:r>
+            <a:endParaRPr lang="en-US" sz="960" dirty="0"/>
+          </a:p>
+        </p:txBody>
+      </p:sp>
+      <p:sp>
+        <p:nvSpPr>
+          <p:cNvPr id="35" name="Text 33"/>
+          <p:cNvSpPr/>
+          <p:nvPr/>
+        </p:nvSpPr>
+        <p:spPr>
+          <a:xfrm>
+            <a:off x="4831854" y="3784402"/>
+            <a:ext cx="3679594" cy="158353"/>
+          </a:xfrm>
+          <a:prstGeom prst="rect">
+            <a:avLst/>
+          </a:prstGeom>
+          <a:noFill/>
+          <a:ln/>
+        </p:spPr>
+        <p:txBody>
+          <a:bodyPr wrap="square" lIns="0" tIns="0" rIns="0" bIns="0" rtlCol="0" anchor="t"/>
+          <a:lstStyle/>
+          <a:p>
+            <a:pPr algn="l" indent="0" marL="0">
+              <a:lnSpc>
+                <a:spcPts val="1248"/>
+              </a:lnSpc>
+              <a:spcAft>
+                <a:spcPts val="200"/>
+              </a:spcAft>
+              <a:buNone/>
+            </a:pPr>
+            <a:r>
+              <a:rPr lang="en-US" sz="960" dirty="0">
+                <a:solidFill>
+                  <a:srgbClr val="79C0FF"/>
+                </a:solidFill>
+                <a:latin typeface="Courier New" pitchFamily="34" charset="0"/>
+                <a:ea typeface="Courier New" pitchFamily="34" charset="-122"/>
+                <a:cs typeface="Courier New" pitchFamily="34" charset="-120"/>
+              </a:rPr>
+              <a:t>$ gh stack sync</a:t>
+            </a:r>
+            <a:endParaRPr lang="en-US" sz="960" dirty="0"/>
+          </a:p>
+        </p:txBody>
+      </p:sp>
+      <p:sp>
+        <p:nvSpPr>
+          <p:cNvPr id="36" name="Text 34"/>
+          <p:cNvSpPr/>
+          <p:nvPr/>
+        </p:nvSpPr>
+        <p:spPr>
+          <a:xfrm>
+            <a:off x="4831854" y="3968055"/>
+            <a:ext cx="3679594" cy="158353"/>
+          </a:xfrm>
+          <a:prstGeom prst="rect">
+            <a:avLst/>
+          </a:prstGeom>
+          <a:noFill/>
+          <a:ln/>
+        </p:spPr>
+        <p:txBody>
+          <a:bodyPr wrap="square" lIns="0" tIns="0" rIns="0" bIns="0" rtlCol="0" anchor="t"/>
+          <a:lstStyle/>
+          <a:p>
+            <a:pPr algn="l" indent="0" marL="0">
+              <a:lnSpc>
+                <a:spcPts val="1248"/>
+              </a:lnSpc>
+              <a:spcAft>
+                <a:spcPts val="200"/>
+              </a:spcAft>
+              <a:buNone/>
+            </a:pPr>
+            <a:r>
+              <a:rPr lang="en-US" sz="960" dirty="0">
+                <a:solidFill>
+                  <a:srgbClr val="79C0FF"/>
+                </a:solidFill>
+                <a:latin typeface="Courier New" pitchFamily="34" charset="0"/>
+                <a:ea typeface="Courier New" pitchFamily="34" charset="-122"/>
+                <a:cs typeface="Courier New" pitchFamily="34" charset="-120"/>
+              </a:rPr>
+              <a:t>$ gh stack merge</a:t>
+            </a:r>
+            <a:endParaRPr lang="en-US" sz="960" dirty="0"/>
+          </a:p>
+        </p:txBody>
+      </p:sp>
+      <p:sp>
+        <p:nvSpPr>
+          <p:cNvPr id="37" name="Text 35"/>
+          <p:cNvSpPr/>
+          <p:nvPr/>
+        </p:nvSpPr>
+        <p:spPr>
+          <a:xfrm>
+            <a:off x="482501" y="4635550"/>
+            <a:ext cx="4166280" cy="152400"/>
+          </a:xfrm>
+          <a:prstGeom prst="rect">
+            <a:avLst/>
+          </a:prstGeom>
+          <a:noFill/>
+          <a:ln/>
+        </p:spPr>
+        <p:txBody>
+          <a:bodyPr wrap="square" lIns="0" tIns="0" rIns="0" bIns="0" rtlCol="0" anchor="t"/>
+          <a:lstStyle/>
+          <a:p>
+            <a:pPr algn="l" indent="0" marL="0">
+              <a:buNone/>
+            </a:pPr>
+            <a:r>
+              <a:rPr lang="en-US" sz="1050" b="1" dirty="0">
+                <a:solidFill>
+                  <a:srgbClr val="56D364"/>
+                </a:solidFill>
+                <a:latin typeface="Arial" pitchFamily="34" charset="0"/>
+                <a:ea typeface="Arial" pitchFamily="34" charset="-122"/>
+                <a:cs typeface="Arial" pitchFamily="34" charset="-120"/>
+              </a:rPr>
+              <a:t>Key idea:</a:t>
+            </a:r>
+            <a:pPr algn="l" indent="0" marL="0">
+              <a:buNone/>
+            </a:pPr>
+            <a:r>
+              <a:rPr lang="en-US" sz="1050" dirty="0">
+                <a:solidFill>
+                  <a:srgbClr val="D2F4D5"/>
+                </a:solidFill>
+                <a:latin typeface="Arial" pitchFamily="34" charset="0"/>
+                <a:ea typeface="Arial" pitchFamily="34" charset="-122"/>
+                <a:cs typeface="Arial" pitchFamily="34" charset="-120"/>
+              </a:rPr>
+              <a:t> commit each focused change before adding the next layer.</a:t>
+            </a:r>
+            <a:endParaRPr lang="en-US" sz="1050" dirty="0"/>
+          </a:p>
+        </p:txBody>
+      </p:sp>
+      <p:sp>
+        <p:nvSpPr>
+          <p:cNvPr id="38" name="Text 36"/>
+          <p:cNvSpPr/>
+          <p:nvPr/>
+        </p:nvSpPr>
+        <p:spPr>
+          <a:xfrm>
+            <a:off x="4636889" y="4635550"/>
+            <a:ext cx="4105102" cy="152400"/>
+          </a:xfrm>
+          <a:prstGeom prst="rect">
+            <a:avLst/>
+          </a:prstGeom>
+          <a:noFill/>
+          <a:ln/>
+        </p:spPr>
+        <p:txBody>
+          <a:bodyPr wrap="square" lIns="0" tIns="0" rIns="0" bIns="0" rtlCol="0" anchor="t"/>
+          <a:lstStyle/>
+          <a:p>
+            <a:pPr algn="l" indent="0" marL="0">
+              <a:buNone/>
+            </a:pPr>
+            <a:r>
+              <a:rPr lang="en-US" sz="1050" dirty="0">
+                <a:solidFill>
+                  <a:srgbClr val="8B949E"/>
+                </a:solidFill>
+                <a:latin typeface="Arial" pitchFamily="34" charset="0"/>
+                <a:ea typeface="Arial" pitchFamily="34" charset="-122"/>
+                <a:cs typeface="Arial" pitchFamily="34" charset="-120"/>
+              </a:rPr>
+              <a:t>Interactive submit lets you review titles, descriptions, and draft state.</a:t>
+            </a:r>
+            <a:endParaRPr lang="en-US" sz="1050" dirty="0"/>
+          </a:p>
+        </p:txBody>
+      </p:sp>
+      <p:sp>
+        <p:nvSpPr>
+          <p:cNvPr id="39" name="Shape 37"/>
+          <p:cNvSpPr/>
+          <p:nvPr/>
+        </p:nvSpPr>
+        <p:spPr>
+          <a:xfrm>
+            <a:off x="7479792" y="146304"/>
+            <a:ext cx="1078992" cy="283464"/>
+          </a:xfrm>
+          <a:prstGeom prst="roundRect">
+            <a:avLst>
+              <a:gd name="adj" fmla="val 19355"/>
+            </a:avLst>
+          </a:prstGeom>
+          <a:solidFill>
+            <a:srgbClr val="1A5D2A"/>
+          </a:solidFill>
+          <a:ln w="12700">
+            <a:solidFill>
+              <a:srgbClr val="2EA043"/>
+            </a:solidFill>
+            <a:prstDash val="solid"/>
+          </a:ln>
+        </p:spPr>
+      </p:sp>
+      <p:sp>
+        <p:nvSpPr>
+          <p:cNvPr id="40" name="Text 38">
+            <a:hlinkClick r:id="rId1" tooltip=""/>
+          </p:cNvPr>
+          <p:cNvSpPr/>
+          <p:nvPr/>
+        </p:nvSpPr>
+        <p:spPr>
+          <a:xfrm>
+            <a:off x="7479792" y="146304"/>
+            <a:ext cx="1078992" cy="283464"/>
+          </a:xfrm>
+          <a:prstGeom prst="rect">
+            <a:avLst/>
+          </a:prstGeom>
+          <a:noFill/>
+          <a:ln/>
+        </p:spPr>
+        <p:txBody>
+          <a:bodyPr wrap="square" lIns="0" tIns="0" rIns="0" bIns="0" rtlCol="0" anchor="ctr"/>
+          <a:lstStyle/>
+          <a:p>
+            <a:pPr algn="ctr" indent="0" marL="0">
+              <a:buNone/>
+            </a:pPr>
+            <a:r>
+              <a:rPr lang="en-US" sz="1050" b="1" u="sng" dirty="0">
+                <a:solidFill>
+                  <a:srgbClr val="FFFFFF"/>
+                </a:solidFill>
+                <a:latin typeface="Arial" pitchFamily="34" charset="0"/>
+                <a:ea typeface="Arial" pitchFamily="34" charset="-122"/>
+                <a:cs typeface="Arial" pitchFamily="34" charset="-120"/>
+                <a:hlinkClick r:id="rId1" invalidUrl="" action="" tgtFrame="" tooltip="" history="1" highlightClick="0" endSnd="0">
+                  <a:extLst>
+                    <a:ext uri="{A12FA001-AC4F-418D-AE19-62706E023703}">
+                      <ahyp:hlinkClr xmlns:ahyp="http://schemas.microsoft.com/office/drawing/2018/hyperlinkcolor" val="tx"/>
+                    </a:ext>
+                  </a:extLst>
+                </a:hlinkClick>
+              </a:rPr>
+              <a:t>gh.io/stacks</a:t>
+            </a:r>
+            <a:endParaRPr lang="en-US" sz="1050" dirty="0"/>
+          </a:p>
+        </p:txBody>
+      </p:sp>
+      <p:pic>
+        <p:nvPicPr>
+          <p:cNvPr id="41" name="Image 0" descr="/root/projects/work/gh-stack-demo/slides/github-invertocat.png">
+            <a:hlinkClick r:id="rId3" tooltip=""/>
+          </p:cNvPr>
+          <p:cNvPicPr>
+            <a:picLocks noChangeAspect="1"/>
+          </p:cNvPicPr>
+          <p:nvPr/>
+        </p:nvPicPr>
+        <p:blipFill>
+          <a:blip r:embed="rId2"/>
+          <a:stretch>
+            <a:fillRect/>
+          </a:stretch>
+        </p:blipFill>
+        <p:spPr>
+          <a:xfrm>
+            <a:off x="8668512" y="137160"/>
+            <a:ext cx="301752" cy="301752"/>
+          </a:xfrm>
+          <a:prstGeom prst="rect">
+            <a:avLst/>
+          </a:prstGeom>
+        </p:spPr>
+      </p:pic>
+    </p:spTree>
+  </p:cSld>
+  <p:clrMapOvr>
+    <a:masterClrMapping/>
+  </p:clrMapOvr>
+</p:sld>
+</file>
+
 <file path=ppt/theme/theme1.xml><?xml version="1.0" encoding="utf-8"?>
 <a:theme xmlns:a="http://schemas.openxmlformats.org/drawingml/2006/main" name="Office Theme">
   <a:themeElements>

</xml_diff>

<commit_message>
docs: update stacked PR slide deck
</commit_message>
<xml_diff>
--- a/github-stacked-prs.pptx
+++ b/github-stacked-prs.pptx
@@ -6857,8 +6857,8 @@
         </p:nvSpPr>
         <p:spPr>
           <a:xfrm>
-            <a:off x="482501" y="1433661"/>
-            <a:ext cx="8178998" cy="3074938"/>
+            <a:off x="73551" y="1433661"/>
+            <a:ext cx="8996898" cy="3074938"/>
           </a:xfrm>
           <a:prstGeom prst="roundRect">
             <a:avLst>
@@ -6893,8 +6893,8 @@
         </p:nvSpPr>
         <p:spPr>
           <a:xfrm>
-            <a:off x="501551" y="1452711"/>
-            <a:ext cx="8140898" cy="355550"/>
+            <a:off x="94506" y="1452711"/>
+            <a:ext cx="8954988" cy="355550"/>
           </a:xfrm>
           <a:prstGeom prst="rect">
             <a:avLst/>
@@ -6953,7 +6953,7 @@
         </p:nvSpPr>
         <p:spPr>
           <a:xfrm>
-            <a:off x="641152" y="1581299"/>
+            <a:off x="237292" y="1581299"/>
             <a:ext cx="88850" cy="88850"/>
           </a:xfrm>
           <a:prstGeom prst="roundRect">
@@ -6985,7 +6985,7 @@
         </p:nvSpPr>
         <p:spPr>
           <a:xfrm>
-            <a:off x="806202" y="1581299"/>
+            <a:off x="402342" y="1581299"/>
             <a:ext cx="88850" cy="88850"/>
           </a:xfrm>
           <a:prstGeom prst="roundRect">
@@ -7017,7 +7017,7 @@
         </p:nvSpPr>
         <p:spPr>
           <a:xfrm>
-            <a:off x="971252" y="1581299"/>
+            <a:off x="567392" y="1581299"/>
             <a:ext cx="88850" cy="88850"/>
           </a:xfrm>
           <a:prstGeom prst="roundRect">
@@ -7049,8 +7049,8 @@
         </p:nvSpPr>
         <p:spPr>
           <a:xfrm>
-            <a:off x="4238923" y="1554212"/>
-            <a:ext cx="1106960" cy="142875"/>
+            <a:off x="3775144" y="1532432"/>
+            <a:ext cx="1605618" cy="186583"/>
           </a:xfrm>
           <a:prstGeom prst="rect">
             <a:avLst/>
@@ -7088,8 +7088,8 @@
         </p:nvSpPr>
         <p:spPr>
           <a:xfrm>
-            <a:off x="704701" y="1947863"/>
-            <a:ext cx="3679746" cy="158353"/>
+            <a:off x="219268" y="1947863"/>
+            <a:ext cx="4452493" cy="158353"/>
           </a:xfrm>
           <a:prstGeom prst="rect">
             <a:avLst/>
@@ -7133,8 +7133,8 @@
         </p:nvSpPr>
         <p:spPr>
           <a:xfrm>
-            <a:off x="704701" y="2131516"/>
-            <a:ext cx="3679746" cy="158353"/>
+            <a:off x="219268" y="2131516"/>
+            <a:ext cx="4452493" cy="158353"/>
           </a:xfrm>
           <a:prstGeom prst="rect">
             <a:avLst/>
@@ -7178,8 +7178,8 @@
         </p:nvSpPr>
         <p:spPr>
           <a:xfrm>
-            <a:off x="704701" y="2315170"/>
-            <a:ext cx="3679746" cy="158353"/>
+            <a:off x="219268" y="2315170"/>
+            <a:ext cx="4452493" cy="158353"/>
           </a:xfrm>
           <a:prstGeom prst="rect">
             <a:avLst/>
@@ -7223,8 +7223,8 @@
         </p:nvSpPr>
         <p:spPr>
           <a:xfrm>
-            <a:off x="704701" y="2498824"/>
-            <a:ext cx="3679746" cy="158353"/>
+            <a:off x="219268" y="2498824"/>
+            <a:ext cx="4452493" cy="158353"/>
           </a:xfrm>
           <a:prstGeom prst="rect">
             <a:avLst/>
@@ -7268,8 +7268,8 @@
         </p:nvSpPr>
         <p:spPr>
           <a:xfrm>
-            <a:off x="704701" y="2682478"/>
-            <a:ext cx="3679746" cy="158353"/>
+            <a:off x="219268" y="2682478"/>
+            <a:ext cx="4452493" cy="158353"/>
           </a:xfrm>
           <a:prstGeom prst="rect">
             <a:avLst/>
@@ -7313,8 +7313,8 @@
         </p:nvSpPr>
         <p:spPr>
           <a:xfrm>
-            <a:off x="704701" y="2866132"/>
-            <a:ext cx="3679746" cy="158353"/>
+            <a:off x="219268" y="2866132"/>
+            <a:ext cx="4452493" cy="158353"/>
           </a:xfrm>
           <a:prstGeom prst="rect">
             <a:avLst/>
@@ -7358,8 +7358,8 @@
         </p:nvSpPr>
         <p:spPr>
           <a:xfrm>
-            <a:off x="704701" y="3049786"/>
-            <a:ext cx="3679746" cy="158353"/>
+            <a:off x="219268" y="3049786"/>
+            <a:ext cx="4452493" cy="158353"/>
           </a:xfrm>
           <a:prstGeom prst="rect">
             <a:avLst/>
@@ -7403,8 +7403,8 @@
         </p:nvSpPr>
         <p:spPr>
           <a:xfrm>
-            <a:off x="704701" y="3233440"/>
-            <a:ext cx="3679746" cy="158353"/>
+            <a:off x="219268" y="3233440"/>
+            <a:ext cx="4452493" cy="158353"/>
           </a:xfrm>
           <a:prstGeom prst="rect">
             <a:avLst/>
@@ -7448,8 +7448,8 @@
         </p:nvSpPr>
         <p:spPr>
           <a:xfrm>
-            <a:off x="704701" y="3417094"/>
-            <a:ext cx="3679746" cy="158353"/>
+            <a:off x="219268" y="3417094"/>
+            <a:ext cx="4452493" cy="158353"/>
           </a:xfrm>
           <a:prstGeom prst="rect">
             <a:avLst/>
@@ -7493,8 +7493,8 @@
         </p:nvSpPr>
         <p:spPr>
           <a:xfrm>
-            <a:off x="704701" y="3600748"/>
-            <a:ext cx="3679746" cy="158353"/>
+            <a:off x="219268" y="3600748"/>
+            <a:ext cx="4452493" cy="158353"/>
           </a:xfrm>
           <a:prstGeom prst="rect">
             <a:avLst/>
@@ -7538,8 +7538,8 @@
         </p:nvSpPr>
         <p:spPr>
           <a:xfrm>
-            <a:off x="704701" y="3784402"/>
-            <a:ext cx="3679746" cy="158353"/>
+            <a:off x="219268" y="3784402"/>
+            <a:ext cx="4452493" cy="158353"/>
           </a:xfrm>
           <a:prstGeom prst="rect">
             <a:avLst/>
@@ -7583,8 +7583,8 @@
         </p:nvSpPr>
         <p:spPr>
           <a:xfrm>
-            <a:off x="704701" y="3968055"/>
-            <a:ext cx="3679746" cy="158353"/>
+            <a:off x="219268" y="3968055"/>
+            <a:ext cx="4452493" cy="158353"/>
           </a:xfrm>
           <a:prstGeom prst="rect">
             <a:avLst/>
@@ -7658,8 +7658,8 @@
         </p:nvSpPr>
         <p:spPr>
           <a:xfrm>
-            <a:off x="4831854" y="1947863"/>
-            <a:ext cx="3679594" cy="158353"/>
+            <a:off x="4681717" y="1947863"/>
+            <a:ext cx="4452308" cy="158353"/>
           </a:xfrm>
           <a:prstGeom prst="rect">
             <a:avLst/>
@@ -7703,8 +7703,8 @@
         </p:nvSpPr>
         <p:spPr>
           <a:xfrm>
-            <a:off x="4831854" y="2131516"/>
-            <a:ext cx="3679594" cy="158353"/>
+            <a:off x="4681717" y="2131516"/>
+            <a:ext cx="4452308" cy="158353"/>
           </a:xfrm>
           <a:prstGeom prst="rect">
             <a:avLst/>
@@ -7748,8 +7748,8 @@
         </p:nvSpPr>
         <p:spPr>
           <a:xfrm>
-            <a:off x="4831854" y="2315170"/>
-            <a:ext cx="3679594" cy="158353"/>
+            <a:off x="4681717" y="2315170"/>
+            <a:ext cx="4452308" cy="158353"/>
           </a:xfrm>
           <a:prstGeom prst="rect">
             <a:avLst/>
@@ -7793,8 +7793,8 @@
         </p:nvSpPr>
         <p:spPr>
           <a:xfrm>
-            <a:off x="4831854" y="2498824"/>
-            <a:ext cx="3679594" cy="158353"/>
+            <a:off x="4681717" y="2498824"/>
+            <a:ext cx="4452308" cy="158353"/>
           </a:xfrm>
           <a:prstGeom prst="rect">
             <a:avLst/>
@@ -7838,8 +7838,8 @@
         </p:nvSpPr>
         <p:spPr>
           <a:xfrm>
-            <a:off x="4831854" y="2682478"/>
-            <a:ext cx="3679594" cy="158353"/>
+            <a:off x="4681717" y="2682478"/>
+            <a:ext cx="4452308" cy="158353"/>
           </a:xfrm>
           <a:prstGeom prst="rect">
             <a:avLst/>
@@ -7861,7 +7861,7 @@
               <a:buNone/>
             </a:pPr>
             <a:r>
-              <a:rPr lang="en-US" sz="800" dirty="0">
+              <a:rPr lang="en-US" sz="1000" dirty="0">
                 <a:solidFill>
                   <a:srgbClr val="79C0FF"/>
                 </a:solidFill>
@@ -7871,7 +7871,7 @@
               </a:rPr>
               <a:t>$ git commit -m "test: cover task creation and validation"</a:t>
             </a:r>
-            <a:endParaRPr lang="en-US" sz="800" dirty="0"/>
+            <a:endParaRPr lang="en-US" sz="1000" dirty="0"/>
           </a:p>
         </p:txBody>
       </p:sp>
@@ -7883,8 +7883,8 @@
         </p:nvSpPr>
         <p:spPr>
           <a:xfrm>
-            <a:off x="4831854" y="2866132"/>
-            <a:ext cx="3679594" cy="158353"/>
+            <a:off x="4681717" y="2866132"/>
+            <a:ext cx="4452308" cy="158353"/>
           </a:xfrm>
           <a:prstGeom prst="rect">
             <a:avLst/>
@@ -7928,8 +7928,8 @@
         </p:nvSpPr>
         <p:spPr>
           <a:xfrm>
-            <a:off x="4831854" y="3049786"/>
-            <a:ext cx="3679594" cy="158353"/>
+            <a:off x="4681717" y="3049786"/>
+            <a:ext cx="4452308" cy="158353"/>
           </a:xfrm>
           <a:prstGeom prst="rect">
             <a:avLst/>
@@ -7973,8 +7973,8 @@
         </p:nvSpPr>
         <p:spPr>
           <a:xfrm>
-            <a:off x="4831854" y="3233440"/>
-            <a:ext cx="3679594" cy="158353"/>
+            <a:off x="4681717" y="3233440"/>
+            <a:ext cx="4452308" cy="158353"/>
           </a:xfrm>
           <a:prstGeom prst="rect">
             <a:avLst/>
@@ -8018,8 +8018,8 @@
         </p:nvSpPr>
         <p:spPr>
           <a:xfrm>
-            <a:off x="4831854" y="3417094"/>
-            <a:ext cx="3679594" cy="158353"/>
+            <a:off x="4681717" y="3417094"/>
+            <a:ext cx="4452308" cy="158353"/>
           </a:xfrm>
           <a:prstGeom prst="rect">
             <a:avLst/>
@@ -8063,8 +8063,8 @@
         </p:nvSpPr>
         <p:spPr>
           <a:xfrm>
-            <a:off x="4831854" y="3600748"/>
-            <a:ext cx="3679594" cy="158353"/>
+            <a:off x="4681717" y="3600748"/>
+            <a:ext cx="4452308" cy="158353"/>
           </a:xfrm>
           <a:prstGeom prst="rect">
             <a:avLst/>
@@ -8108,8 +8108,8 @@
         </p:nvSpPr>
         <p:spPr>
           <a:xfrm>
-            <a:off x="4831854" y="3784402"/>
-            <a:ext cx="3679594" cy="158353"/>
+            <a:off x="4681717" y="3784402"/>
+            <a:ext cx="4452308" cy="158353"/>
           </a:xfrm>
           <a:prstGeom prst="rect">
             <a:avLst/>
@@ -8153,8 +8153,8 @@
         </p:nvSpPr>
         <p:spPr>
           <a:xfrm>
-            <a:off x="4831854" y="3968055"/>
-            <a:ext cx="3679594" cy="158353"/>
+            <a:off x="4681717" y="3968055"/>
+            <a:ext cx="4452308" cy="158353"/>
           </a:xfrm>
           <a:prstGeom prst="rect">
             <a:avLst/>

</xml_diff>

<commit_message>
chore: align assets with renamed repository
</commit_message>
<xml_diff>
--- a/github-stacked-prs.pptx
+++ b/github-stacked-prs.pptx
@@ -1040,7 +1040,7 @@
       </p:sp>
       <p:pic>
         <p:nvPicPr>
-          <p:cNvPr id="9" name="Image 0" descr="/root/projects/work/gh-stack-demo/slides/github-invertocat.png">
+          <p:cNvPr id="9" name="Image 0" descr="/root/projects/work/gh-stacked-prs-demo/slides/github-invertocat.png">
             <a:hlinkClick r:id="rId3"/>
           </p:cNvPr>
           <p:cNvPicPr>
@@ -2228,7 +2228,7 @@
       </p:sp>
       <p:pic>
         <p:nvPicPr>
-          <p:cNvPr id="34" name="Image 0" descr="/root/projects/work/gh-stack-demo/slides/github-invertocat.png">
+          <p:cNvPr id="34" name="Image 0" descr="/root/projects/work/gh-stacked-prs-demo/slides/github-invertocat.png">
             <a:hlinkClick r:id="rId4"/>
           </p:cNvPr>
           <p:cNvPicPr>
@@ -4188,7 +4188,7 @@
       </p:sp>
       <p:pic>
         <p:nvPicPr>
-          <p:cNvPr id="48" name="Image 0" descr="/root/projects/work/gh-stack-demo/slides/github-invertocat.png">
+          <p:cNvPr id="48" name="Image 0" descr="/root/projects/work/gh-stacked-prs-demo/slides/github-invertocat.png">
             <a:hlinkClick r:id="rId4"/>
           </p:cNvPr>
           <p:cNvPicPr>
@@ -6309,7 +6309,7 @@
       </p:sp>
       <p:pic>
         <p:nvPicPr>
-          <p:cNvPr id="33" name="Image 0" descr="/root/projects/work/gh-stack-demo/slides/github-invertocat.png">
+          <p:cNvPr id="33" name="Image 0" descr="/root/projects/work/gh-stacked-prs-demo/slides/github-invertocat.png">
             <a:hlinkClick r:id="rId4"/>
           </p:cNvPr>
           <p:cNvPicPr>
@@ -7074,7 +7074,7 @@
                 <a:ea typeface="Courier New" pitchFamily="34" charset="-122"/>
                 <a:cs typeface="Courier New" pitchFamily="34" charset="-120"/>
               </a:rPr>
-              <a:t>gh-stack-demo — bash</a:t>
+              <a:t>gh-stacked-prs-demo — bash</a:t>
             </a:r>
             <a:endParaRPr lang="en-US" sz="950" dirty="0"/>
           </a:p>
@@ -8324,7 +8324,7 @@
       </p:sp>
       <p:pic>
         <p:nvPicPr>
-          <p:cNvPr id="41" name="Image 0" descr="/root/projects/work/gh-stack-demo/slides/github-invertocat.png">
+          <p:cNvPr id="41" name="Image 0" descr="/root/projects/work/gh-stacked-prs-demo/slides/github-invertocat.png">
             <a:hlinkClick r:id="rId3"/>
           </p:cNvPr>
           <p:cNvPicPr>
@@ -8431,7 +8431,7 @@
                   <a:schemeClr val="bg1"/>
                 </a:solidFill>
               </a:rPr>
-              <a:t>-stack-demo</a:t>
+              <a:t>-stacked-prs-demo</a:t>
             </a:r>
           </a:p>
         </p:txBody>

</xml_diff>

<commit_message>
docs: align resource with canonical stack
</commit_message>
<xml_diff>
--- a/github-stacked-prs.pptx
+++ b/github-stacked-prs.pptx
@@ -1040,7 +1040,7 @@
       </p:sp>
       <p:pic>
         <p:nvPicPr>
-          <p:cNvPr id="9" name="Image 0" descr="/root/projects/work/gh-stacked-prs-demo/slides/github-invertocat.png">
+          <p:cNvPr id="9" name="Image 0" descr="GitHub logo">
             <a:hlinkClick r:id="rId3"/>
           </p:cNvPr>
           <p:cNvPicPr>
@@ -1518,7 +1518,7 @@
                   <a:ea typeface="Arial" pitchFamily="34" charset="-122"/>
                   <a:cs typeface="Arial" pitchFamily="34" charset="-120"/>
                 </a:rPr>
-                <a:t>Everything arrives at once. Reviewers must untangle the model, validation, and tests together.</a:t>
+                <a:t>Everything arrives at once. Reviewers must untangle the model, validation, and API together.</a:t>
               </a:r>
               <a:endParaRPr lang="en-US" sz="1400" dirty="0"/>
             </a:p>
@@ -2228,7 +2228,7 @@
       </p:sp>
       <p:pic>
         <p:nvPicPr>
-          <p:cNvPr id="34" name="Image 0" descr="/root/projects/work/gh-stacked-prs-demo/slides/github-invertocat.png">
+          <p:cNvPr id="34" name="Image 0" descr="GitHub logo">
             <a:hlinkClick r:id="rId4"/>
           </p:cNvPr>
           <p:cNvPicPr>
@@ -2664,7 +2664,7 @@
                 <a:ea typeface="Arial" pitchFamily="34" charset="-122"/>
                 <a:cs typeface="Arial" pitchFamily="34" charset="-120"/>
               </a:rPr>
-              <a:t>Model + validation + tests arrive as one mixed review.</a:t>
+              <a:t>Model + validation + API arrive as one mixed review.</a:t>
             </a:r>
             <a:endParaRPr lang="en-US" sz="1250" dirty="0"/>
           </a:p>
@@ -2960,7 +2960,7 @@
                   <a:ea typeface="Arial" pitchFamily="34" charset="-122"/>
                   <a:cs typeface="Arial" pitchFamily="34" charset="-120"/>
                 </a:rPr>
-                <a:t>Tests</a:t>
+                <a:t>API</a:t>
               </a:r>
               <a:endParaRPr lang="en-US" sz="1050" dirty="0"/>
             </a:p>
@@ -4188,7 +4188,7 @@
       </p:sp>
       <p:pic>
         <p:nvPicPr>
-          <p:cNvPr id="48" name="Image 0" descr="/root/projects/work/gh-stacked-prs-demo/slides/github-invertocat.png">
+          <p:cNvPr id="48" name="Image 0" descr="GitHub logo">
             <a:hlinkClick r:id="rId4"/>
           </p:cNvPr>
           <p:cNvPicPr>
@@ -5989,7 +5989,7 @@
                   <a:ea typeface="Arial" pitchFamily="34" charset="-122"/>
                   <a:cs typeface="Arial" pitchFamily="34" charset="-120"/>
                 </a:rPr>
-                <a:t>Review focused diffs, update dependent layers, then land all or part of the stack.</a:t>
+                <a:t>Review focused diffs, get approval, then update or land the stack.</a:t>
               </a:r>
               <a:endParaRPr lang="en-US" sz="1150" dirty="0"/>
             </a:p>
@@ -6309,7 +6309,7 @@
       </p:sp>
       <p:pic>
         <p:nvPicPr>
-          <p:cNvPr id="33" name="Image 0" descr="/root/projects/work/gh-stacked-prs-demo/slides/github-invertocat.png">
+          <p:cNvPr id="33" name="Image 0" descr="GitHub logo">
             <a:hlinkClick r:id="rId4"/>
           </p:cNvPr>
           <p:cNvPicPr>
@@ -7074,7 +7074,7 @@
                 <a:ea typeface="Courier New" pitchFamily="34" charset="-122"/>
                 <a:cs typeface="Courier New" pitchFamily="34" charset="-120"/>
               </a:rPr>
-              <a:t>gh-stacked-prs-demo — bash</a:t>
+              <a:t>gh-stacked-prs — bash</a:t>
             </a:r>
             <a:endParaRPr lang="en-US" sz="950" dirty="0"/>
           </a:p>
@@ -7254,7 +7254,7 @@
                 <a:ea typeface="Courier New" pitchFamily="34" charset="-122"/>
                 <a:cs typeface="Courier New" pitchFamily="34" charset="-120"/>
               </a:rPr>
-              <a:t>$ gh stack init feature/task-model</a:t>
+              <a:t>$ gh stack init --base main tasks/model</a:t>
             </a:r>
             <a:endParaRPr lang="en-US" sz="1000" dirty="0"/>
           </a:p>
@@ -7299,7 +7299,7 @@
                 <a:ea typeface="Courier New" pitchFamily="34" charset="-122"/>
                 <a:cs typeface="Courier New" pitchFamily="34" charset="-120"/>
               </a:rPr>
-              <a:t># edit src/tasks.js</a:t>
+              <a:t># edit model + model test</a:t>
             </a:r>
             <a:endParaRPr lang="en-US" sz="1000" dirty="0"/>
           </a:p>
@@ -7344,7 +7344,7 @@
                 <a:ea typeface="Courier New" pitchFamily="34" charset="-122"/>
                 <a:cs typeface="Courier New" pitchFamily="34" charset="-120"/>
               </a:rPr>
-              <a:t>$ git add src/tasks.js</a:t>
+              <a:t>$ git add src test</a:t>
             </a:r>
             <a:endParaRPr lang="en-US" sz="1000" dirty="0"/>
           </a:p>
@@ -7389,7 +7389,7 @@
                 <a:ea typeface="Courier New" pitchFamily="34" charset="-122"/>
                 <a:cs typeface="Courier New" pitchFamily="34" charset="-120"/>
               </a:rPr>
-              <a:t>$ git commit -m "feat: add task model"</a:t>
+              <a:t>$ git commit -m "feat: add tested task model"</a:t>
             </a:r>
             <a:endParaRPr lang="en-US" sz="1000" dirty="0"/>
           </a:p>
@@ -7479,7 +7479,7 @@
                 <a:ea typeface="Courier New" pitchFamily="34" charset="-122"/>
                 <a:cs typeface="Courier New" pitchFamily="34" charset="-120"/>
               </a:rPr>
-              <a:t>$ gh stack add feature/task-validation</a:t>
+              <a:t>$ gh stack add tasks/validation</a:t>
             </a:r>
             <a:endParaRPr lang="en-US" sz="1000" dirty="0"/>
           </a:p>
@@ -7524,7 +7524,7 @@
                 <a:ea typeface="Courier New" pitchFamily="34" charset="-122"/>
                 <a:cs typeface="Courier New" pitchFamily="34" charset="-120"/>
               </a:rPr>
-              <a:t># edit src/tasks.js</a:t>
+              <a:t># edit validation + test</a:t>
             </a:r>
             <a:endParaRPr lang="en-US" sz="1000" dirty="0"/>
           </a:p>
@@ -7569,7 +7569,7 @@
                 <a:ea typeface="Courier New" pitchFamily="34" charset="-122"/>
                 <a:cs typeface="Courier New" pitchFamily="34" charset="-120"/>
               </a:rPr>
-              <a:t>$ git add src/tasks.js</a:t>
+              <a:t>$ git add src test</a:t>
             </a:r>
             <a:endParaRPr lang="en-US" sz="1000" dirty="0"/>
           </a:p>
@@ -7614,7 +7614,7 @@
                 <a:ea typeface="Courier New" pitchFamily="34" charset="-122"/>
                 <a:cs typeface="Courier New" pitchFamily="34" charset="-120"/>
               </a:rPr>
-              <a:t>$ git commit -m "feat: validate task titles"</a:t>
+              <a:t>$ git commit -m "feat: add tested task validation"</a:t>
             </a:r>
             <a:endParaRPr lang="en-US" sz="1000" dirty="0"/>
           </a:p>
@@ -7689,7 +7689,7 @@
                 <a:ea typeface="Courier New" pitchFamily="34" charset="-122"/>
                 <a:cs typeface="Courier New" pitchFamily="34" charset="-120"/>
               </a:rPr>
-              <a:t># Layer 3: tests</a:t>
+              <a:t># Layer 3: API</a:t>
             </a:r>
             <a:endParaRPr lang="en-US" sz="1000" dirty="0"/>
           </a:p>
@@ -7734,7 +7734,7 @@
                 <a:ea typeface="Courier New" pitchFamily="34" charset="-122"/>
                 <a:cs typeface="Courier New" pitchFamily="34" charset="-120"/>
               </a:rPr>
-              <a:t>$ gh stack add test/task-model</a:t>
+              <a:t>$ gh stack add tasks/api</a:t>
             </a:r>
             <a:endParaRPr lang="en-US" sz="1000" dirty="0"/>
           </a:p>
@@ -7779,7 +7779,7 @@
                 <a:ea typeface="Courier New" pitchFamily="34" charset="-122"/>
                 <a:cs typeface="Courier New" pitchFamily="34" charset="-120"/>
               </a:rPr>
-              <a:t># edit test/tasks.test.js</a:t>
+              <a:t># edit package.json + API files</a:t>
             </a:r>
             <a:endParaRPr lang="en-US" sz="1000" dirty="0"/>
           </a:p>
@@ -7824,7 +7824,7 @@
                 <a:ea typeface="Courier New" pitchFamily="34" charset="-122"/>
                 <a:cs typeface="Courier New" pitchFamily="34" charset="-120"/>
               </a:rPr>
-              <a:t>$ git add test/tasks.test.js</a:t>
+              <a:t>$ git add package.json src test</a:t>
             </a:r>
             <a:endParaRPr lang="en-US" sz="1000" dirty="0"/>
           </a:p>
@@ -7869,7 +7869,7 @@
                 <a:ea typeface="Courier New" pitchFamily="34" charset="-122"/>
                 <a:cs typeface="Courier New" pitchFamily="34" charset="-120"/>
               </a:rPr>
-              <a:t>$ git commit -m "test: cover task creation and validation"</a:t>
+              <a:t>$ git commit -m "feat: add tested task API"</a:t>
             </a:r>
             <a:endParaRPr lang="en-US" sz="1000" dirty="0"/>
           </a:p>
@@ -7959,7 +7959,7 @@
                 <a:ea typeface="Courier New" pitchFamily="34" charset="-122"/>
                 <a:cs typeface="Courier New" pitchFamily="34" charset="-120"/>
               </a:rPr>
-              <a:t>$ gh stack view</a:t>
+              <a:t>$ gh stack view --json</a:t>
             </a:r>
             <a:endParaRPr lang="en-US" sz="1000" dirty="0"/>
           </a:p>
@@ -8094,7 +8094,7 @@
                 <a:ea typeface="Courier New" pitchFamily="34" charset="-122"/>
                 <a:cs typeface="Courier New" pitchFamily="34" charset="-120"/>
               </a:rPr>
-              <a:t># Later: update and land the stack</a:t>
+              <a:t># Later, after approval: update or land</a:t>
             </a:r>
             <a:endParaRPr lang="en-US" sz="1000" dirty="0"/>
           </a:p>
@@ -8184,7 +8184,7 @@
                 <a:ea typeface="Courier New" pitchFamily="34" charset="-122"/>
                 <a:cs typeface="Courier New" pitchFamily="34" charset="-120"/>
               </a:rPr>
-              <a:t>$ gh stack merge</a:t>
+              <a:t>$ gh stack merge --yes --squash</a:t>
             </a:r>
             <a:endParaRPr lang="en-US" sz="1000" dirty="0"/>
           </a:p>
@@ -8324,7 +8324,7 @@
       </p:sp>
       <p:pic>
         <p:nvPicPr>
-          <p:cNvPr id="41" name="Image 0" descr="/root/projects/work/gh-stacked-prs-demo/slides/github-invertocat.png">
+          <p:cNvPr id="41" name="Image 0" descr="GitHub logo">
             <a:hlinkClick r:id="rId3"/>
           </p:cNvPr>
           <p:cNvPicPr>
@@ -8431,7 +8431,7 @@
                   <a:schemeClr val="bg1"/>
                 </a:solidFill>
               </a:rPr>
-              <a:t>-stacked-prs-demo</a:t>
+              <a:t>-stacked-prs</a:t>
             </a:r>
           </a:p>
         </p:txBody>

</xml_diff>

<commit_message>
docs: rename learning repository
</commit_message>
<xml_diff>
--- a/github-stacked-prs.pptx
+++ b/github-stacked-prs.pptx
@@ -7074,7 +7074,7 @@
                 <a:ea typeface="Courier New" pitchFamily="34" charset="-122"/>
                 <a:cs typeface="Courier New" pitchFamily="34" charset="-120"/>
               </a:rPr>
-              <a:t>gh-stacked-prs — bash</a:t>
+              <a:t>stacked-prs — bash</a:t>
             </a:r>
             <a:endParaRPr lang="en-US" sz="950" dirty="0"/>
           </a:p>
@@ -8423,7 +8423,7 @@
                   <a:schemeClr val="bg1"/>
                 </a:solidFill>
               </a:rPr>
-              <a:t>gh</a:t>
+              <a:t>learn-github</a:t>
             </a:r>
             <a:r>
               <a:rPr lang="en-US" sz="1100" dirty="0">

</xml_diff>

<commit_message>
docs: refine stacked PR workshop and deck
</commit_message>
<xml_diff>
--- a/github-stacked-prs.pptx
+++ b/github-stacked-prs.pptx
@@ -11,7 +11,9 @@
     <p:sldId id="259" r:id="rId2"/>
     <p:sldId id="256" r:id="rId3"/>
     <p:sldId id="257" r:id="rId4"/>
+    <p:sldId id="262" r:id="rId13"/>
     <p:sldId id="258" r:id="rId5"/>
+    <p:sldId id="261" r:id="rId12"/>
     <p:sldId id="260" r:id="rId6"/>
   </p:sldIdLst>
   <p:sldSz cx="9144000" cy="5143500" type="screen16x9"/>
@@ -1017,20 +1019,13 @@
               <a:buNone/>
             </a:pPr>
             <a:r>
-              <a:rPr lang="en-US" sz="1050" b="1" u="sng" dirty="0">
+              <a:rPr lang="en-US" sz="1050" b="1" dirty="0">
                 <a:solidFill>
                   <a:srgbClr val="FFFFFF"/>
                 </a:solidFill>
                 <a:latin typeface="Arial" pitchFamily="34" charset="0"/>
                 <a:ea typeface="Arial" pitchFamily="34" charset="-122"/>
                 <a:cs typeface="Arial" pitchFamily="34" charset="-120"/>
-                <a:hlinkClick r:id="rId2">
-                  <a:extLst>
-                    <a:ext uri="{A12FA001-AC4F-418D-AE19-62706E023703}">
-                      <ahyp:hlinkClr xmlns:ahyp="http://schemas.microsoft.com/office/drawing/2018/hyperlinkcolor" val="tx"/>
-                    </a:ext>
-                  </a:extLst>
-                </a:hlinkClick>
               </a:rPr>
               <a:t>gh.io/stacks</a:t>
             </a:r>
@@ -1064,6 +1059,48 @@
           </a:prstGeom>
         </p:spPr>
       </p:pic>
+      <p:sp>
+        <p:nvSpPr>
+          <p:cNvPr id="10" name="Repository Link">
+            <a:hlinkClick r:id="rId5"/>
+          </p:cNvPr>
+          <p:cNvSpPr txBox="1"/>
+          <p:nvPr/>
+        </p:nvSpPr>
+        <p:spPr>
+          <a:xfrm>
+            <a:off x="484632" y="3858768"/>
+            <a:ext cx="7379208" cy="256032"/>
+          </a:xfrm>
+          <a:prstGeom prst="rect">
+            <a:avLst/>
+          </a:prstGeom>
+          <a:noFill/>
+        </p:spPr>
+        <p:txBody>
+          <a:bodyPr wrap="square" lIns="0" tIns="0" rIns="0" bIns="0" rtlCol="0" anchor="t">
+            <a:noAutofit/>
+          </a:bodyPr>
+          <a:lstStyle/>
+          <a:p>
+            <a:pPr marL="0" indent="0" algn="l">
+              <a:buNone/>
+            </a:pPr>
+            <a:r>
+              <a:rPr lang="en-US" sz="1000" b="1" dirty="0">
+                <a:solidFill>
+                  <a:srgbClr val="58A6FF"/>
+                </a:solidFill>
+                <a:latin typeface="Arial" pitchFamily="34" charset="0"/>
+                <a:ea typeface="Arial" pitchFamily="34" charset="-122"/>
+                <a:cs typeface="Arial" pitchFamily="34" charset="-120"/>
+              </a:rPr>
+              <a:t>github.com/DanWahlin/learn-github-stacked-prs</a:t>
+            </a:r>
+            <a:endParaRPr lang="en-US" sz="1000" dirty="0"/>
+          </a:p>
+        </p:txBody>
+      </p:sp>
     </p:spTree>
   </p:cSld>
   <p:clrMapOvr>
@@ -1133,7 +1170,7 @@
                 <a:ea typeface="Arial" pitchFamily="34" charset="-122"/>
                 <a:cs typeface="Arial" pitchFamily="34" charset="-120"/>
               </a:rPr>
-              <a:t>THE PROBLEM</a:t>
+              <a:t>THE CHALLENGE</a:t>
             </a:r>
             <a:endParaRPr lang="en-US" sz="1100" dirty="0"/>
           </a:p>
@@ -2205,20 +2242,13 @@
               <a:buNone/>
             </a:pPr>
             <a:r>
-              <a:rPr lang="en-US" sz="1050" b="1" u="sng" dirty="0">
+              <a:rPr lang="en-US" sz="1050" b="1" dirty="0">
                 <a:solidFill>
                   <a:srgbClr val="FFFFFF"/>
                 </a:solidFill>
                 <a:latin typeface="Arial" pitchFamily="34" charset="0"/>
                 <a:ea typeface="Arial" pitchFamily="34" charset="-122"/>
                 <a:cs typeface="Arial" pitchFamily="34" charset="-120"/>
-                <a:hlinkClick r:id="rId3">
-                  <a:extLst>
-                    <a:ext uri="{A12FA001-AC4F-418D-AE19-62706E023703}">
-                      <ahyp:hlinkClr xmlns:ahyp="http://schemas.microsoft.com/office/drawing/2018/hyperlinkcolor" val="tx"/>
-                    </a:ext>
-                  </a:extLst>
-                </a:hlinkClick>
               </a:rPr>
               <a:t>gh.io/stacks</a:t>
             </a:r>
@@ -4165,20 +4195,13 @@
               <a:buNone/>
             </a:pPr>
             <a:r>
-              <a:rPr lang="en-US" sz="1050" b="1" u="sng" dirty="0">
+              <a:rPr lang="en-US" sz="1050" b="1" dirty="0">
                 <a:solidFill>
                   <a:srgbClr val="FFFFFF"/>
                 </a:solidFill>
                 <a:latin typeface="Arial" pitchFamily="34" charset="0"/>
                 <a:ea typeface="Arial" pitchFamily="34" charset="-122"/>
                 <a:cs typeface="Arial" pitchFamily="34" charset="-120"/>
-                <a:hlinkClick r:id="rId3">
-                  <a:extLst>
-                    <a:ext uri="{A12FA001-AC4F-418D-AE19-62706E023703}">
-                      <ahyp:hlinkClr xmlns:ahyp="http://schemas.microsoft.com/office/drawing/2018/hyperlinkcolor" val="tx"/>
-                    </a:ext>
-                  </a:extLst>
-                </a:hlinkClick>
               </a:rPr>
               <a:t>gh.io/stacks</a:t>
             </a:r>
@@ -5004,7 +5027,7 @@
                 <a:ea typeface="Arial" pitchFamily="34" charset="-122"/>
                 <a:cs typeface="Arial" pitchFamily="34" charset="-120"/>
               </a:rPr>
-              <a:t>THE WORKFLOW</a:t>
+              <a:t>INTERACTIVE HUMAN WORKFLOW</a:t>
             </a:r>
             <a:endParaRPr lang="en-US" sz="1100" dirty="0"/>
           </a:p>
@@ -6201,7 +6224,7 @@
               <a:r>
                 <a:rPr lang="en-US" sz="1400" b="1" dirty="0">
                   <a:solidFill>
-                    <a:srgbClr val="56D364"/>
+                    <a:srgbClr val="79C0FF"/>
                   </a:solidFill>
                   <a:latin typeface="Arial" pitchFamily="34" charset="0"/>
                   <a:ea typeface="Arial" pitchFamily="34" charset="-122"/>
@@ -6212,7 +6235,7 @@
               <a:r>
                 <a:rPr lang="en-US" sz="1400" dirty="0">
                   <a:solidFill>
-                    <a:srgbClr val="D2F4D5"/>
+                    <a:srgbClr val="F0F6FC"/>
                   </a:solidFill>
                   <a:latin typeface="Arial" pitchFamily="34" charset="0"/>
                   <a:ea typeface="Arial" pitchFamily="34" charset="-122"/>
@@ -6286,20 +6309,13 @@
               <a:buNone/>
             </a:pPr>
             <a:r>
-              <a:rPr lang="en-US" sz="1050" b="1" u="sng" dirty="0">
+              <a:rPr lang="en-US" sz="1050" b="1" dirty="0">
                 <a:solidFill>
                   <a:srgbClr val="FFFFFF"/>
                 </a:solidFill>
                 <a:latin typeface="Arial" pitchFamily="34" charset="0"/>
                 <a:ea typeface="Arial" pitchFamily="34" charset="-122"/>
                 <a:cs typeface="Arial" pitchFamily="34" charset="-120"/>
-                <a:hlinkClick r:id="rId3">
-                  <a:extLst>
-                    <a:ext uri="{A12FA001-AC4F-418D-AE19-62706E023703}">
-                      <ahyp:hlinkClr xmlns:ahyp="http://schemas.microsoft.com/office/drawing/2018/hyperlinkcolor" val="tx"/>
-                    </a:ext>
-                  </a:extLst>
-                </a:hlinkClick>
               </a:rPr>
               <a:t>gh.io/stacks</a:t>
             </a:r>
@@ -6843,7 +6859,7 @@
                 <a:ea typeface="Arial" pitchFamily="34" charset="-122"/>
                 <a:cs typeface="Arial" pitchFamily="34" charset="-120"/>
               </a:rPr>
-              <a:t>Run this inside a clean repository with an authenticated GitHub CLI and a configured remote.</a:t>
+              <a:t>This is the CLI sequence. Add and test each layer before committing.</a:t>
             </a:r>
             <a:endParaRPr lang="en-US" sz="1400" dirty="0"/>
           </a:p>
@@ -7299,7 +7315,7 @@
                 <a:ea typeface="Courier New" pitchFamily="34" charset="-122"/>
                 <a:cs typeface="Courier New" pitchFamily="34" charset="-120"/>
               </a:rPr>
-              <a:t># edit model + model test</a:t>
+              <a:t># edit model + test; run npm test</a:t>
             </a:r>
             <a:endParaRPr lang="en-US" sz="1000" dirty="0"/>
           </a:p>
@@ -7524,7 +7540,7 @@
                 <a:ea typeface="Courier New" pitchFamily="34" charset="-122"/>
                 <a:cs typeface="Courier New" pitchFamily="34" charset="-120"/>
               </a:rPr>
-              <a:t># edit validation + test</a:t>
+              <a:t># edit validation + test; run npm test</a:t>
             </a:r>
             <a:endParaRPr lang="en-US" sz="1000" dirty="0"/>
           </a:p>
@@ -7779,7 +7795,7 @@
                 <a:ea typeface="Courier New" pitchFamily="34" charset="-122"/>
                 <a:cs typeface="Courier New" pitchFamily="34" charset="-120"/>
               </a:rPr>
-              <a:t># edit package.json + API files</a:t>
+              <a:t># edit API + tests; run npm test</a:t>
             </a:r>
             <a:endParaRPr lang="en-US" sz="1000" dirty="0"/>
           </a:p>
@@ -8094,7 +8110,7 @@
                 <a:ea typeface="Courier New" pitchFamily="34" charset="-122"/>
                 <a:cs typeface="Courier New" pitchFamily="34" charset="-120"/>
               </a:rPr>
-              <a:t># Later, after approval: update or land</a:t>
+              <a:t># Separate step: after review + approval</a:t>
             </a:r>
             <a:endParaRPr lang="en-US" sz="1000" dirty="0"/>
           </a:p>
@@ -8234,7 +8250,7 @@
                 <a:ea typeface="Arial" pitchFamily="34" charset="-122"/>
                 <a:cs typeface="Arial" pitchFamily="34" charset="-120"/>
               </a:rPr>
-              <a:t> commit each focused change before adding the next layer.</a:t>
+              <a:t> test and commit each focused change before adding the next layer.</a:t>
             </a:r>
             <a:endParaRPr lang="en-US" sz="1050" dirty="0"/>
           </a:p>
@@ -8301,20 +8317,13 @@
               <a:buNone/>
             </a:pPr>
             <a:r>
-              <a:rPr lang="en-US" sz="1050" b="1" u="sng" dirty="0">
+              <a:rPr lang="en-US" sz="1050" b="1" dirty="0">
                 <a:solidFill>
                   <a:srgbClr val="FFFFFF"/>
                 </a:solidFill>
                 <a:latin typeface="Arial" pitchFamily="34" charset="0"/>
                 <a:ea typeface="Arial" pitchFamily="34" charset="-122"/>
                 <a:cs typeface="Arial" pitchFamily="34" charset="-120"/>
-                <a:hlinkClick r:id="rId2">
-                  <a:extLst>
-                    <a:ext uri="{A12FA001-AC4F-418D-AE19-62706E023703}">
-                      <ahyp:hlinkClr xmlns:ahyp="http://schemas.microsoft.com/office/drawing/2018/hyperlinkcolor" val="tx"/>
-                    </a:ext>
-                  </a:extLst>
-                </a:hlinkClick>
               </a:rPr>
               <a:t>gh.io/stacks</a:t>
             </a:r>
@@ -8351,6 +8360,7 @@
       <p:sp>
         <p:nvSpPr>
           <p:cNvPr id="43" name="TextBox 42">
+            <a:hlinkClick r:id="rId3"/>
             <a:extLst>
               <a:ext uri="{FF2B5EF4-FFF2-40B4-BE49-F238E27FC236}">
                 <a16:creationId xmlns:a16="http://schemas.microsoft.com/office/drawing/2014/main" id="{849F82F5-1A90-4E9E-7917-95A0558D5451}"/>
@@ -8432,6 +8442,3328 @@
                 </a:solidFill>
               </a:rPr>
               <a:t>-stacked-prs</a:t>
+            </a:r>
+          </a:p>
+        </p:txBody>
+      </p:sp>
+    </p:spTree>
+  </p:cSld>
+  <p:clrMapOvr>
+    <a:masterClrMapping/>
+  </p:clrMapOvr>
+</p:sld>
+</file>
+
+<file path=ppt/slides/slide6.xml><?xml version="1.0" encoding="utf-8"?>
+<p:sld xmlns:a="http://schemas.openxmlformats.org/drawingml/2006/main" xmlns:p="http://schemas.openxmlformats.org/presentationml/2006/main" xmlns:r="http://schemas.openxmlformats.org/officeDocument/2006/relationships">
+  <p:cSld>
+    <p:bg>
+      <p:bgPr>
+        <a:solidFill>
+          <a:srgbClr val="0D1117"/>
+        </a:solidFill>
+        <a:effectLst/>
+      </p:bgPr>
+    </p:bg>
+    <p:spTree>
+      <p:nvGrpSpPr>
+        <p:cNvPr id="1" name=""/>
+        <p:cNvGrpSpPr/>
+        <p:nvPr/>
+      </p:nvGrpSpPr>
+      <p:grpSpPr/>
+      <p:sp>
+        <p:nvSpPr>
+          <p:cNvPr id="2" name="TextBox 1"/>
+          <p:cNvSpPr txBox="1"/>
+          <p:nvPr/>
+        </p:nvSpPr>
+        <p:spPr>
+          <a:xfrm>
+            <a:off x="484632" y="347472"/>
+            <a:ext cx="6583680" cy="164592"/>
+          </a:xfrm>
+          <a:prstGeom prst="rect">
+            <a:avLst/>
+          </a:prstGeom>
+          <a:noFill/>
+        </p:spPr>
+        <p:txBody>
+          <a:bodyPr wrap="square" lIns="0" rIns="0" tIns="0" bIns="0" anchor="t">
+            <a:noAutofit/>
+          </a:bodyPr>
+          <a:lstStyle/>
+          <a:p>
+            <a:pPr algn="l">
+              <a:lnSpc>
+                <a:spcPct val="100000"/>
+              </a:lnSpc>
+              <a:spcBef>
+                <a:spcPts val="0"/>
+              </a:spcBef>
+              <a:spcAft>
+                <a:spcPts val="0"/>
+              </a:spcAft>
+            </a:pPr>
+            <a:r>
+              <a:rPr sz="850" b="1">
+                <a:solidFill>
+                  <a:srgbClr val="58A6FF"/>
+                </a:solidFill>
+                <a:latin typeface="Arial"/>
+              </a:rPr>
+              <a:t>AGENTIC WORKFLOW</a:t>
+            </a:r>
+          </a:p>
+        </p:txBody>
+      </p:sp>
+      <p:sp>
+        <p:nvSpPr>
+          <p:cNvPr id="3" name="TextBox 2"/>
+          <p:cNvSpPr txBox="1"/>
+          <p:nvPr/>
+        </p:nvSpPr>
+        <p:spPr>
+          <a:xfrm>
+            <a:off x="484632" y="585216"/>
+            <a:ext cx="8001000" cy="384048"/>
+          </a:xfrm>
+          <a:prstGeom prst="rect">
+            <a:avLst/>
+          </a:prstGeom>
+          <a:noFill/>
+        </p:spPr>
+        <p:txBody>
+          <a:bodyPr wrap="square" lIns="0" rIns="0" tIns="0" bIns="0" anchor="t">
+            <a:noAutofit/>
+          </a:bodyPr>
+          <a:lstStyle/>
+          <a:p>
+            <a:pPr algn="l">
+              <a:lnSpc>
+                <a:spcPct val="100000"/>
+              </a:lnSpc>
+              <a:spcBef>
+                <a:spcPts val="0"/>
+              </a:spcBef>
+              <a:spcAft>
+                <a:spcPts val="0"/>
+              </a:spcAft>
+            </a:pPr>
+            <a:r>
+              <a:rPr sz="2700" b="1">
+                <a:solidFill>
+                  <a:srgbClr val="F0F6FC"/>
+                </a:solidFill>
+                <a:latin typeface="Arial"/>
+              </a:rPr>
+              <a:t>From prompt to published stack</a:t>
+            </a:r>
+          </a:p>
+        </p:txBody>
+      </p:sp>
+      <p:sp>
+        <p:nvSpPr>
+          <p:cNvPr id="4" name="TextBox 3"/>
+          <p:cNvSpPr txBox="1"/>
+          <p:nvPr/>
+        </p:nvSpPr>
+        <p:spPr>
+          <a:xfrm>
+            <a:off x="484632" y="1005840"/>
+            <a:ext cx="8092440" cy="256032"/>
+          </a:xfrm>
+          <a:prstGeom prst="rect">
+            <a:avLst/>
+          </a:prstGeom>
+          <a:noFill/>
+        </p:spPr>
+        <p:txBody>
+          <a:bodyPr wrap="square" lIns="0" rIns="0" tIns="0" bIns="0" anchor="t">
+            <a:noAutofit/>
+          </a:bodyPr>
+          <a:lstStyle/>
+          <a:p>
+            <a:pPr algn="l">
+              <a:lnSpc>
+                <a:spcPct val="100000"/>
+              </a:lnSpc>
+              <a:spcBef>
+                <a:spcPts val="0"/>
+              </a:spcBef>
+              <a:spcAft>
+                <a:spcPts val="0"/>
+              </a:spcAft>
+            </a:pPr>
+            <a:r>
+              <a:rPr sz="1150" b="0">
+                <a:solidFill>
+                  <a:srgbClr val="8B949E"/>
+                </a:solidFill>
+                <a:latin typeface="Arial"/>
+              </a:rPr>
+              <a:t>Follow four steps, and stop for human approval before coding or publishing.</a:t>
+            </a:r>
+          </a:p>
+        </p:txBody>
+      </p:sp>
+      <p:sp>
+        <p:nvSpPr>
+          <p:cNvPr id="5" name="Rounded Rectangle 4">
+            <a:hlinkClick r:id="rId2"/>
+          </p:cNvPr>
+          <p:cNvSpPr/>
+          <p:nvPr/>
+        </p:nvSpPr>
+        <p:spPr>
+          <a:xfrm>
+            <a:off x="7479792" y="146304"/>
+            <a:ext cx="1078992" cy="283464"/>
+          </a:xfrm>
+          <a:prstGeom prst="roundRect">
+            <a:avLst>
+              <a:gd name="adj" fmla="val 8000"/>
+            </a:avLst>
+          </a:prstGeom>
+          <a:solidFill>
+            <a:srgbClr val="1F6F37"/>
+          </a:solidFill>
+          <a:ln w="12700">
+            <a:solidFill>
+              <a:srgbClr val="2EA043"/>
+            </a:solidFill>
+          </a:ln>
+        </p:spPr>
+        <p:style>
+          <a:lnRef idx="1">
+            <a:schemeClr val="accent1"/>
+          </a:lnRef>
+          <a:fillRef idx="3">
+            <a:schemeClr val="accent1"/>
+          </a:fillRef>
+          <a:effectRef idx="2">
+            <a:schemeClr val="accent1"/>
+          </a:effectRef>
+          <a:fontRef idx="minor">
+            <a:schemeClr val="lt1"/>
+          </a:fontRef>
+        </p:style>
+        <p:txBody>
+          <a:bodyPr rtlCol="0" anchor="ctr" wrap="square" lIns="0" rIns="0" tIns="0" bIns="0">
+            <a:noAutofit/>
+          </a:bodyPr>
+          <a:lstStyle/>
+          <a:p>
+            <a:pPr algn="ctr"/>
+            <a:r>
+              <a:rPr sz="750" b="1">
+                <a:solidFill>
+                  <a:srgbClr val="FFFFFF"/>
+                </a:solidFill>
+                <a:latin typeface="Arial"/>
+              </a:rPr>
+              <a:t>gh.io/stacks</a:t>
+            </a:r>
+          </a:p>
+        </p:txBody>
+      </p:sp>
+      <p:pic>
+        <p:nvPicPr>
+          <p:cNvPr id="6" name="Picture 5" descr="stack-github-logo.png">
+            <a:hlinkClick r:id="rId4"/>
+          </p:cNvPr>
+          <p:cNvPicPr>
+            <a:picLocks noChangeAspect="1"/>
+          </p:cNvPicPr>
+          <p:nvPr/>
+        </p:nvPicPr>
+        <p:blipFill>
+          <a:blip r:embed="rId3"/>
+          <a:stretch>
+            <a:fillRect/>
+          </a:stretch>
+        </p:blipFill>
+        <p:spPr>
+          <a:xfrm>
+            <a:off x="8668512" y="137160"/>
+            <a:ext cx="256032" cy="256032"/>
+          </a:xfrm>
+          <a:prstGeom prst="rect">
+            <a:avLst/>
+          </a:prstGeom>
+        </p:spPr>
+      </p:pic>
+      <p:sp>
+        <p:nvSpPr>
+          <p:cNvPr id="7" name="Rounded Rectangle 6"/>
+          <p:cNvSpPr/>
+          <p:nvPr/>
+        </p:nvSpPr>
+        <p:spPr>
+          <a:xfrm>
+            <a:off x="484632" y="1444752"/>
+            <a:ext cx="1975104" cy="2670048"/>
+          </a:xfrm>
+          <a:prstGeom prst="roundRect">
+            <a:avLst>
+              <a:gd name="adj" fmla="val 8000"/>
+            </a:avLst>
+          </a:prstGeom>
+          <a:solidFill>
+            <a:srgbClr val="161B22"/>
+          </a:solidFill>
+          <a:ln w="12700">
+            <a:solidFill>
+              <a:srgbClr val="30363D"/>
+            </a:solidFill>
+          </a:ln>
+        </p:spPr>
+        <p:style>
+          <a:lnRef idx="1">
+            <a:schemeClr val="accent1"/>
+          </a:lnRef>
+          <a:fillRef idx="3">
+            <a:schemeClr val="accent1"/>
+          </a:fillRef>
+          <a:effectRef idx="2">
+            <a:schemeClr val="accent1"/>
+          </a:effectRef>
+          <a:fontRef idx="minor">
+            <a:schemeClr val="lt1"/>
+          </a:fontRef>
+        </p:style>
+        <p:txBody>
+          <a:bodyPr rtlCol="0" anchor="ctr"/>
+          <a:lstStyle/>
+          <a:p>
+            <a:pPr algn="ctr"/>
+          </a:p>
+        </p:txBody>
+      </p:sp>
+      <p:sp>
+        <p:nvSpPr>
+          <p:cNvPr id="8" name="Oval 7"/>
+          <p:cNvSpPr/>
+          <p:nvPr/>
+        </p:nvSpPr>
+        <p:spPr>
+          <a:xfrm>
+            <a:off x="630936" y="1618488"/>
+            <a:ext cx="329184" cy="329184"/>
+          </a:xfrm>
+          <a:prstGeom prst="ellipse">
+            <a:avLst/>
+          </a:prstGeom>
+          <a:solidFill>
+            <a:srgbClr val="58A6FF"/>
+          </a:solidFill>
+          <a:ln>
+            <a:noFill/>
+          </a:ln>
+        </p:spPr>
+        <p:style>
+          <a:lnRef idx="1">
+            <a:schemeClr val="accent1"/>
+          </a:lnRef>
+          <a:fillRef idx="3">
+            <a:schemeClr val="accent1"/>
+          </a:fillRef>
+          <a:effectRef idx="2">
+            <a:schemeClr val="accent1"/>
+          </a:effectRef>
+          <a:fontRef idx="minor">
+            <a:schemeClr val="lt1"/>
+          </a:fontRef>
+        </p:style>
+        <p:txBody>
+          <a:bodyPr rtlCol="0" anchor="ctr" wrap="square" lIns="0" rIns="0" tIns="0" bIns="0">
+            <a:noAutofit/>
+          </a:bodyPr>
+          <a:lstStyle/>
+          <a:p>
+            <a:pPr algn="ctr"/>
+            <a:r>
+              <a:rPr sz="900" b="1">
+                <a:solidFill>
+                  <a:srgbClr val="F0F6FC"/>
+                </a:solidFill>
+                <a:latin typeface="Arial"/>
+              </a:rPr>
+              <a:t>1</a:t>
+            </a:r>
+          </a:p>
+        </p:txBody>
+      </p:sp>
+      <p:sp>
+        <p:nvSpPr>
+          <p:cNvPr id="9" name="TextBox 8"/>
+          <p:cNvSpPr txBox="1"/>
+          <p:nvPr/>
+        </p:nvSpPr>
+        <p:spPr>
+          <a:xfrm>
+            <a:off x="1033271" y="1572768"/>
+            <a:ext cx="1298448" cy="384048"/>
+          </a:xfrm>
+          <a:prstGeom prst="rect">
+            <a:avLst/>
+          </a:prstGeom>
+          <a:noFill/>
+        </p:spPr>
+        <p:txBody>
+          <a:bodyPr wrap="square" lIns="0" rIns="0" tIns="0" bIns="0" anchor="t">
+            <a:noAutofit/>
+          </a:bodyPr>
+          <a:lstStyle/>
+          <a:p>
+            <a:pPr algn="l">
+              <a:lnSpc>
+                <a:spcPct val="100000"/>
+              </a:lnSpc>
+              <a:spcBef>
+                <a:spcPts val="0"/>
+              </a:spcBef>
+              <a:spcAft>
+                <a:spcPts val="0"/>
+              </a:spcAft>
+            </a:pPr>
+            <a:r>
+              <a:rPr sz="1180" b="1">
+                <a:solidFill>
+                  <a:srgbClr val="F0F6FC"/>
+                </a:solidFill>
+                <a:latin typeface="Arial"/>
+              </a:rPr>
+              <a:t>Start with context</a:t>
+            </a:r>
+          </a:p>
+        </p:txBody>
+      </p:sp>
+      <p:sp>
+        <p:nvSpPr>
+          <p:cNvPr id="10" name="Rounded Rectangle 9"/>
+          <p:cNvSpPr/>
+          <p:nvPr/>
+        </p:nvSpPr>
+        <p:spPr>
+          <a:xfrm>
+            <a:off x="2551176" y="1444752"/>
+            <a:ext cx="1975104" cy="2670048"/>
+          </a:xfrm>
+          <a:prstGeom prst="roundRect">
+            <a:avLst>
+              <a:gd name="adj" fmla="val 8000"/>
+            </a:avLst>
+          </a:prstGeom>
+          <a:solidFill>
+            <a:srgbClr val="161B22"/>
+          </a:solidFill>
+          <a:ln w="12700">
+            <a:solidFill>
+              <a:srgbClr val="30363D"/>
+            </a:solidFill>
+          </a:ln>
+        </p:spPr>
+        <p:style>
+          <a:lnRef idx="1">
+            <a:schemeClr val="accent1"/>
+          </a:lnRef>
+          <a:fillRef idx="3">
+            <a:schemeClr val="accent1"/>
+          </a:fillRef>
+          <a:effectRef idx="2">
+            <a:schemeClr val="accent1"/>
+          </a:effectRef>
+          <a:fontRef idx="minor">
+            <a:schemeClr val="lt1"/>
+          </a:fontRef>
+        </p:style>
+        <p:txBody>
+          <a:bodyPr rtlCol="0" anchor="ctr"/>
+          <a:lstStyle/>
+          <a:p>
+            <a:pPr algn="ctr"/>
+          </a:p>
+        </p:txBody>
+      </p:sp>
+      <p:sp>
+        <p:nvSpPr>
+          <p:cNvPr id="11" name="Oval 10"/>
+          <p:cNvSpPr/>
+          <p:nvPr/>
+        </p:nvSpPr>
+        <p:spPr>
+          <a:xfrm>
+            <a:off x="2697480" y="1618488"/>
+            <a:ext cx="329184" cy="329184"/>
+          </a:xfrm>
+          <a:prstGeom prst="ellipse">
+            <a:avLst/>
+          </a:prstGeom>
+          <a:solidFill>
+            <a:srgbClr val="58A6FF"/>
+          </a:solidFill>
+          <a:ln>
+            <a:noFill/>
+          </a:ln>
+        </p:spPr>
+        <p:style>
+          <a:lnRef idx="1">
+            <a:schemeClr val="accent1"/>
+          </a:lnRef>
+          <a:fillRef idx="3">
+            <a:schemeClr val="accent1"/>
+          </a:fillRef>
+          <a:effectRef idx="2">
+            <a:schemeClr val="accent1"/>
+          </a:effectRef>
+          <a:fontRef idx="minor">
+            <a:schemeClr val="lt1"/>
+          </a:fontRef>
+        </p:style>
+        <p:txBody>
+          <a:bodyPr rtlCol="0" anchor="ctr" wrap="square" lIns="0" rIns="0" tIns="0" bIns="0">
+            <a:noAutofit/>
+          </a:bodyPr>
+          <a:lstStyle/>
+          <a:p>
+            <a:pPr algn="ctr"/>
+            <a:r>
+              <a:rPr sz="900" b="1">
+                <a:solidFill>
+                  <a:srgbClr val="F0F6FC"/>
+                </a:solidFill>
+                <a:latin typeface="Arial"/>
+              </a:rPr>
+              <a:t>2</a:t>
+            </a:r>
+          </a:p>
+        </p:txBody>
+      </p:sp>
+      <p:sp>
+        <p:nvSpPr>
+          <p:cNvPr id="12" name="TextBox 11"/>
+          <p:cNvSpPr txBox="1"/>
+          <p:nvPr/>
+        </p:nvSpPr>
+        <p:spPr>
+          <a:xfrm>
+            <a:off x="3099816" y="1572768"/>
+            <a:ext cx="1298448" cy="384048"/>
+          </a:xfrm>
+          <a:prstGeom prst="rect">
+            <a:avLst/>
+          </a:prstGeom>
+          <a:noFill/>
+        </p:spPr>
+        <p:txBody>
+          <a:bodyPr wrap="square" lIns="0" rIns="0" tIns="0" bIns="0" anchor="t">
+            <a:noAutofit/>
+          </a:bodyPr>
+          <a:lstStyle/>
+          <a:p>
+            <a:pPr algn="l">
+              <a:lnSpc>
+                <a:spcPct val="100000"/>
+              </a:lnSpc>
+              <a:spcBef>
+                <a:spcPts val="0"/>
+              </a:spcBef>
+              <a:spcAft>
+                <a:spcPts val="0"/>
+              </a:spcAft>
+            </a:pPr>
+            <a:r>
+              <a:rPr sz="1180" b="1">
+                <a:solidFill>
+                  <a:srgbClr val="F0F6FC"/>
+                </a:solidFill>
+                <a:latin typeface="Arial"/>
+              </a:rPr>
+              <a:t>Plan only</a:t>
+            </a:r>
+          </a:p>
+        </p:txBody>
+      </p:sp>
+      <p:sp>
+        <p:nvSpPr>
+          <p:cNvPr id="13" name="Rounded Rectangle 12"/>
+          <p:cNvSpPr/>
+          <p:nvPr/>
+        </p:nvSpPr>
+        <p:spPr>
+          <a:xfrm>
+            <a:off x="4617720" y="1444752"/>
+            <a:ext cx="1975104" cy="2670048"/>
+          </a:xfrm>
+          <a:prstGeom prst="roundRect">
+            <a:avLst>
+              <a:gd name="adj" fmla="val 8000"/>
+            </a:avLst>
+          </a:prstGeom>
+          <a:solidFill>
+            <a:srgbClr val="161B22"/>
+          </a:solidFill>
+          <a:ln w="12700">
+            <a:solidFill>
+              <a:srgbClr val="30363D"/>
+            </a:solidFill>
+          </a:ln>
+        </p:spPr>
+        <p:style>
+          <a:lnRef idx="1">
+            <a:schemeClr val="accent1"/>
+          </a:lnRef>
+          <a:fillRef idx="3">
+            <a:schemeClr val="accent1"/>
+          </a:fillRef>
+          <a:effectRef idx="2">
+            <a:schemeClr val="accent1"/>
+          </a:effectRef>
+          <a:fontRef idx="minor">
+            <a:schemeClr val="lt1"/>
+          </a:fontRef>
+        </p:style>
+        <p:txBody>
+          <a:bodyPr rtlCol="0" anchor="ctr"/>
+          <a:lstStyle/>
+          <a:p>
+            <a:pPr algn="ctr"/>
+          </a:p>
+        </p:txBody>
+      </p:sp>
+      <p:sp>
+        <p:nvSpPr>
+          <p:cNvPr id="14" name="Oval 13"/>
+          <p:cNvSpPr/>
+          <p:nvPr/>
+        </p:nvSpPr>
+        <p:spPr>
+          <a:xfrm>
+            <a:off x="4764024" y="1618488"/>
+            <a:ext cx="329184" cy="329184"/>
+          </a:xfrm>
+          <a:prstGeom prst="ellipse">
+            <a:avLst/>
+          </a:prstGeom>
+          <a:solidFill>
+            <a:srgbClr val="58A6FF"/>
+          </a:solidFill>
+          <a:ln>
+            <a:noFill/>
+          </a:ln>
+        </p:spPr>
+        <p:style>
+          <a:lnRef idx="1">
+            <a:schemeClr val="accent1"/>
+          </a:lnRef>
+          <a:fillRef idx="3">
+            <a:schemeClr val="accent1"/>
+          </a:fillRef>
+          <a:effectRef idx="2">
+            <a:schemeClr val="accent1"/>
+          </a:effectRef>
+          <a:fontRef idx="minor">
+            <a:schemeClr val="lt1"/>
+          </a:fontRef>
+        </p:style>
+        <p:txBody>
+          <a:bodyPr rtlCol="0" anchor="ctr" wrap="square" lIns="0" rIns="0" tIns="0" bIns="0">
+            <a:noAutofit/>
+          </a:bodyPr>
+          <a:lstStyle/>
+          <a:p>
+            <a:pPr algn="ctr"/>
+            <a:r>
+              <a:rPr sz="900" b="1">
+                <a:solidFill>
+                  <a:srgbClr val="F0F6FC"/>
+                </a:solidFill>
+                <a:latin typeface="Arial"/>
+              </a:rPr>
+              <a:t>3</a:t>
+            </a:r>
+          </a:p>
+        </p:txBody>
+      </p:sp>
+      <p:sp>
+        <p:nvSpPr>
+          <p:cNvPr id="15" name="TextBox 14"/>
+          <p:cNvSpPr txBox="1"/>
+          <p:nvPr/>
+        </p:nvSpPr>
+        <p:spPr>
+          <a:xfrm>
+            <a:off x="5166359" y="1572768"/>
+            <a:ext cx="1298448" cy="384048"/>
+          </a:xfrm>
+          <a:prstGeom prst="rect">
+            <a:avLst/>
+          </a:prstGeom>
+          <a:noFill/>
+        </p:spPr>
+        <p:txBody>
+          <a:bodyPr wrap="square" lIns="0" rIns="0" tIns="0" bIns="0" anchor="t">
+            <a:noAutofit/>
+          </a:bodyPr>
+          <a:lstStyle/>
+          <a:p>
+            <a:pPr algn="l">
+              <a:lnSpc>
+                <a:spcPct val="100000"/>
+              </a:lnSpc>
+              <a:spcBef>
+                <a:spcPts val="0"/>
+              </a:spcBef>
+              <a:spcAft>
+                <a:spcPts val="0"/>
+              </a:spcAft>
+            </a:pPr>
+            <a:r>
+              <a:rPr sz="1180" b="1">
+                <a:solidFill>
+                  <a:srgbClr val="F0F6FC"/>
+                </a:solidFill>
+                <a:latin typeface="Arial"/>
+              </a:rPr>
+              <a:t>Build each layer</a:t>
+            </a:r>
+          </a:p>
+        </p:txBody>
+      </p:sp>
+      <p:sp>
+        <p:nvSpPr>
+          <p:cNvPr id="16" name="Rounded Rectangle 15"/>
+          <p:cNvSpPr/>
+          <p:nvPr/>
+        </p:nvSpPr>
+        <p:spPr>
+          <a:xfrm>
+            <a:off x="6684264" y="1444752"/>
+            <a:ext cx="1975104" cy="2670048"/>
+          </a:xfrm>
+          <a:prstGeom prst="roundRect">
+            <a:avLst>
+              <a:gd name="adj" fmla="val 8000"/>
+            </a:avLst>
+          </a:prstGeom>
+          <a:solidFill>
+            <a:srgbClr val="161B22"/>
+          </a:solidFill>
+          <a:ln w="12700">
+            <a:solidFill>
+              <a:srgbClr val="30363D"/>
+            </a:solidFill>
+          </a:ln>
+        </p:spPr>
+        <p:style>
+          <a:lnRef idx="1">
+            <a:schemeClr val="accent1"/>
+          </a:lnRef>
+          <a:fillRef idx="3">
+            <a:schemeClr val="accent1"/>
+          </a:fillRef>
+          <a:effectRef idx="2">
+            <a:schemeClr val="accent1"/>
+          </a:effectRef>
+          <a:fontRef idx="minor">
+            <a:schemeClr val="lt1"/>
+          </a:fontRef>
+        </p:style>
+        <p:txBody>
+          <a:bodyPr rtlCol="0" anchor="ctr"/>
+          <a:lstStyle/>
+          <a:p>
+            <a:pPr algn="ctr"/>
+          </a:p>
+        </p:txBody>
+      </p:sp>
+      <p:sp>
+        <p:nvSpPr>
+          <p:cNvPr id="17" name="Oval 16"/>
+          <p:cNvSpPr/>
+          <p:nvPr/>
+        </p:nvSpPr>
+        <p:spPr>
+          <a:xfrm>
+            <a:off x="6830568" y="1618488"/>
+            <a:ext cx="329184" cy="329184"/>
+          </a:xfrm>
+          <a:prstGeom prst="ellipse">
+            <a:avLst/>
+          </a:prstGeom>
+          <a:solidFill>
+            <a:srgbClr val="58A6FF"/>
+          </a:solidFill>
+          <a:ln>
+            <a:noFill/>
+          </a:ln>
+        </p:spPr>
+        <p:style>
+          <a:lnRef idx="1">
+            <a:schemeClr val="accent1"/>
+          </a:lnRef>
+          <a:fillRef idx="3">
+            <a:schemeClr val="accent1"/>
+          </a:fillRef>
+          <a:effectRef idx="2">
+            <a:schemeClr val="accent1"/>
+          </a:effectRef>
+          <a:fontRef idx="minor">
+            <a:schemeClr val="lt1"/>
+          </a:fontRef>
+        </p:style>
+        <p:txBody>
+          <a:bodyPr rtlCol="0" anchor="ctr" wrap="square" lIns="0" rIns="0" tIns="0" bIns="0">
+            <a:noAutofit/>
+          </a:bodyPr>
+          <a:lstStyle/>
+          <a:p>
+            <a:pPr algn="ctr"/>
+            <a:r>
+              <a:rPr sz="900" b="1">
+                <a:solidFill>
+                  <a:srgbClr val="F0F6FC"/>
+                </a:solidFill>
+                <a:latin typeface="Arial"/>
+              </a:rPr>
+              <a:t>4</a:t>
+            </a:r>
+          </a:p>
+        </p:txBody>
+      </p:sp>
+      <p:sp>
+        <p:nvSpPr>
+          <p:cNvPr id="18" name="TextBox 17"/>
+          <p:cNvSpPr txBox="1"/>
+          <p:nvPr/>
+        </p:nvSpPr>
+        <p:spPr>
+          <a:xfrm>
+            <a:off x="7232903" y="1572768"/>
+            <a:ext cx="1298448" cy="384048"/>
+          </a:xfrm>
+          <a:prstGeom prst="rect">
+            <a:avLst/>
+          </a:prstGeom>
+          <a:noFill/>
+        </p:spPr>
+        <p:txBody>
+          <a:bodyPr wrap="square" lIns="0" rIns="0" tIns="0" bIns="0" anchor="t">
+            <a:noAutofit/>
+          </a:bodyPr>
+          <a:lstStyle/>
+          <a:p>
+            <a:pPr algn="l">
+              <a:lnSpc>
+                <a:spcPct val="100000"/>
+              </a:lnSpc>
+              <a:spcBef>
+                <a:spcPts val="0"/>
+              </a:spcBef>
+              <a:spcAft>
+                <a:spcPts val="0"/>
+              </a:spcAft>
+            </a:pPr>
+            <a:r>
+              <a:rPr sz="1180" b="1">
+                <a:solidFill>
+                  <a:srgbClr val="F0F6FC"/>
+                </a:solidFill>
+                <a:latin typeface="Arial"/>
+              </a:rPr>
+              <a:t>Verify + publish</a:t>
+            </a:r>
+          </a:p>
+        </p:txBody>
+      </p:sp>
+      <p:sp>
+        <p:nvSpPr>
+          <p:cNvPr id="19" name="TextBox 18"/>
+          <p:cNvSpPr txBox="1"/>
+          <p:nvPr/>
+        </p:nvSpPr>
+        <p:spPr>
+          <a:xfrm>
+            <a:off x="640080" y="2103120"/>
+            <a:ext cx="1664208" cy="192024"/>
+          </a:xfrm>
+          <a:prstGeom prst="rect">
+            <a:avLst/>
+          </a:prstGeom>
+          <a:noFill/>
+        </p:spPr>
+        <p:txBody>
+          <a:bodyPr wrap="square" lIns="0" rIns="0" tIns="0" bIns="0" anchor="t">
+            <a:noAutofit/>
+          </a:bodyPr>
+          <a:lstStyle/>
+          <a:p>
+            <a:pPr algn="l">
+              <a:lnSpc>
+                <a:spcPct val="100000"/>
+              </a:lnSpc>
+              <a:spcBef>
+                <a:spcPts val="0"/>
+              </a:spcBef>
+              <a:spcAft>
+                <a:spcPts val="0"/>
+              </a:spcAft>
+            </a:pPr>
+            <a:r>
+              <a:rPr sz="869" b="0">
+                <a:solidFill>
+                  <a:srgbClr val="8B949E"/>
+                </a:solidFill>
+                <a:latin typeface="Arial"/>
+              </a:rPr>
+              <a:t>•  Launch from the repository root</a:t>
+            </a:r>
+          </a:p>
+        </p:txBody>
+      </p:sp>
+      <p:sp>
+        <p:nvSpPr>
+          <p:cNvPr id="20" name="TextBox 19"/>
+          <p:cNvSpPr txBox="1"/>
+          <p:nvPr/>
+        </p:nvSpPr>
+        <p:spPr>
+          <a:xfrm>
+            <a:off x="640080" y="2368296"/>
+            <a:ext cx="1664208" cy="192024"/>
+          </a:xfrm>
+          <a:prstGeom prst="rect">
+            <a:avLst/>
+          </a:prstGeom>
+          <a:noFill/>
+        </p:spPr>
+        <p:txBody>
+          <a:bodyPr wrap="square" lIns="0" rIns="0" tIns="0" bIns="0" anchor="t">
+            <a:noAutofit/>
+          </a:bodyPr>
+          <a:lstStyle/>
+          <a:p>
+            <a:pPr algn="l">
+              <a:lnSpc>
+                <a:spcPct val="100000"/>
+              </a:lnSpc>
+              <a:spcBef>
+                <a:spcPts val="0"/>
+              </a:spcBef>
+              <a:spcAft>
+                <a:spcPts val="0"/>
+              </a:spcAft>
+            </a:pPr>
+            <a:r>
+              <a:rPr sz="869" b="0">
+                <a:solidFill>
+                  <a:srgbClr val="8B949E"/>
+                </a:solidFill>
+                <a:latin typeface="Arial"/>
+              </a:rPr>
+              <a:t>•  Confirm AGENTS.md is loaded</a:t>
+            </a:r>
+          </a:p>
+        </p:txBody>
+      </p:sp>
+      <p:sp>
+        <p:nvSpPr>
+          <p:cNvPr id="21" name="TextBox 20"/>
+          <p:cNvSpPr txBox="1"/>
+          <p:nvPr/>
+        </p:nvSpPr>
+        <p:spPr>
+          <a:xfrm>
+            <a:off x="640080" y="2633472"/>
+            <a:ext cx="1664208" cy="192024"/>
+          </a:xfrm>
+          <a:prstGeom prst="rect">
+            <a:avLst/>
+          </a:prstGeom>
+          <a:noFill/>
+        </p:spPr>
+        <p:txBody>
+          <a:bodyPr wrap="square" lIns="0" rIns="0" tIns="0" bIns="0" anchor="t">
+            <a:noAutofit/>
+          </a:bodyPr>
+          <a:lstStyle/>
+          <a:p>
+            <a:pPr algn="l">
+              <a:lnSpc>
+                <a:spcPct val="100000"/>
+              </a:lnSpc>
+              <a:spcBef>
+                <a:spcPts val="0"/>
+              </a:spcBef>
+              <a:spcAft>
+                <a:spcPts val="0"/>
+              </a:spcAft>
+            </a:pPr>
+            <a:r>
+              <a:rPr sz="869" b="0">
+                <a:solidFill>
+                  <a:srgbClr val="8B949E"/>
+                </a:solidFill>
+                <a:latin typeface="Arial"/>
+              </a:rPr>
+              <a:t>•  Confirm the gh-stack skill</a:t>
+            </a:r>
+          </a:p>
+        </p:txBody>
+      </p:sp>
+      <p:sp>
+        <p:nvSpPr>
+          <p:cNvPr id="22" name="Rounded Rectangle 21"/>
+          <p:cNvSpPr/>
+          <p:nvPr/>
+        </p:nvSpPr>
+        <p:spPr>
+          <a:xfrm>
+            <a:off x="630936" y="3072384"/>
+            <a:ext cx="1682496" cy="566928"/>
+          </a:xfrm>
+          <a:prstGeom prst="roundRect">
+            <a:avLst>
+              <a:gd name="adj" fmla="val 8000"/>
+            </a:avLst>
+          </a:prstGeom>
+          <a:solidFill>
+            <a:srgbClr val="010409"/>
+          </a:solidFill>
+          <a:ln w="12700">
+            <a:solidFill>
+              <a:srgbClr val="30363D"/>
+            </a:solidFill>
+          </a:ln>
+        </p:spPr>
+        <p:style>
+          <a:lnRef idx="1">
+            <a:schemeClr val="accent1"/>
+          </a:lnRef>
+          <a:fillRef idx="3">
+            <a:schemeClr val="accent1"/>
+          </a:fillRef>
+          <a:effectRef idx="2">
+            <a:schemeClr val="accent1"/>
+          </a:effectRef>
+          <a:fontRef idx="minor">
+            <a:schemeClr val="lt1"/>
+          </a:fontRef>
+        </p:style>
+        <p:txBody>
+          <a:bodyPr rtlCol="0" anchor="t" wrap="square" lIns="100584" rIns="100584" tIns="73152">
+            <a:noAutofit/>
+          </a:bodyPr>
+          <a:lstStyle/>
+          <a:p>
+            <a:pPr algn="l">
+              <a:lnSpc>
+                <a:spcPct val="92000"/>
+              </a:lnSpc>
+              <a:spcBef>
+                <a:spcPts val="0"/>
+              </a:spcBef>
+              <a:spcAft>
+                <a:spcPts val="0"/>
+              </a:spcAft>
+            </a:pPr>
+            <a:r>
+              <a:rPr sz="780">
+                <a:solidFill>
+                  <a:srgbClr val="58A6FF"/>
+                </a:solidFill>
+                <a:latin typeface="Courier New"/>
+              </a:rPr>
+              <a:t>copilot skill list</a:t>
+            </a:r>
+          </a:p>
+        </p:txBody>
+      </p:sp>
+      <p:sp>
+        <p:nvSpPr>
+          <p:cNvPr id="23" name="Rounded Rectangle 22"/>
+          <p:cNvSpPr/>
+          <p:nvPr/>
+        </p:nvSpPr>
+        <p:spPr>
+          <a:xfrm>
+            <a:off x="630936" y="3685032"/>
+            <a:ext cx="1682496" cy="274320"/>
+          </a:xfrm>
+          <a:prstGeom prst="roundRect">
+            <a:avLst>
+              <a:gd name="adj" fmla="val 8000"/>
+            </a:avLst>
+          </a:prstGeom>
+          <a:solidFill>
+            <a:srgbClr val="0F2D1A"/>
+          </a:solidFill>
+          <a:ln w="12700">
+            <a:solidFill>
+              <a:srgbClr val="1F6F37"/>
+            </a:solidFill>
+          </a:ln>
+        </p:spPr>
+        <p:style>
+          <a:lnRef idx="1">
+            <a:schemeClr val="accent1"/>
+          </a:lnRef>
+          <a:fillRef idx="3">
+            <a:schemeClr val="accent1"/>
+          </a:fillRef>
+          <a:effectRef idx="2">
+            <a:schemeClr val="accent1"/>
+          </a:effectRef>
+          <a:fontRef idx="minor">
+            <a:schemeClr val="lt1"/>
+          </a:fontRef>
+        </p:style>
+        <p:txBody>
+          <a:bodyPr rtlCol="0" anchor="ctr" wrap="square" lIns="0" rIns="0" tIns="0" bIns="0">
+            <a:noAutofit/>
+          </a:bodyPr>
+          <a:lstStyle/>
+          <a:p>
+            <a:pPr algn="ctr"/>
+            <a:r>
+              <a:rPr sz="760" b="1">
+                <a:solidFill>
+                  <a:srgbClr val="79C0FF"/>
+                </a:solidFill>
+                <a:latin typeface="Arial"/>
+              </a:rPr>
+              <a:t>Ask: </a:t>
+            </a:r>
+            <a:r>
+              <a:rPr sz="760" b="1">
+                <a:solidFill>
+                  <a:srgbClr val="F0F6FC"/>
+                </a:solidFill>
+                <a:latin typeface="Arial"/>
+              </a:rPr>
+              <a:t>"Summarize AGENTS.md."</a:t>
+            </a:r>
+          </a:p>
+        </p:txBody>
+      </p:sp>
+      <p:sp>
+        <p:nvSpPr>
+          <p:cNvPr id="24" name="TextBox 23"/>
+          <p:cNvSpPr txBox="1"/>
+          <p:nvPr/>
+        </p:nvSpPr>
+        <p:spPr>
+          <a:xfrm>
+            <a:off x="2706624" y="2103120"/>
+            <a:ext cx="1664208" cy="192024"/>
+          </a:xfrm>
+          <a:prstGeom prst="rect">
+            <a:avLst/>
+          </a:prstGeom>
+          <a:noFill/>
+        </p:spPr>
+        <p:txBody>
+          <a:bodyPr wrap="square" lIns="0" rIns="0" tIns="0" bIns="0" anchor="t">
+            <a:noAutofit/>
+          </a:bodyPr>
+          <a:lstStyle/>
+          <a:p>
+            <a:pPr algn="l">
+              <a:lnSpc>
+                <a:spcPct val="100000"/>
+              </a:lnSpc>
+              <a:spcBef>
+                <a:spcPts val="0"/>
+              </a:spcBef>
+              <a:spcAft>
+                <a:spcPts val="0"/>
+              </a:spcAft>
+            </a:pPr>
+            <a:r>
+              <a:rPr sz="869" b="0">
+                <a:solidFill>
+                  <a:srgbClr val="8B949E"/>
+                </a:solidFill>
+                <a:latin typeface="Arial"/>
+              </a:rPr>
+              <a:t>•  Ask for trunk + branch order</a:t>
+            </a:r>
+          </a:p>
+        </p:txBody>
+      </p:sp>
+      <p:sp>
+        <p:nvSpPr>
+          <p:cNvPr id="25" name="TextBox 24"/>
+          <p:cNvSpPr txBox="1"/>
+          <p:nvPr/>
+        </p:nvSpPr>
+        <p:spPr>
+          <a:xfrm>
+            <a:off x="2706624" y="2368296"/>
+            <a:ext cx="1664208" cy="192024"/>
+          </a:xfrm>
+          <a:prstGeom prst="rect">
+            <a:avLst/>
+          </a:prstGeom>
+          <a:noFill/>
+        </p:spPr>
+        <p:txBody>
+          <a:bodyPr wrap="square" lIns="0" rIns="0" tIns="0" bIns="0" anchor="t">
+            <a:noAutofit/>
+          </a:bodyPr>
+          <a:lstStyle/>
+          <a:p>
+            <a:pPr algn="l">
+              <a:lnSpc>
+                <a:spcPct val="100000"/>
+              </a:lnSpc>
+              <a:spcBef>
+                <a:spcPts val="0"/>
+              </a:spcBef>
+              <a:spcAft>
+                <a:spcPts val="0"/>
+              </a:spcAft>
+            </a:pPr>
+            <a:r>
+              <a:rPr sz="869" b="0">
+                <a:solidFill>
+                  <a:srgbClr val="8B949E"/>
+                </a:solidFill>
+                <a:latin typeface="Arial"/>
+              </a:rPr>
+              <a:t>•  Define responsibility + tests</a:t>
+            </a:r>
+          </a:p>
+        </p:txBody>
+      </p:sp>
+      <p:sp>
+        <p:nvSpPr>
+          <p:cNvPr id="26" name="TextBox 25"/>
+          <p:cNvSpPr txBox="1"/>
+          <p:nvPr/>
+        </p:nvSpPr>
+        <p:spPr>
+          <a:xfrm>
+            <a:off x="2706624" y="2633472"/>
+            <a:ext cx="1664208" cy="192024"/>
+          </a:xfrm>
+          <a:prstGeom prst="rect">
+            <a:avLst/>
+          </a:prstGeom>
+          <a:noFill/>
+        </p:spPr>
+        <p:txBody>
+          <a:bodyPr wrap="square" lIns="0" rIns="0" tIns="0" bIns="0" anchor="t">
+            <a:noAutofit/>
+          </a:bodyPr>
+          <a:lstStyle/>
+          <a:p>
+            <a:pPr algn="l">
+              <a:lnSpc>
+                <a:spcPct val="100000"/>
+              </a:lnSpc>
+              <a:spcBef>
+                <a:spcPts val="0"/>
+              </a:spcBef>
+              <a:spcAft>
+                <a:spcPts val="0"/>
+              </a:spcAft>
+            </a:pPr>
+            <a:r>
+              <a:rPr sz="869" b="0">
+                <a:solidFill>
+                  <a:srgbClr val="8B949E"/>
+                </a:solidFill>
+                <a:latin typeface="Arial"/>
+              </a:rPr>
+              <a:t>•  Do not modify files</a:t>
+            </a:r>
+          </a:p>
+        </p:txBody>
+      </p:sp>
+      <p:sp>
+        <p:nvSpPr>
+          <p:cNvPr id="27" name="Rounded Rectangle 26"/>
+          <p:cNvSpPr/>
+          <p:nvPr/>
+        </p:nvSpPr>
+        <p:spPr>
+          <a:xfrm>
+            <a:off x="2697480" y="3108960"/>
+            <a:ext cx="1682496" cy="658368"/>
+          </a:xfrm>
+          <a:prstGeom prst="roundRect">
+            <a:avLst>
+              <a:gd name="adj" fmla="val 8000"/>
+            </a:avLst>
+          </a:prstGeom>
+          <a:solidFill>
+            <a:srgbClr val="0F2D1A"/>
+          </a:solidFill>
+          <a:ln w="12700">
+            <a:solidFill>
+              <a:srgbClr val="1F6F37"/>
+            </a:solidFill>
+          </a:ln>
+        </p:spPr>
+        <p:style>
+          <a:lnRef idx="1">
+            <a:schemeClr val="accent1"/>
+          </a:lnRef>
+          <a:fillRef idx="3">
+            <a:schemeClr val="accent1"/>
+          </a:fillRef>
+          <a:effectRef idx="2">
+            <a:schemeClr val="accent1"/>
+          </a:effectRef>
+          <a:fontRef idx="minor">
+            <a:schemeClr val="lt1"/>
+          </a:fontRef>
+        </p:style>
+        <p:txBody>
+          <a:bodyPr rtlCol="0" anchor="t" wrap="square" tIns="73152">
+            <a:noAutofit/>
+          </a:bodyPr>
+          <a:lstStyle/>
+          <a:p>
+            <a:pPr algn="ctr">
+              <a:lnSpc>
+                <a:spcPct val="95000"/>
+              </a:lnSpc>
+              <a:spcBef>
+                <a:spcPts val="0"/>
+              </a:spcBef>
+              <a:spcAft>
+                <a:spcPts val="0"/>
+              </a:spcAft>
+            </a:pPr>
+            <a:r>
+              <a:rPr sz="810">
+                <a:solidFill>
+                  <a:srgbClr val="F0F6FC"/>
+                </a:solidFill>
+                <a:latin typeface="Arial"/>
+              </a:rPr>
+              <a:t>"Plan the stack. Wait for approval before coding."</a:t>
+            </a:r>
+          </a:p>
+        </p:txBody>
+      </p:sp>
+      <p:sp>
+        <p:nvSpPr>
+          <p:cNvPr id="28" name="TextBox 27"/>
+          <p:cNvSpPr txBox="1"/>
+          <p:nvPr/>
+        </p:nvSpPr>
+        <p:spPr>
+          <a:xfrm>
+            <a:off x="4773168" y="2103120"/>
+            <a:ext cx="1664208" cy="192024"/>
+          </a:xfrm>
+          <a:prstGeom prst="rect">
+            <a:avLst/>
+          </a:prstGeom>
+          <a:noFill/>
+        </p:spPr>
+        <p:txBody>
+          <a:bodyPr wrap="square" lIns="0" rIns="0" tIns="0" bIns="0" anchor="t">
+            <a:noAutofit/>
+          </a:bodyPr>
+          <a:lstStyle/>
+          <a:p>
+            <a:pPr algn="l">
+              <a:lnSpc>
+                <a:spcPct val="100000"/>
+              </a:lnSpc>
+              <a:spcBef>
+                <a:spcPts val="0"/>
+              </a:spcBef>
+              <a:spcAft>
+                <a:spcPts val="0"/>
+              </a:spcAft>
+            </a:pPr>
+            <a:r>
+              <a:rPr sz="869" b="0">
+                <a:solidFill>
+                  <a:srgbClr val="8B949E"/>
+                </a:solidFill>
+                <a:latin typeface="Arial"/>
+              </a:rPr>
+              <a:t>•  Create the approved branch</a:t>
+            </a:r>
+          </a:p>
+        </p:txBody>
+      </p:sp>
+      <p:sp>
+        <p:nvSpPr>
+          <p:cNvPr id="29" name="TextBox 28"/>
+          <p:cNvSpPr txBox="1"/>
+          <p:nvPr/>
+        </p:nvSpPr>
+        <p:spPr>
+          <a:xfrm>
+            <a:off x="4773168" y="2368296"/>
+            <a:ext cx="1664208" cy="192024"/>
+          </a:xfrm>
+          <a:prstGeom prst="rect">
+            <a:avLst/>
+          </a:prstGeom>
+          <a:noFill/>
+        </p:spPr>
+        <p:txBody>
+          <a:bodyPr wrap="square" lIns="0" rIns="0" tIns="0" bIns="0" anchor="t">
+            <a:noAutofit/>
+          </a:bodyPr>
+          <a:lstStyle/>
+          <a:p>
+            <a:pPr algn="l">
+              <a:lnSpc>
+                <a:spcPct val="100000"/>
+              </a:lnSpc>
+              <a:spcBef>
+                <a:spcPts val="0"/>
+              </a:spcBef>
+              <a:spcAft>
+                <a:spcPts val="0"/>
+              </a:spcAft>
+            </a:pPr>
+            <a:r>
+              <a:rPr sz="869" b="0">
+                <a:solidFill>
+                  <a:srgbClr val="8B949E"/>
+                </a:solidFill>
+                <a:latin typeface="Arial"/>
+              </a:rPr>
+              <a:t>•  Implement behavior + tests</a:t>
+            </a:r>
+          </a:p>
+        </p:txBody>
+      </p:sp>
+      <p:sp>
+        <p:nvSpPr>
+          <p:cNvPr id="30" name="TextBox 29"/>
+          <p:cNvSpPr txBox="1"/>
+          <p:nvPr/>
+        </p:nvSpPr>
+        <p:spPr>
+          <a:xfrm>
+            <a:off x="4773168" y="2633472"/>
+            <a:ext cx="1664208" cy="192024"/>
+          </a:xfrm>
+          <a:prstGeom prst="rect">
+            <a:avLst/>
+          </a:prstGeom>
+          <a:noFill/>
+        </p:spPr>
+        <p:txBody>
+          <a:bodyPr wrap="square" lIns="0" rIns="0" tIns="0" bIns="0" anchor="t">
+            <a:noAutofit/>
+          </a:bodyPr>
+          <a:lstStyle/>
+          <a:p>
+            <a:pPr algn="l">
+              <a:lnSpc>
+                <a:spcPct val="100000"/>
+              </a:lnSpc>
+              <a:spcBef>
+                <a:spcPts val="0"/>
+              </a:spcBef>
+              <a:spcAft>
+                <a:spcPts val="0"/>
+              </a:spcAft>
+            </a:pPr>
+            <a:r>
+              <a:rPr sz="869" b="0">
+                <a:solidFill>
+                  <a:srgbClr val="8B949E"/>
+                </a:solidFill>
+                <a:latin typeface="Arial"/>
+              </a:rPr>
+              <a:t>•  Run tests + inspect parent diff</a:t>
+            </a:r>
+          </a:p>
+        </p:txBody>
+      </p:sp>
+      <p:sp>
+        <p:nvSpPr>
+          <p:cNvPr id="31" name="TextBox 30"/>
+          <p:cNvSpPr txBox="1"/>
+          <p:nvPr/>
+        </p:nvSpPr>
+        <p:spPr>
+          <a:xfrm>
+            <a:off x="4773168" y="2898648"/>
+            <a:ext cx="1664208" cy="192024"/>
+          </a:xfrm>
+          <a:prstGeom prst="rect">
+            <a:avLst/>
+          </a:prstGeom>
+          <a:noFill/>
+        </p:spPr>
+        <p:txBody>
+          <a:bodyPr wrap="square" lIns="0" rIns="0" tIns="0" bIns="0" anchor="t">
+            <a:noAutofit/>
+          </a:bodyPr>
+          <a:lstStyle/>
+          <a:p>
+            <a:pPr algn="l">
+              <a:lnSpc>
+                <a:spcPct val="100000"/>
+              </a:lnSpc>
+              <a:spcBef>
+                <a:spcPts val="0"/>
+              </a:spcBef>
+              <a:spcAft>
+                <a:spcPts val="0"/>
+              </a:spcAft>
+            </a:pPr>
+            <a:r>
+              <a:rPr sz="869" b="0">
+                <a:solidFill>
+                  <a:srgbClr val="8B949E"/>
+                </a:solidFill>
+                <a:latin typeface="Arial"/>
+              </a:rPr>
+              <a:t>•  Commit locally, then stop</a:t>
+            </a:r>
+          </a:p>
+        </p:txBody>
+      </p:sp>
+      <p:sp>
+        <p:nvSpPr>
+          <p:cNvPr id="32" name="Rounded Rectangle 31"/>
+          <p:cNvSpPr/>
+          <p:nvPr/>
+        </p:nvSpPr>
+        <p:spPr>
+          <a:xfrm>
+            <a:off x="4764024" y="3401568"/>
+            <a:ext cx="1682496" cy="356616"/>
+          </a:xfrm>
+          <a:prstGeom prst="roundRect">
+            <a:avLst>
+              <a:gd name="adj" fmla="val 8000"/>
+            </a:avLst>
+          </a:prstGeom>
+          <a:solidFill>
+            <a:srgbClr val="0F2D1A"/>
+          </a:solidFill>
+          <a:ln w="12700">
+            <a:solidFill>
+              <a:srgbClr val="1F6F37"/>
+            </a:solidFill>
+          </a:ln>
+        </p:spPr>
+        <p:style>
+          <a:lnRef idx="1">
+            <a:schemeClr val="accent1"/>
+          </a:lnRef>
+          <a:fillRef idx="3">
+            <a:schemeClr val="accent1"/>
+          </a:fillRef>
+          <a:effectRef idx="2">
+            <a:schemeClr val="accent1"/>
+          </a:effectRef>
+          <a:fontRef idx="minor">
+            <a:schemeClr val="lt1"/>
+          </a:fontRef>
+        </p:style>
+        <p:txBody>
+          <a:bodyPr rtlCol="0" anchor="ctr" wrap="square" lIns="0" rIns="0" tIns="0" bIns="0">
+            <a:noAutofit/>
+          </a:bodyPr>
+          <a:lstStyle/>
+          <a:p>
+            <a:pPr algn="ctr"/>
+            <a:r>
+              <a:rPr sz="850" b="1">
+                <a:solidFill>
+                  <a:srgbClr val="79C0FF"/>
+                </a:solidFill>
+                <a:latin typeface="Arial"/>
+              </a:rPr>
+              <a:t>Repeat bottom-to-top</a:t>
+            </a:r>
+          </a:p>
+        </p:txBody>
+      </p:sp>
+      <p:sp>
+        <p:nvSpPr>
+          <p:cNvPr id="33" name="TextBox 32"/>
+          <p:cNvSpPr txBox="1"/>
+          <p:nvPr/>
+        </p:nvSpPr>
+        <p:spPr>
+          <a:xfrm>
+            <a:off x="6839712" y="2103120"/>
+            <a:ext cx="1664208" cy="192024"/>
+          </a:xfrm>
+          <a:prstGeom prst="rect">
+            <a:avLst/>
+          </a:prstGeom>
+          <a:noFill/>
+        </p:spPr>
+        <p:txBody>
+          <a:bodyPr wrap="square" lIns="0" rIns="0" tIns="0" bIns="0" anchor="t">
+            <a:noAutofit/>
+          </a:bodyPr>
+          <a:lstStyle/>
+          <a:p>
+            <a:pPr algn="l">
+              <a:lnSpc>
+                <a:spcPct val="100000"/>
+              </a:lnSpc>
+              <a:spcBef>
+                <a:spcPts val="0"/>
+              </a:spcBef>
+              <a:spcAft>
+                <a:spcPts val="0"/>
+              </a:spcAft>
+            </a:pPr>
+            <a:r>
+              <a:rPr sz="869" b="0">
+                <a:solidFill>
+                  <a:srgbClr val="8B949E"/>
+                </a:solidFill>
+                <a:latin typeface="Arial"/>
+              </a:rPr>
+              <a:t>•  Return stack state + ancestry</a:t>
+            </a:r>
+          </a:p>
+        </p:txBody>
+      </p:sp>
+      <p:sp>
+        <p:nvSpPr>
+          <p:cNvPr id="34" name="TextBox 33"/>
+          <p:cNvSpPr txBox="1"/>
+          <p:nvPr/>
+        </p:nvSpPr>
+        <p:spPr>
+          <a:xfrm>
+            <a:off x="6839712" y="2368296"/>
+            <a:ext cx="1664208" cy="192024"/>
+          </a:xfrm>
+          <a:prstGeom prst="rect">
+            <a:avLst/>
+          </a:prstGeom>
+          <a:noFill/>
+        </p:spPr>
+        <p:txBody>
+          <a:bodyPr wrap="square" lIns="0" rIns="0" tIns="0" bIns="0" anchor="t">
+            <a:noAutofit/>
+          </a:bodyPr>
+          <a:lstStyle/>
+          <a:p>
+            <a:pPr algn="l">
+              <a:lnSpc>
+                <a:spcPct val="100000"/>
+              </a:lnSpc>
+              <a:spcBef>
+                <a:spcPts val="0"/>
+              </a:spcBef>
+              <a:spcAft>
+                <a:spcPts val="0"/>
+              </a:spcAft>
+            </a:pPr>
+            <a:r>
+              <a:rPr sz="869" b="0">
+                <a:solidFill>
+                  <a:srgbClr val="8B949E"/>
+                </a:solidFill>
+                <a:latin typeface="Arial"/>
+              </a:rPr>
+              <a:t>•  Return per-layer diffs + tests</a:t>
+            </a:r>
+          </a:p>
+        </p:txBody>
+      </p:sp>
+      <p:sp>
+        <p:nvSpPr>
+          <p:cNvPr id="35" name="TextBox 34"/>
+          <p:cNvSpPr txBox="1"/>
+          <p:nvPr/>
+        </p:nvSpPr>
+        <p:spPr>
+          <a:xfrm>
+            <a:off x="6839712" y="2633472"/>
+            <a:ext cx="1664208" cy="192024"/>
+          </a:xfrm>
+          <a:prstGeom prst="rect">
+            <a:avLst/>
+          </a:prstGeom>
+          <a:noFill/>
+        </p:spPr>
+        <p:txBody>
+          <a:bodyPr wrap="square" lIns="0" rIns="0" tIns="0" bIns="0" anchor="t">
+            <a:noAutofit/>
+          </a:bodyPr>
+          <a:lstStyle/>
+          <a:p>
+            <a:pPr algn="l">
+              <a:lnSpc>
+                <a:spcPct val="100000"/>
+              </a:lnSpc>
+              <a:spcBef>
+                <a:spcPts val="0"/>
+              </a:spcBef>
+              <a:spcAft>
+                <a:spcPts val="0"/>
+              </a:spcAft>
+            </a:pPr>
+            <a:r>
+              <a:rPr sz="869" b="0">
+                <a:solidFill>
+                  <a:srgbClr val="8B949E"/>
+                </a:solidFill>
+                <a:latin typeface="Arial"/>
+              </a:rPr>
+              <a:t>•  Get approval for remote actions</a:t>
+            </a:r>
+          </a:p>
+        </p:txBody>
+      </p:sp>
+      <p:sp>
+        <p:nvSpPr>
+          <p:cNvPr id="36" name="TextBox 35"/>
+          <p:cNvSpPr txBox="1"/>
+          <p:nvPr/>
+        </p:nvSpPr>
+        <p:spPr>
+          <a:xfrm>
+            <a:off x="6839712" y="2898648"/>
+            <a:ext cx="1664208" cy="192024"/>
+          </a:xfrm>
+          <a:prstGeom prst="rect">
+            <a:avLst/>
+          </a:prstGeom>
+          <a:noFill/>
+        </p:spPr>
+        <p:txBody>
+          <a:bodyPr wrap="square" lIns="0" rIns="0" tIns="0" bIns="0" anchor="t">
+            <a:noAutofit/>
+          </a:bodyPr>
+          <a:lstStyle/>
+          <a:p>
+            <a:pPr algn="l">
+              <a:lnSpc>
+                <a:spcPct val="100000"/>
+              </a:lnSpc>
+              <a:spcBef>
+                <a:spcPts val="0"/>
+              </a:spcBef>
+              <a:spcAft>
+                <a:spcPts val="0"/>
+              </a:spcAft>
+            </a:pPr>
+            <a:r>
+              <a:rPr sz="869" b="0">
+                <a:solidFill>
+                  <a:srgbClr val="8B949E"/>
+                </a:solidFill>
+                <a:latin typeface="Arial"/>
+              </a:rPr>
+              <a:t>•  Submit, then inspect live PRs</a:t>
+            </a:r>
+          </a:p>
+        </p:txBody>
+      </p:sp>
+      <p:sp>
+        <p:nvSpPr>
+          <p:cNvPr id="37" name="Rounded Rectangle 36"/>
+          <p:cNvSpPr/>
+          <p:nvPr/>
+        </p:nvSpPr>
+        <p:spPr>
+          <a:xfrm>
+            <a:off x="6830568" y="3401568"/>
+            <a:ext cx="1682496" cy="356616"/>
+          </a:xfrm>
+          <a:prstGeom prst="roundRect">
+            <a:avLst>
+              <a:gd name="adj" fmla="val 8000"/>
+            </a:avLst>
+          </a:prstGeom>
+          <a:solidFill>
+            <a:srgbClr val="0F2D1A"/>
+          </a:solidFill>
+          <a:ln w="12700">
+            <a:solidFill>
+              <a:srgbClr val="1F6F37"/>
+            </a:solidFill>
+          </a:ln>
+        </p:spPr>
+        <p:style>
+          <a:lnRef idx="1">
+            <a:schemeClr val="accent1"/>
+          </a:lnRef>
+          <a:fillRef idx="3">
+            <a:schemeClr val="accent1"/>
+          </a:fillRef>
+          <a:effectRef idx="2">
+            <a:schemeClr val="accent1"/>
+          </a:effectRef>
+          <a:fontRef idx="minor">
+            <a:schemeClr val="lt1"/>
+          </a:fontRef>
+        </p:style>
+        <p:txBody>
+          <a:bodyPr rtlCol="0" anchor="ctr" wrap="square" lIns="0" rIns="0" tIns="0" bIns="0">
+            <a:noAutofit/>
+          </a:bodyPr>
+          <a:lstStyle/>
+          <a:p>
+            <a:pPr algn="ctr"/>
+            <a:r>
+              <a:rPr sz="770" b="1">
+                <a:solidFill>
+                  <a:srgbClr val="79C0FF"/>
+                </a:solidFill>
+                <a:latin typeface="Arial"/>
+              </a:rPr>
+              <a:t>Verify the live GitHub state</a:t>
+            </a:r>
+          </a:p>
+        </p:txBody>
+      </p:sp>
+    </p:spTree>
+  </p:cSld>
+  <p:clrMapOvr>
+    <a:masterClrMapping/>
+  </p:clrMapOvr>
+</p:sld>
+</file>
+
+<file path=ppt/slides/slide7.xml><?xml version="1.0" encoding="utf-8"?>
+<p:sld xmlns:a="http://schemas.openxmlformats.org/drawingml/2006/main" xmlns:p="http://schemas.openxmlformats.org/presentationml/2006/main" xmlns:r="http://schemas.openxmlformats.org/officeDocument/2006/relationships">
+  <p:cSld>
+    <p:bg>
+      <p:bgPr>
+        <a:solidFill>
+          <a:srgbClr val="0D1117"/>
+        </a:solidFill>
+        <a:effectLst/>
+      </p:bgPr>
+    </p:bg>
+    <p:spTree>
+      <p:nvGrpSpPr>
+        <p:cNvPr id="1" name=""/>
+        <p:cNvGrpSpPr/>
+        <p:nvPr/>
+      </p:nvGrpSpPr>
+      <p:grpSpPr/>
+      <p:sp>
+        <p:nvSpPr>
+          <p:cNvPr id="2" name="TextBox 1"/>
+          <p:cNvSpPr txBox="1"/>
+          <p:nvPr/>
+        </p:nvSpPr>
+        <p:spPr>
+          <a:xfrm>
+            <a:off x="484632" y="347472"/>
+            <a:ext cx="6583680" cy="164592"/>
+          </a:xfrm>
+          <a:prstGeom prst="rect">
+            <a:avLst/>
+          </a:prstGeom>
+          <a:noFill/>
+        </p:spPr>
+        <p:txBody>
+          <a:bodyPr wrap="square" lIns="0" rIns="0" tIns="0" bIns="0" anchor="t">
+            <a:noAutofit/>
+          </a:bodyPr>
+          <a:lstStyle/>
+          <a:p>
+            <a:pPr algn="l">
+              <a:lnSpc>
+                <a:spcPct val="100000"/>
+              </a:lnSpc>
+              <a:spcBef>
+                <a:spcPts val="0"/>
+              </a:spcBef>
+              <a:spcAft>
+                <a:spcPts val="0"/>
+              </a:spcAft>
+            </a:pPr>
+            <a:r>
+              <a:rPr sz="850" b="1">
+                <a:solidFill>
+                  <a:srgbClr val="58A6FF"/>
+                </a:solidFill>
+                <a:latin typeface="Arial"/>
+              </a:rPr>
+              <a:t>BEFORE THE WORKFLOW</a:t>
+            </a:r>
+          </a:p>
+        </p:txBody>
+      </p:sp>
+      <p:sp>
+        <p:nvSpPr>
+          <p:cNvPr id="3" name="TextBox 2"/>
+          <p:cNvSpPr txBox="1"/>
+          <p:nvPr/>
+        </p:nvSpPr>
+        <p:spPr>
+          <a:xfrm>
+            <a:off x="484632" y="585216"/>
+            <a:ext cx="8001000" cy="384048"/>
+          </a:xfrm>
+          <a:prstGeom prst="rect">
+            <a:avLst/>
+          </a:prstGeom>
+          <a:noFill/>
+        </p:spPr>
+        <p:txBody>
+          <a:bodyPr wrap="square" lIns="0" rIns="0" tIns="0" bIns="0" anchor="t">
+            <a:noAutofit/>
+          </a:bodyPr>
+          <a:lstStyle/>
+          <a:p>
+            <a:pPr algn="l">
+              <a:lnSpc>
+                <a:spcPct val="100000"/>
+              </a:lnSpc>
+              <a:spcBef>
+                <a:spcPts val="0"/>
+              </a:spcBef>
+              <a:spcAft>
+                <a:spcPts val="0"/>
+              </a:spcAft>
+            </a:pPr>
+            <a:r>
+              <a:rPr sz="2700" b="1">
+                <a:solidFill>
+                  <a:srgbClr val="F0F6FC"/>
+                </a:solidFill>
+                <a:latin typeface="Arial"/>
+              </a:rPr>
+              <a:t>Install and verify the tooling</a:t>
+            </a:r>
+          </a:p>
+        </p:txBody>
+      </p:sp>
+      <p:sp>
+        <p:nvSpPr>
+          <p:cNvPr id="4" name="TextBox 3"/>
+          <p:cNvSpPr txBox="1"/>
+          <p:nvPr/>
+        </p:nvSpPr>
+        <p:spPr>
+          <a:xfrm>
+            <a:off x="484632" y="1005840"/>
+            <a:ext cx="8092440" cy="256032"/>
+          </a:xfrm>
+          <a:prstGeom prst="rect">
+            <a:avLst/>
+          </a:prstGeom>
+          <a:noFill/>
+        </p:spPr>
+        <p:txBody>
+          <a:bodyPr wrap="square" lIns="0" rIns="0" tIns="0" bIns="0" anchor="t">
+            <a:noAutofit/>
+          </a:bodyPr>
+          <a:lstStyle/>
+          <a:p>
+            <a:pPr algn="l">
+              <a:lnSpc>
+                <a:spcPct val="100000"/>
+              </a:lnSpc>
+              <a:spcBef>
+                <a:spcPts val="0"/>
+              </a:spcBef>
+              <a:spcAft>
+                <a:spcPts val="0"/>
+              </a:spcAft>
+            </a:pPr>
+            <a:r>
+              <a:rPr sz="1150" b="0">
+                <a:solidFill>
+                  <a:srgbClr val="8B949E"/>
+                </a:solidFill>
+                <a:latin typeface="Arial"/>
+              </a:rPr>
+              <a:t>GitHub shows the stack; the gh stack extension manages it from the terminal.</a:t>
+            </a:r>
+          </a:p>
+        </p:txBody>
+      </p:sp>
+      <p:sp>
+        <p:nvSpPr>
+          <p:cNvPr id="5" name="Rounded Rectangle 4">
+            <a:hlinkClick r:id="rId2"/>
+          </p:cNvPr>
+          <p:cNvSpPr/>
+          <p:nvPr/>
+        </p:nvSpPr>
+        <p:spPr>
+          <a:xfrm>
+            <a:off x="7479792" y="146304"/>
+            <a:ext cx="1078992" cy="283464"/>
+          </a:xfrm>
+          <a:prstGeom prst="roundRect">
+            <a:avLst>
+              <a:gd name="adj" fmla="val 8000"/>
+            </a:avLst>
+          </a:prstGeom>
+          <a:solidFill>
+            <a:srgbClr val="1F6F37"/>
+          </a:solidFill>
+          <a:ln w="12700">
+            <a:solidFill>
+              <a:srgbClr val="2EA043"/>
+            </a:solidFill>
+          </a:ln>
+        </p:spPr>
+        <p:style>
+          <a:lnRef idx="1">
+            <a:schemeClr val="accent1"/>
+          </a:lnRef>
+          <a:fillRef idx="3">
+            <a:schemeClr val="accent1"/>
+          </a:fillRef>
+          <a:effectRef idx="2">
+            <a:schemeClr val="accent1"/>
+          </a:effectRef>
+          <a:fontRef idx="minor">
+            <a:schemeClr val="lt1"/>
+          </a:fontRef>
+        </p:style>
+        <p:txBody>
+          <a:bodyPr rtlCol="0" anchor="ctr" wrap="square" lIns="0" rIns="0" tIns="0" bIns="0">
+            <a:noAutofit/>
+          </a:bodyPr>
+          <a:lstStyle/>
+          <a:p>
+            <a:pPr algn="ctr"/>
+            <a:r>
+              <a:rPr sz="750" b="1">
+                <a:solidFill>
+                  <a:srgbClr val="FFFFFF"/>
+                </a:solidFill>
+                <a:latin typeface="Arial"/>
+              </a:rPr>
+              <a:t>gh.io/stacks</a:t>
+            </a:r>
+          </a:p>
+        </p:txBody>
+      </p:sp>
+      <p:pic>
+        <p:nvPicPr>
+          <p:cNvPr id="6" name="Picture 5" descr="stack-github-logo.png">
+            <a:hlinkClick r:id="rId4"/>
+          </p:cNvPr>
+          <p:cNvPicPr>
+            <a:picLocks noChangeAspect="1"/>
+          </p:cNvPicPr>
+          <p:nvPr/>
+        </p:nvPicPr>
+        <p:blipFill>
+          <a:blip r:embed="rId3"/>
+          <a:stretch>
+            <a:fillRect/>
+          </a:stretch>
+        </p:blipFill>
+        <p:spPr>
+          <a:xfrm>
+            <a:off x="8668512" y="137160"/>
+            <a:ext cx="256032" cy="256032"/>
+          </a:xfrm>
+          <a:prstGeom prst="rect">
+            <a:avLst/>
+          </a:prstGeom>
+        </p:spPr>
+      </p:pic>
+      <p:sp>
+        <p:nvSpPr>
+          <p:cNvPr id="7" name="Rounded Rectangle 6"/>
+          <p:cNvSpPr/>
+          <p:nvPr/>
+        </p:nvSpPr>
+        <p:spPr>
+          <a:xfrm>
+            <a:off x="484632" y="1444752"/>
+            <a:ext cx="2532888" cy="2176272"/>
+          </a:xfrm>
+          <a:prstGeom prst="roundRect">
+            <a:avLst>
+              <a:gd name="adj" fmla="val 8000"/>
+            </a:avLst>
+          </a:prstGeom>
+          <a:solidFill>
+            <a:srgbClr val="161B22"/>
+          </a:solidFill>
+          <a:ln w="12700">
+            <a:solidFill>
+              <a:srgbClr val="30363D"/>
+            </a:solidFill>
+          </a:ln>
+        </p:spPr>
+        <p:style>
+          <a:lnRef idx="1">
+            <a:schemeClr val="accent1"/>
+          </a:lnRef>
+          <a:fillRef idx="3">
+            <a:schemeClr val="accent1"/>
+          </a:fillRef>
+          <a:effectRef idx="2">
+            <a:schemeClr val="accent1"/>
+          </a:effectRef>
+          <a:fontRef idx="minor">
+            <a:schemeClr val="lt1"/>
+          </a:fontRef>
+        </p:style>
+        <p:txBody>
+          <a:bodyPr rtlCol="0" anchor="ctr"/>
+          <a:lstStyle/>
+          <a:p>
+            <a:pPr algn="ctr"/>
+          </a:p>
+        </p:txBody>
+      </p:sp>
+      <p:sp>
+        <p:nvSpPr>
+          <p:cNvPr id="8" name="Oval 7"/>
+          <p:cNvSpPr/>
+          <p:nvPr/>
+        </p:nvSpPr>
+        <p:spPr>
+          <a:xfrm>
+            <a:off x="649224" y="1609344"/>
+            <a:ext cx="310896" cy="310896"/>
+          </a:xfrm>
+          <a:prstGeom prst="ellipse">
+            <a:avLst/>
+          </a:prstGeom>
+          <a:solidFill>
+            <a:srgbClr val="58A6FF"/>
+          </a:solidFill>
+          <a:ln>
+            <a:noFill/>
+          </a:ln>
+        </p:spPr>
+        <p:style>
+          <a:lnRef idx="1">
+            <a:schemeClr val="accent1"/>
+          </a:lnRef>
+          <a:fillRef idx="3">
+            <a:schemeClr val="accent1"/>
+          </a:fillRef>
+          <a:effectRef idx="2">
+            <a:schemeClr val="accent1"/>
+          </a:effectRef>
+          <a:fontRef idx="minor">
+            <a:schemeClr val="lt1"/>
+          </a:fontRef>
+        </p:style>
+        <p:txBody>
+          <a:bodyPr rtlCol="0" anchor="ctr" wrap="square" lIns="0" rIns="0" tIns="0" bIns="0">
+            <a:noAutofit/>
+          </a:bodyPr>
+          <a:lstStyle/>
+          <a:p>
+            <a:pPr algn="ctr"/>
+            <a:r>
+              <a:rPr sz="900" b="1">
+                <a:solidFill>
+                  <a:srgbClr val="F0F6FC"/>
+                </a:solidFill>
+                <a:latin typeface="Arial"/>
+              </a:rPr>
+              <a:t>1</a:t>
+            </a:r>
+          </a:p>
+        </p:txBody>
+      </p:sp>
+      <p:sp>
+        <p:nvSpPr>
+          <p:cNvPr id="9" name="TextBox 8"/>
+          <p:cNvSpPr txBox="1"/>
+          <p:nvPr/>
+        </p:nvSpPr>
+        <p:spPr>
+          <a:xfrm>
+            <a:off x="1060704" y="1572768"/>
+            <a:ext cx="1755648" cy="228600"/>
+          </a:xfrm>
+          <a:prstGeom prst="rect">
+            <a:avLst/>
+          </a:prstGeom>
+          <a:noFill/>
+        </p:spPr>
+        <p:txBody>
+          <a:bodyPr wrap="square" lIns="0" rIns="0" tIns="0" bIns="0" anchor="t">
+            <a:noAutofit/>
+          </a:bodyPr>
+          <a:lstStyle/>
+          <a:p>
+            <a:pPr algn="l">
+              <a:lnSpc>
+                <a:spcPct val="100000"/>
+              </a:lnSpc>
+              <a:spcBef>
+                <a:spcPts val="0"/>
+              </a:spcBef>
+              <a:spcAft>
+                <a:spcPts val="0"/>
+              </a:spcAft>
+            </a:pPr>
+            <a:r>
+              <a:rPr sz="1300" b="1">
+                <a:solidFill>
+                  <a:srgbClr val="F0F6FC"/>
+                </a:solidFill>
+                <a:latin typeface="Arial"/>
+              </a:rPr>
+              <a:t>Prerequisites</a:t>
+            </a:r>
+          </a:p>
+        </p:txBody>
+      </p:sp>
+      <p:sp>
+        <p:nvSpPr>
+          <p:cNvPr id="10" name="Rounded Rectangle 9"/>
+          <p:cNvSpPr/>
+          <p:nvPr/>
+        </p:nvSpPr>
+        <p:spPr>
+          <a:xfrm>
+            <a:off x="3218688" y="1444752"/>
+            <a:ext cx="2532888" cy="2176272"/>
+          </a:xfrm>
+          <a:prstGeom prst="roundRect">
+            <a:avLst>
+              <a:gd name="adj" fmla="val 8000"/>
+            </a:avLst>
+          </a:prstGeom>
+          <a:solidFill>
+            <a:srgbClr val="161B22"/>
+          </a:solidFill>
+          <a:ln w="12700">
+            <a:solidFill>
+              <a:srgbClr val="30363D"/>
+            </a:solidFill>
+          </a:ln>
+        </p:spPr>
+        <p:style>
+          <a:lnRef idx="1">
+            <a:schemeClr val="accent1"/>
+          </a:lnRef>
+          <a:fillRef idx="3">
+            <a:schemeClr val="accent1"/>
+          </a:fillRef>
+          <a:effectRef idx="2">
+            <a:schemeClr val="accent1"/>
+          </a:effectRef>
+          <a:fontRef idx="minor">
+            <a:schemeClr val="lt1"/>
+          </a:fontRef>
+        </p:style>
+        <p:txBody>
+          <a:bodyPr rtlCol="0" anchor="ctr"/>
+          <a:lstStyle/>
+          <a:p>
+            <a:pPr algn="ctr"/>
+          </a:p>
+        </p:txBody>
+      </p:sp>
+      <p:sp>
+        <p:nvSpPr>
+          <p:cNvPr id="11" name="Oval 10"/>
+          <p:cNvSpPr/>
+          <p:nvPr/>
+        </p:nvSpPr>
+        <p:spPr>
+          <a:xfrm>
+            <a:off x="3383280" y="1609344"/>
+            <a:ext cx="310896" cy="310896"/>
+          </a:xfrm>
+          <a:prstGeom prst="ellipse">
+            <a:avLst/>
+          </a:prstGeom>
+          <a:solidFill>
+            <a:srgbClr val="58A6FF"/>
+          </a:solidFill>
+          <a:ln>
+            <a:noFill/>
+          </a:ln>
+        </p:spPr>
+        <p:style>
+          <a:lnRef idx="1">
+            <a:schemeClr val="accent1"/>
+          </a:lnRef>
+          <a:fillRef idx="3">
+            <a:schemeClr val="accent1"/>
+          </a:fillRef>
+          <a:effectRef idx="2">
+            <a:schemeClr val="accent1"/>
+          </a:effectRef>
+          <a:fontRef idx="minor">
+            <a:schemeClr val="lt1"/>
+          </a:fontRef>
+        </p:style>
+        <p:txBody>
+          <a:bodyPr rtlCol="0" anchor="ctr" wrap="square" lIns="0" rIns="0" tIns="0" bIns="0">
+            <a:noAutofit/>
+          </a:bodyPr>
+          <a:lstStyle/>
+          <a:p>
+            <a:pPr algn="ctr"/>
+            <a:r>
+              <a:rPr sz="900" b="1">
+                <a:solidFill>
+                  <a:srgbClr val="F0F6FC"/>
+                </a:solidFill>
+                <a:latin typeface="Arial"/>
+              </a:rPr>
+              <a:t>2</a:t>
+            </a:r>
+          </a:p>
+        </p:txBody>
+      </p:sp>
+      <p:sp>
+        <p:nvSpPr>
+          <p:cNvPr id="12" name="TextBox 11"/>
+          <p:cNvSpPr txBox="1"/>
+          <p:nvPr/>
+        </p:nvSpPr>
+        <p:spPr>
+          <a:xfrm>
+            <a:off x="3794760" y="1572768"/>
+            <a:ext cx="1755648" cy="228600"/>
+          </a:xfrm>
+          <a:prstGeom prst="rect">
+            <a:avLst/>
+          </a:prstGeom>
+          <a:noFill/>
+        </p:spPr>
+        <p:txBody>
+          <a:bodyPr wrap="square" lIns="0" rIns="0" tIns="0" bIns="0" anchor="t">
+            <a:noAutofit/>
+          </a:bodyPr>
+          <a:lstStyle/>
+          <a:p>
+            <a:pPr algn="l">
+              <a:lnSpc>
+                <a:spcPct val="100000"/>
+              </a:lnSpc>
+              <a:spcBef>
+                <a:spcPts val="0"/>
+              </a:spcBef>
+              <a:spcAft>
+                <a:spcPts val="0"/>
+              </a:spcAft>
+            </a:pPr>
+            <a:r>
+              <a:rPr sz="1300" b="1">
+                <a:solidFill>
+                  <a:srgbClr val="F0F6FC"/>
+                </a:solidFill>
+                <a:latin typeface="Arial"/>
+              </a:rPr>
+              <a:t>Authenticate</a:t>
+            </a:r>
+          </a:p>
+        </p:txBody>
+      </p:sp>
+      <p:sp>
+        <p:nvSpPr>
+          <p:cNvPr id="13" name="Rounded Rectangle 12"/>
+          <p:cNvSpPr/>
+          <p:nvPr/>
+        </p:nvSpPr>
+        <p:spPr>
+          <a:xfrm>
+            <a:off x="5952744" y="1444752"/>
+            <a:ext cx="2532888" cy="2176272"/>
+          </a:xfrm>
+          <a:prstGeom prst="roundRect">
+            <a:avLst>
+              <a:gd name="adj" fmla="val 8000"/>
+            </a:avLst>
+          </a:prstGeom>
+          <a:solidFill>
+            <a:srgbClr val="161B22"/>
+          </a:solidFill>
+          <a:ln w="12700">
+            <a:solidFill>
+              <a:srgbClr val="30363D"/>
+            </a:solidFill>
+          </a:ln>
+        </p:spPr>
+        <p:style>
+          <a:lnRef idx="1">
+            <a:schemeClr val="accent1"/>
+          </a:lnRef>
+          <a:fillRef idx="3">
+            <a:schemeClr val="accent1"/>
+          </a:fillRef>
+          <a:effectRef idx="2">
+            <a:schemeClr val="accent1"/>
+          </a:effectRef>
+          <a:fontRef idx="minor">
+            <a:schemeClr val="lt1"/>
+          </a:fontRef>
+        </p:style>
+        <p:txBody>
+          <a:bodyPr rtlCol="0" anchor="ctr"/>
+          <a:lstStyle/>
+          <a:p>
+            <a:pPr algn="ctr"/>
+          </a:p>
+        </p:txBody>
+      </p:sp>
+      <p:sp>
+        <p:nvSpPr>
+          <p:cNvPr id="14" name="Oval 13"/>
+          <p:cNvSpPr/>
+          <p:nvPr/>
+        </p:nvSpPr>
+        <p:spPr>
+          <a:xfrm>
+            <a:off x="6117336" y="1609344"/>
+            <a:ext cx="310896" cy="310896"/>
+          </a:xfrm>
+          <a:prstGeom prst="ellipse">
+            <a:avLst/>
+          </a:prstGeom>
+          <a:solidFill>
+            <a:srgbClr val="58A6FF"/>
+          </a:solidFill>
+          <a:ln>
+            <a:noFill/>
+          </a:ln>
+        </p:spPr>
+        <p:style>
+          <a:lnRef idx="1">
+            <a:schemeClr val="accent1"/>
+          </a:lnRef>
+          <a:fillRef idx="3">
+            <a:schemeClr val="accent1"/>
+          </a:fillRef>
+          <a:effectRef idx="2">
+            <a:schemeClr val="accent1"/>
+          </a:effectRef>
+          <a:fontRef idx="minor">
+            <a:schemeClr val="lt1"/>
+          </a:fontRef>
+        </p:style>
+        <p:txBody>
+          <a:bodyPr rtlCol="0" anchor="ctr" wrap="square" lIns="0" rIns="0" tIns="0" bIns="0">
+            <a:noAutofit/>
+          </a:bodyPr>
+          <a:lstStyle/>
+          <a:p>
+            <a:pPr algn="ctr"/>
+            <a:r>
+              <a:rPr sz="900" b="1">
+                <a:solidFill>
+                  <a:srgbClr val="F0F6FC"/>
+                </a:solidFill>
+                <a:latin typeface="Arial"/>
+              </a:rPr>
+              <a:t>3</a:t>
+            </a:r>
+          </a:p>
+        </p:txBody>
+      </p:sp>
+      <p:sp>
+        <p:nvSpPr>
+          <p:cNvPr id="15" name="TextBox 14"/>
+          <p:cNvSpPr txBox="1"/>
+          <p:nvPr/>
+        </p:nvSpPr>
+        <p:spPr>
+          <a:xfrm>
+            <a:off x="6528816" y="1572768"/>
+            <a:ext cx="1755648" cy="228600"/>
+          </a:xfrm>
+          <a:prstGeom prst="rect">
+            <a:avLst/>
+          </a:prstGeom>
+          <a:noFill/>
+        </p:spPr>
+        <p:txBody>
+          <a:bodyPr wrap="square" lIns="0" rIns="0" tIns="0" bIns="0" anchor="t">
+            <a:noAutofit/>
+          </a:bodyPr>
+          <a:lstStyle/>
+          <a:p>
+            <a:pPr algn="l">
+              <a:lnSpc>
+                <a:spcPct val="100000"/>
+              </a:lnSpc>
+              <a:spcBef>
+                <a:spcPts val="0"/>
+              </a:spcBef>
+              <a:spcAft>
+                <a:spcPts val="0"/>
+              </a:spcAft>
+            </a:pPr>
+            <a:r>
+              <a:rPr sz="1300" b="1">
+                <a:solidFill>
+                  <a:srgbClr val="F0F6FC"/>
+                </a:solidFill>
+                <a:latin typeface="Arial"/>
+              </a:rPr>
+              <a:t>Install + verify</a:t>
+            </a:r>
+          </a:p>
+        </p:txBody>
+      </p:sp>
+      <p:sp>
+        <p:nvSpPr>
+          <p:cNvPr id="16" name="TextBox 15"/>
+          <p:cNvSpPr txBox="1"/>
+          <p:nvPr/>
+        </p:nvSpPr>
+        <p:spPr>
+          <a:xfrm>
+            <a:off x="658368" y="1984248"/>
+            <a:ext cx="2176272" cy="164592"/>
+          </a:xfrm>
+          <a:prstGeom prst="rect">
+            <a:avLst/>
+          </a:prstGeom>
+          <a:noFill/>
+        </p:spPr>
+        <p:txBody>
+          <a:bodyPr wrap="square" lIns="0" rIns="0" tIns="0" bIns="0" anchor="t">
+            <a:noAutofit/>
+          </a:bodyPr>
+          <a:lstStyle/>
+          <a:p>
+            <a:pPr algn="l">
+              <a:lnSpc>
+                <a:spcPct val="100000"/>
+              </a:lnSpc>
+              <a:spcBef>
+                <a:spcPts val="0"/>
+              </a:spcBef>
+              <a:spcAft>
+                <a:spcPts val="0"/>
+              </a:spcAft>
+            </a:pPr>
+            <a:r>
+              <a:rPr sz="800" b="1">
+                <a:solidFill>
+                  <a:srgbClr val="3FB950"/>
+                </a:solidFill>
+                <a:latin typeface="Arial"/>
+              </a:rPr>
+              <a:t>REQUIRED</a:t>
+            </a:r>
+          </a:p>
+        </p:txBody>
+      </p:sp>
+      <p:sp>
+        <p:nvSpPr>
+          <p:cNvPr id="17" name="TextBox 16"/>
+          <p:cNvSpPr txBox="1"/>
+          <p:nvPr/>
+        </p:nvSpPr>
+        <p:spPr>
+          <a:xfrm>
+            <a:off x="694944" y="2267712"/>
+            <a:ext cx="2029968" cy="201168"/>
+          </a:xfrm>
+          <a:prstGeom prst="rect">
+            <a:avLst/>
+          </a:prstGeom>
+          <a:noFill/>
+        </p:spPr>
+        <p:txBody>
+          <a:bodyPr wrap="square" lIns="0" rIns="0" tIns="0" bIns="0" anchor="t">
+            <a:noAutofit/>
+          </a:bodyPr>
+          <a:lstStyle/>
+          <a:p>
+            <a:pPr algn="l">
+              <a:lnSpc>
+                <a:spcPct val="100000"/>
+              </a:lnSpc>
+              <a:spcBef>
+                <a:spcPts val="0"/>
+              </a:spcBef>
+              <a:spcAft>
+                <a:spcPts val="0"/>
+              </a:spcAft>
+            </a:pPr>
+            <a:r>
+              <a:rPr sz="960" b="0">
+                <a:solidFill>
+                  <a:srgbClr val="8B949E"/>
+                </a:solidFill>
+                <a:latin typeface="Arial"/>
+              </a:rPr>
+              <a:t>•  Git 2.20 or newer</a:t>
+            </a:r>
+          </a:p>
+        </p:txBody>
+      </p:sp>
+      <p:sp>
+        <p:nvSpPr>
+          <p:cNvPr id="18" name="TextBox 17"/>
+          <p:cNvSpPr txBox="1"/>
+          <p:nvPr/>
+        </p:nvSpPr>
+        <p:spPr>
+          <a:xfrm>
+            <a:off x="694944" y="2560320"/>
+            <a:ext cx="2029968" cy="201168"/>
+          </a:xfrm>
+          <a:prstGeom prst="rect">
+            <a:avLst/>
+          </a:prstGeom>
+          <a:noFill/>
+        </p:spPr>
+        <p:txBody>
+          <a:bodyPr wrap="square" lIns="0" rIns="0" tIns="0" bIns="0" anchor="t">
+            <a:noAutofit/>
+          </a:bodyPr>
+          <a:lstStyle/>
+          <a:p>
+            <a:pPr algn="l">
+              <a:lnSpc>
+                <a:spcPct val="100000"/>
+              </a:lnSpc>
+              <a:spcBef>
+                <a:spcPts val="0"/>
+              </a:spcBef>
+              <a:spcAft>
+                <a:spcPts val="0"/>
+              </a:spcAft>
+            </a:pPr>
+            <a:r>
+              <a:rPr sz="960" b="0">
+                <a:solidFill>
+                  <a:srgbClr val="8B949E"/>
+                </a:solidFill>
+                <a:latin typeface="Arial"/>
+              </a:rPr>
+              <a:t>•  GitHub CLI 2.90 or newer</a:t>
+            </a:r>
+          </a:p>
+        </p:txBody>
+      </p:sp>
+      <p:sp>
+        <p:nvSpPr>
+          <p:cNvPr id="19" name="TextBox 18"/>
+          <p:cNvSpPr txBox="1"/>
+          <p:nvPr/>
+        </p:nvSpPr>
+        <p:spPr>
+          <a:xfrm>
+            <a:off x="694944" y="2852928"/>
+            <a:ext cx="2029968" cy="201168"/>
+          </a:xfrm>
+          <a:prstGeom prst="rect">
+            <a:avLst/>
+          </a:prstGeom>
+          <a:noFill/>
+        </p:spPr>
+        <p:txBody>
+          <a:bodyPr wrap="square" lIns="0" rIns="0" tIns="0" bIns="0" anchor="t">
+            <a:noAutofit/>
+          </a:bodyPr>
+          <a:lstStyle/>
+          <a:p>
+            <a:pPr algn="l">
+              <a:lnSpc>
+                <a:spcPct val="100000"/>
+              </a:lnSpc>
+              <a:spcBef>
+                <a:spcPts val="0"/>
+              </a:spcBef>
+              <a:spcAft>
+                <a:spcPts val="0"/>
+              </a:spcAft>
+            </a:pPr>
+            <a:r>
+              <a:rPr sz="960" b="0">
+                <a:solidFill>
+                  <a:srgbClr val="8B949E"/>
+                </a:solidFill>
+                <a:latin typeface="Arial"/>
+              </a:rPr>
+              <a:t>•  Node.js 20 or newer</a:t>
+            </a:r>
+          </a:p>
+        </p:txBody>
+      </p:sp>
+      <p:sp>
+        <p:nvSpPr>
+          <p:cNvPr id="20" name="TextBox 19"/>
+          <p:cNvSpPr txBox="1"/>
+          <p:nvPr/>
+        </p:nvSpPr>
+        <p:spPr>
+          <a:xfrm>
+            <a:off x="694944" y="3145536"/>
+            <a:ext cx="2029968" cy="201168"/>
+          </a:xfrm>
+          <a:prstGeom prst="rect">
+            <a:avLst/>
+          </a:prstGeom>
+          <a:noFill/>
+        </p:spPr>
+        <p:txBody>
+          <a:bodyPr wrap="square" lIns="0" rIns="0" tIns="0" bIns="0" anchor="t">
+            <a:noAutofit/>
+          </a:bodyPr>
+          <a:lstStyle/>
+          <a:p>
+            <a:pPr algn="l">
+              <a:lnSpc>
+                <a:spcPct val="100000"/>
+              </a:lnSpc>
+              <a:spcBef>
+                <a:spcPts val="0"/>
+              </a:spcBef>
+              <a:spcAft>
+                <a:spcPts val="0"/>
+              </a:spcAft>
+            </a:pPr>
+            <a:r>
+              <a:rPr sz="960" b="0">
+                <a:solidFill>
+                  <a:srgbClr val="8B949E"/>
+                </a:solidFill>
+                <a:latin typeface="Arial"/>
+              </a:rPr>
+              <a:t>•  Git identity + GitHub push access</a:t>
+            </a:r>
+          </a:p>
+        </p:txBody>
+      </p:sp>
+      <p:sp>
+        <p:nvSpPr>
+          <p:cNvPr id="21" name="TextBox 20"/>
+          <p:cNvSpPr txBox="1"/>
+          <p:nvPr/>
+        </p:nvSpPr>
+        <p:spPr>
+          <a:xfrm>
+            <a:off x="3392424" y="1984248"/>
+            <a:ext cx="2176272" cy="164592"/>
+          </a:xfrm>
+          <a:prstGeom prst="rect">
+            <a:avLst/>
+          </a:prstGeom>
+          <a:noFill/>
+        </p:spPr>
+        <p:txBody>
+          <a:bodyPr wrap="square" lIns="0" rIns="0" tIns="0" bIns="0" anchor="t">
+            <a:noAutofit/>
+          </a:bodyPr>
+          <a:lstStyle/>
+          <a:p>
+            <a:pPr algn="l">
+              <a:lnSpc>
+                <a:spcPct val="100000"/>
+              </a:lnSpc>
+              <a:spcBef>
+                <a:spcPts val="0"/>
+              </a:spcBef>
+              <a:spcAft>
+                <a:spcPts val="0"/>
+              </a:spcAft>
+            </a:pPr>
+            <a:r>
+              <a:rPr sz="800" b="1">
+                <a:solidFill>
+                  <a:srgbClr val="3FB950"/>
+                </a:solidFill>
+                <a:latin typeface="Arial"/>
+              </a:rPr>
+              <a:t>SIGN IN ONCE</a:t>
+            </a:r>
+          </a:p>
+        </p:txBody>
+      </p:sp>
+      <p:sp>
+        <p:nvSpPr>
+          <p:cNvPr id="22" name="Rounded Rectangle 21"/>
+          <p:cNvSpPr/>
+          <p:nvPr/>
+        </p:nvSpPr>
+        <p:spPr>
+          <a:xfrm>
+            <a:off x="3383280" y="2240280"/>
+            <a:ext cx="2194560" cy="713232"/>
+          </a:xfrm>
+          <a:prstGeom prst="roundRect">
+            <a:avLst>
+              <a:gd name="adj" fmla="val 8000"/>
+            </a:avLst>
+          </a:prstGeom>
+          <a:solidFill>
+            <a:srgbClr val="010409"/>
+          </a:solidFill>
+          <a:ln w="12700">
+            <a:solidFill>
+              <a:srgbClr val="30363D"/>
+            </a:solidFill>
+          </a:ln>
+        </p:spPr>
+        <p:style>
+          <a:lnRef idx="1">
+            <a:schemeClr val="accent1"/>
+          </a:lnRef>
+          <a:fillRef idx="3">
+            <a:schemeClr val="accent1"/>
+          </a:fillRef>
+          <a:effectRef idx="2">
+            <a:schemeClr val="accent1"/>
+          </a:effectRef>
+          <a:fontRef idx="minor">
+            <a:schemeClr val="lt1"/>
+          </a:fontRef>
+        </p:style>
+        <p:txBody>
+          <a:bodyPr rtlCol="0" anchor="t" wrap="square" lIns="128016" rIns="128016" tIns="100584" bIns="73152">
+            <a:noAutofit/>
+          </a:bodyPr>
+          <a:lstStyle/>
+          <a:p>
+            <a:pPr algn="l">
+              <a:lnSpc>
+                <a:spcPct val="105000"/>
+              </a:lnSpc>
+              <a:spcBef>
+                <a:spcPts val="0"/>
+              </a:spcBef>
+              <a:spcAft>
+                <a:spcPts val="0"/>
+              </a:spcAft>
+            </a:pPr>
+            <a:r>
+              <a:rPr sz="1000" b="0">
+                <a:solidFill>
+                  <a:srgbClr val="58A6FF"/>
+                </a:solidFill>
+                <a:latin typeface="Courier New"/>
+              </a:rPr>
+              <a:t>gh auth login</a:t>
+            </a:r>
+          </a:p>
+          <a:p>
+            <a:pPr algn="l">
+              <a:lnSpc>
+                <a:spcPct val="105000"/>
+              </a:lnSpc>
+              <a:spcBef>
+                <a:spcPts val="0"/>
+              </a:spcBef>
+              <a:spcAft>
+                <a:spcPts val="0"/>
+              </a:spcAft>
+            </a:pPr>
+            <a:r>
+              <a:rPr sz="1000" b="0">
+                <a:solidFill>
+                  <a:srgbClr val="58A6FF"/>
+                </a:solidFill>
+                <a:latin typeface="Courier New"/>
+              </a:rPr>
+              <a:t>gh auth status</a:t>
+            </a:r>
+          </a:p>
+        </p:txBody>
+      </p:sp>
+      <p:sp>
+        <p:nvSpPr>
+          <p:cNvPr id="23" name="TextBox 22"/>
+          <p:cNvSpPr txBox="1"/>
+          <p:nvPr/>
+        </p:nvSpPr>
+        <p:spPr>
+          <a:xfrm>
+            <a:off x="3410712" y="3136392"/>
+            <a:ext cx="2121408" cy="310896"/>
+          </a:xfrm>
+          <a:prstGeom prst="rect">
+            <a:avLst/>
+          </a:prstGeom>
+          <a:noFill/>
+        </p:spPr>
+        <p:txBody>
+          <a:bodyPr wrap="square" lIns="0" rIns="0" tIns="0" bIns="0" anchor="t">
+            <a:noAutofit/>
+          </a:bodyPr>
+          <a:lstStyle/>
+          <a:p>
+            <a:pPr algn="l">
+              <a:lnSpc>
+                <a:spcPct val="100000"/>
+              </a:lnSpc>
+              <a:spcBef>
+                <a:spcPts val="0"/>
+              </a:spcBef>
+              <a:spcAft>
+                <a:spcPts val="0"/>
+              </a:spcAft>
+            </a:pPr>
+            <a:r>
+              <a:rPr sz="940" b="0">
+                <a:solidFill>
+                  <a:srgbClr val="8B949E"/>
+                </a:solidFill>
+                <a:latin typeface="Arial"/>
+              </a:rPr>
+              <a:t>Confirm the active account and the repository host.</a:t>
+            </a:r>
+          </a:p>
+        </p:txBody>
+      </p:sp>
+      <p:sp>
+        <p:nvSpPr>
+          <p:cNvPr id="24" name="TextBox 23"/>
+          <p:cNvSpPr txBox="1"/>
+          <p:nvPr/>
+        </p:nvSpPr>
+        <p:spPr>
+          <a:xfrm>
+            <a:off x="6126480" y="1984248"/>
+            <a:ext cx="2176272" cy="164592"/>
+          </a:xfrm>
+          <a:prstGeom prst="rect">
+            <a:avLst/>
+          </a:prstGeom>
+          <a:noFill/>
+        </p:spPr>
+        <p:txBody>
+          <a:bodyPr wrap="square" lIns="0" rIns="0" tIns="0" bIns="0" anchor="t">
+            <a:noAutofit/>
+          </a:bodyPr>
+          <a:lstStyle/>
+          <a:p>
+            <a:pPr algn="l">
+              <a:lnSpc>
+                <a:spcPct val="100000"/>
+              </a:lnSpc>
+              <a:spcBef>
+                <a:spcPts val="0"/>
+              </a:spcBef>
+              <a:spcAft>
+                <a:spcPts val="0"/>
+              </a:spcAft>
+            </a:pPr>
+            <a:r>
+              <a:rPr sz="800" b="1">
+                <a:solidFill>
+                  <a:srgbClr val="3FB950"/>
+                </a:solidFill>
+                <a:latin typeface="Arial"/>
+              </a:rPr>
+              <a:t>INSTALL ONCE</a:t>
+            </a:r>
+          </a:p>
+        </p:txBody>
+      </p:sp>
+      <p:sp>
+        <p:nvSpPr>
+          <p:cNvPr id="25" name="Rounded Rectangle 24"/>
+          <p:cNvSpPr/>
+          <p:nvPr/>
+        </p:nvSpPr>
+        <p:spPr>
+          <a:xfrm>
+            <a:off x="6117336" y="2221992"/>
+            <a:ext cx="2194560" cy="877824"/>
+          </a:xfrm>
+          <a:prstGeom prst="roundRect">
+            <a:avLst>
+              <a:gd name="adj" fmla="val 8000"/>
+            </a:avLst>
+          </a:prstGeom>
+          <a:solidFill>
+            <a:srgbClr val="010409"/>
+          </a:solidFill>
+          <a:ln w="12700">
+            <a:solidFill>
+              <a:srgbClr val="30363D"/>
+            </a:solidFill>
+          </a:ln>
+        </p:spPr>
+        <p:style>
+          <a:lnRef idx="1">
+            <a:schemeClr val="accent1"/>
+          </a:lnRef>
+          <a:fillRef idx="3">
+            <a:schemeClr val="accent1"/>
+          </a:fillRef>
+          <a:effectRef idx="2">
+            <a:schemeClr val="accent1"/>
+          </a:effectRef>
+          <a:fontRef idx="minor">
+            <a:schemeClr val="lt1"/>
+          </a:fontRef>
+        </p:style>
+        <p:txBody>
+          <a:bodyPr rtlCol="0" anchor="t" wrap="square" lIns="118872" rIns="118872" tIns="146304" bIns="73152">
+            <a:noAutofit/>
+          </a:bodyPr>
+          <a:lstStyle/>
+          <a:p>
+            <a:pPr algn="l">
+              <a:lnSpc>
+                <a:spcPct val="105000"/>
+              </a:lnSpc>
+              <a:spcBef>
+                <a:spcPts val="0"/>
+              </a:spcBef>
+              <a:spcAft>
+                <a:spcPts val="0"/>
+              </a:spcAft>
+            </a:pPr>
+            <a:r>
+              <a:rPr sz="680" b="0">
+                <a:solidFill>
+                  <a:srgbClr val="58A6FF"/>
+                </a:solidFill>
+                <a:latin typeface="Courier New"/>
+              </a:rPr>
+              <a:t>gh extension install github/gh-stack</a:t>
+            </a:r>
+          </a:p>
+          <a:p>
+            <a:pPr algn="l">
+              <a:lnSpc>
+                <a:spcPct val="105000"/>
+              </a:lnSpc>
+              <a:spcBef>
+                <a:spcPts val="0"/>
+              </a:spcBef>
+              <a:spcAft>
+                <a:spcPts val="0"/>
+              </a:spcAft>
+            </a:pPr>
+            <a:r>
+              <a:rPr sz="680" b="0">
+                <a:solidFill>
+                  <a:srgbClr val="58A6FF"/>
+                </a:solidFill>
+                <a:latin typeface="Courier New"/>
+              </a:rPr>
+              <a:t>gh stack --version</a:t>
+            </a:r>
+          </a:p>
+        </p:txBody>
+      </p:sp>
+      <p:sp>
+        <p:nvSpPr>
+          <p:cNvPr id="26" name="TextBox 25"/>
+          <p:cNvSpPr txBox="1"/>
+          <p:nvPr/>
+        </p:nvSpPr>
+        <p:spPr>
+          <a:xfrm>
+            <a:off x="6144768" y="3209544"/>
+            <a:ext cx="2112264" cy="201168"/>
+          </a:xfrm>
+          <a:prstGeom prst="rect">
+            <a:avLst/>
+          </a:prstGeom>
+          <a:noFill/>
+        </p:spPr>
+        <p:txBody>
+          <a:bodyPr wrap="square" lIns="0" rIns="0" tIns="0" bIns="0" anchor="t">
+            <a:noAutofit/>
+          </a:bodyPr>
+          <a:lstStyle/>
+          <a:p>
+            <a:pPr algn="l">
+              <a:lnSpc>
+                <a:spcPct val="100000"/>
+              </a:lnSpc>
+              <a:spcBef>
+                <a:spcPts val="0"/>
+              </a:spcBef>
+              <a:spcAft>
+                <a:spcPts val="0"/>
+              </a:spcAft>
+            </a:pPr>
+            <a:r>
+              <a:rPr sz="940" b="0">
+                <a:solidFill>
+                  <a:srgbClr val="8B949E"/>
+                </a:solidFill>
+                <a:latin typeface="Arial"/>
+              </a:rPr>
+              <a:t>Verify the command before starting.</a:t>
+            </a:r>
+          </a:p>
+        </p:txBody>
+      </p:sp>
+      <p:sp>
+        <p:nvSpPr>
+          <p:cNvPr id="27" name="Rounded Rectangle 26"/>
+          <p:cNvSpPr/>
+          <p:nvPr/>
+        </p:nvSpPr>
+        <p:spPr>
+          <a:xfrm>
+            <a:off x="484632" y="3840480"/>
+            <a:ext cx="8001000" cy="950976"/>
+          </a:xfrm>
+          <a:prstGeom prst="roundRect">
+            <a:avLst>
+              <a:gd name="adj" fmla="val 8000"/>
+            </a:avLst>
+          </a:prstGeom>
+          <a:solidFill>
+            <a:srgbClr val="0F2D1A"/>
+          </a:solidFill>
+          <a:ln w="12700">
+            <a:solidFill>
+              <a:srgbClr val="1F6F37"/>
+            </a:solidFill>
+          </a:ln>
+        </p:spPr>
+        <p:style>
+          <a:lnRef idx="1">
+            <a:schemeClr val="accent1"/>
+          </a:lnRef>
+          <a:fillRef idx="3">
+            <a:schemeClr val="accent1"/>
+          </a:fillRef>
+          <a:effectRef idx="2">
+            <a:schemeClr val="accent1"/>
+          </a:effectRef>
+          <a:fontRef idx="minor">
+            <a:schemeClr val="lt1"/>
+          </a:fontRef>
+        </p:style>
+        <p:txBody>
+          <a:bodyPr rtlCol="0" anchor="ctr"/>
+          <a:lstStyle/>
+          <a:p>
+            <a:pPr algn="ctr"/>
+          </a:p>
+        </p:txBody>
+      </p:sp>
+      <p:sp>
+        <p:nvSpPr>
+          <p:cNvPr id="28" name="TextBox 27"/>
+          <p:cNvSpPr txBox="1"/>
+          <p:nvPr/>
+        </p:nvSpPr>
+        <p:spPr>
+          <a:xfrm>
+            <a:off x="667512" y="3995928"/>
+            <a:ext cx="1298448" cy="173736"/>
+          </a:xfrm>
+          <a:prstGeom prst="rect">
+            <a:avLst/>
+          </a:prstGeom>
+          <a:noFill/>
+        </p:spPr>
+        <p:txBody>
+          <a:bodyPr wrap="square" lIns="0" rIns="0" tIns="0" bIns="0" anchor="t">
+            <a:noAutofit/>
+          </a:bodyPr>
+          <a:lstStyle/>
+          <a:p>
+            <a:pPr algn="l">
+              <a:lnSpc>
+                <a:spcPct val="100000"/>
+              </a:lnSpc>
+              <a:spcBef>
+                <a:spcPts val="0"/>
+              </a:spcBef>
+              <a:spcAft>
+                <a:spcPts val="0"/>
+              </a:spcAft>
+            </a:pPr>
+            <a:r>
+              <a:rPr sz="850" b="1">
+                <a:solidFill>
+                  <a:srgbClr val="79C0FF"/>
+                </a:solidFill>
+                <a:latin typeface="Arial"/>
+              </a:rPr>
+              <a:t>USING AN AGENT?</a:t>
+            </a:r>
+          </a:p>
+        </p:txBody>
+      </p:sp>
+      <p:sp>
+        <p:nvSpPr>
+          <p:cNvPr id="29" name="TextBox 28"/>
+          <p:cNvSpPr txBox="1"/>
+          <p:nvPr/>
+        </p:nvSpPr>
+        <p:spPr>
+          <a:xfrm>
+            <a:off x="667512" y="4261104"/>
+            <a:ext cx="1417320" cy="292608"/>
+          </a:xfrm>
+          <a:prstGeom prst="rect">
+            <a:avLst/>
+          </a:prstGeom>
+          <a:noFill/>
+        </p:spPr>
+        <p:txBody>
+          <a:bodyPr wrap="square" lIns="0" rIns="0" tIns="0" bIns="0" anchor="t">
+            <a:noAutofit/>
+          </a:bodyPr>
+          <a:lstStyle/>
+          <a:p>
+            <a:pPr algn="l">
+              <a:lnSpc>
+                <a:spcPct val="100000"/>
+              </a:lnSpc>
+              <a:spcBef>
+                <a:spcPts val="0"/>
+              </a:spcBef>
+              <a:spcAft>
+                <a:spcPts val="0"/>
+              </a:spcAft>
+            </a:pPr>
+            <a:r>
+              <a:rPr sz="1040" b="1">
+                <a:solidFill>
+                  <a:srgbClr val="F0F6FC"/>
+                </a:solidFill>
+                <a:latin typeface="Arial"/>
+              </a:rPr>
+              <a:t>Install the gh-stack skill too.</a:t>
+            </a:r>
+          </a:p>
+        </p:txBody>
+      </p:sp>
+      <p:sp>
+        <p:nvSpPr>
+          <p:cNvPr id="30" name="Rounded Rectangle 29"/>
+          <p:cNvSpPr/>
+          <p:nvPr/>
+        </p:nvSpPr>
+        <p:spPr>
+          <a:xfrm>
+            <a:off x="2176272" y="3995928"/>
+            <a:ext cx="3703320" cy="548640"/>
+          </a:xfrm>
+          <a:prstGeom prst="roundRect">
+            <a:avLst>
+              <a:gd name="adj" fmla="val 8000"/>
+            </a:avLst>
+          </a:prstGeom>
+          <a:solidFill>
+            <a:srgbClr val="010409"/>
+          </a:solidFill>
+          <a:ln w="12700">
+            <a:solidFill>
+              <a:srgbClr val="30363D"/>
+            </a:solidFill>
+          </a:ln>
+        </p:spPr>
+        <p:style>
+          <a:lnRef idx="1">
+            <a:schemeClr val="accent1"/>
+          </a:lnRef>
+          <a:fillRef idx="3">
+            <a:schemeClr val="accent1"/>
+          </a:fillRef>
+          <a:effectRef idx="2">
+            <a:schemeClr val="accent1"/>
+          </a:effectRef>
+          <a:fontRef idx="minor">
+            <a:schemeClr val="lt1"/>
+          </a:fontRef>
+        </p:style>
+        <p:txBody>
+          <a:bodyPr rtlCol="0" anchor="t" wrap="square" lIns="118872" rIns="118872" tIns="82296" bIns="73152">
+            <a:noAutofit/>
+          </a:bodyPr>
+          <a:lstStyle/>
+          <a:p>
+            <a:pPr algn="l">
+              <a:lnSpc>
+                <a:spcPct val="90000"/>
+              </a:lnSpc>
+              <a:spcBef>
+                <a:spcPts val="0"/>
+              </a:spcBef>
+              <a:spcAft>
+                <a:spcPts val="0"/>
+              </a:spcAft>
+            </a:pPr>
+            <a:r>
+              <a:rPr sz="819" b="0">
+                <a:solidFill>
+                  <a:srgbClr val="58A6FF"/>
+                </a:solidFill>
+                <a:latin typeface="Courier New"/>
+              </a:rPr>
+              <a:t>gh skill install github/gh-stack gh-stack \</a:t>
+            </a:r>
+          </a:p>
+          <a:p>
+            <a:pPr algn="l">
+              <a:lnSpc>
+                <a:spcPct val="90000"/>
+              </a:lnSpc>
+              <a:spcBef>
+                <a:spcPts val="0"/>
+              </a:spcBef>
+              <a:spcAft>
+                <a:spcPts val="0"/>
+              </a:spcAft>
+            </a:pPr>
+            <a:r>
+              <a:rPr sz="819" b="0">
+                <a:solidFill>
+                  <a:srgbClr val="58A6FF"/>
+                </a:solidFill>
+                <a:latin typeface="Courier New"/>
+              </a:rPr>
+              <a:t>  --agent github-copilot --scope user</a:t>
+            </a:r>
+          </a:p>
+        </p:txBody>
+      </p:sp>
+      <p:sp>
+        <p:nvSpPr>
+          <p:cNvPr id="31" name="TextBox 30"/>
+          <p:cNvSpPr txBox="1"/>
+          <p:nvPr/>
+        </p:nvSpPr>
+        <p:spPr>
+          <a:xfrm>
+            <a:off x="6071616" y="4005072"/>
+            <a:ext cx="2194560" cy="438912"/>
+          </a:xfrm>
+          <a:prstGeom prst="rect">
+            <a:avLst/>
+          </a:prstGeom>
+          <a:noFill/>
+        </p:spPr>
+        <p:txBody>
+          <a:bodyPr wrap="square" lIns="0" rIns="0" tIns="0" bIns="0" anchor="t">
+            <a:noAutofit/>
+          </a:bodyPr>
+          <a:lstStyle/>
+          <a:p>
+            <a:pPr algn="l">
+              <a:lnSpc>
+                <a:spcPct val="100000"/>
+              </a:lnSpc>
+              <a:spcBef>
+                <a:spcPts val="0"/>
+              </a:spcBef>
+              <a:spcAft>
+                <a:spcPts val="0"/>
+              </a:spcAft>
+            </a:pPr>
+            <a:r>
+              <a:rPr sz="930" b="0">
+                <a:solidFill>
+                  <a:srgbClr val="F0F6FC"/>
+                </a:solidFill>
+                <a:latin typeface="Arial"/>
+              </a:rPr>
+              <a:t>The skill adds command knowledge. It does not replace the extension.</a:t>
             </a:r>
           </a:p>
         </p:txBody>

</xml_diff>

<commit_message>
docs: add video plan and clean deck notes
</commit_message>
<xml_diff>
--- a/github-stacked-prs.pptx
+++ b/github-stacked-prs.pptx
@@ -289,7 +289,7 @@
           <a:p>
             <a:r>
               <a:rPr lang="en-US" dirty="0"/>
-              <a:t>Video visual 1 of 3. See VIDEO.md for narration and shot timing.</a:t>
+              <a:t/>
             </a:r>
           </a:p>
         </p:txBody>
@@ -376,7 +376,7 @@
           <a:p>
             <a:r>
               <a:rPr lang="en-US" dirty="0"/>
-              <a:t>Video visual 2 of 3. See VIDEO.md for narration and shot timing.</a:t>
+              <a:t/>
             </a:r>
           </a:p>
         </p:txBody>
@@ -463,7 +463,7 @@
           <a:p>
             <a:r>
               <a:rPr lang="en-US" dirty="0"/>
-              <a:t>Video visual 3 of 3. See VIDEO.md for narration and shot timing.</a:t>
+              <a:t/>
             </a:r>
           </a:p>
         </p:txBody>

</xml_diff>

<commit_message>
docs: replace stacked PR presentation
</commit_message>
<xml_diff>
--- a/github-stacked-prs.pptx
+++ b/github-stacked-prs.pptx
@@ -2678,7 +2678,7 @@
               <a:buNone/>
             </a:pPr>
             <a:r>
-              <a:rPr lang="en-US" sz="2900" b="1" dirty="0">
+              <a:rPr lang="en-US" sz="3100" b="1" dirty="0">
                 <a:solidFill>
                   <a:srgbClr val="F0F6FC"/>
                 </a:solidFill>
@@ -2688,7 +2688,7 @@
               </a:rPr>
               <a:t>Turn one large pull request into reviewable layers</a:t>
             </a:r>
-            <a:endParaRPr lang="en-US" sz="2900" dirty="0"/>
+            <a:endParaRPr lang="en-US" sz="3100" dirty="0"/>
           </a:p>
         </p:txBody>
       </p:sp>
@@ -5201,7 +5201,7 @@
         </p:nvSpPr>
         <p:spPr>
           <a:xfrm>
-            <a:off x="484632" y="585216"/>
+            <a:off x="484632" y="530352"/>
             <a:ext cx="8001000" cy="384048"/>
           </a:xfrm>
           <a:prstGeom prst="rect">
@@ -5227,7 +5227,7 @@
               </a:spcAft>
             </a:pPr>
             <a:r>
-              <a:rPr sz="2700" b="1">
+              <a:rPr sz="3100" b="1" dirty="0">
                 <a:solidFill>
                   <a:srgbClr val="F0F6FC"/>
                 </a:solidFill>
@@ -5272,13 +5272,31 @@
               </a:spcAft>
             </a:pPr>
             <a:r>
-              <a:rPr sz="1150" b="0">
+              <a:rPr sz="1600" b="0" dirty="0">
                 <a:solidFill>
                   <a:srgbClr val="8B949E"/>
                 </a:solidFill>
                 <a:latin typeface="Arial"/>
               </a:rPr>
-              <a:t>GitHub shows the stack; the gh stack extension manages it from the terminal.</a:t>
+              <a:t>GitHub shows the stack; the </a:t>
+            </a:r>
+            <a:r>
+              <a:rPr sz="1600" b="0" dirty="0" err="1">
+                <a:solidFill>
+                  <a:srgbClr val="8B949E"/>
+                </a:solidFill>
+                <a:latin typeface="Arial"/>
+              </a:rPr>
+              <a:t>gh</a:t>
+            </a:r>
+            <a:r>
+              <a:rPr sz="1600" b="0" dirty="0">
+                <a:solidFill>
+                  <a:srgbClr val="8B949E"/>
+                </a:solidFill>
+                <a:latin typeface="Arial"/>
+              </a:rPr>
+              <a:t> stack extension manages it from the terminal.</a:t>
             </a:r>
           </a:p>
         </p:txBody>
@@ -7404,7 +7422,7 @@
         </p:nvSpPr>
         <p:spPr>
           <a:xfrm>
-            <a:off x="482501" y="1124396"/>
+            <a:off x="482501" y="1056084"/>
             <a:ext cx="8342578" cy="238125"/>
           </a:xfrm>
           <a:prstGeom prst="rect">
@@ -9142,7 +9160,7 @@
         </p:nvSpPr>
         <p:spPr>
           <a:xfrm>
-            <a:off x="484632" y="585216"/>
+            <a:off x="484632" y="525780"/>
             <a:ext cx="8001000" cy="384048"/>
           </a:xfrm>
           <a:prstGeom prst="rect">
@@ -9168,7 +9186,7 @@
               </a:spcAft>
             </a:pPr>
             <a:r>
-              <a:rPr sz="2700" b="1">
+              <a:rPr sz="3100" b="1" dirty="0">
                 <a:solidFill>
                   <a:srgbClr val="F0F6FC"/>
                 </a:solidFill>
@@ -9187,7 +9205,7 @@
         </p:nvSpPr>
         <p:spPr>
           <a:xfrm>
-            <a:off x="484632" y="1005840"/>
+            <a:off x="484632" y="1033653"/>
             <a:ext cx="8092440" cy="256032"/>
           </a:xfrm>
           <a:prstGeom prst="rect">
@@ -9213,7 +9231,7 @@
               </a:spcAft>
             </a:pPr>
             <a:r>
-              <a:rPr sz="1150" b="0" dirty="0">
+              <a:rPr sz="1600" b="0" dirty="0">
                 <a:solidFill>
                   <a:srgbClr val="8B949E"/>
                 </a:solidFill>
@@ -9222,7 +9240,7 @@
               <a:t>Follow four </a:t>
             </a:r>
             <a:r>
-              <a:rPr lang="en-US" sz="1150" b="0" dirty="0">
+              <a:rPr lang="en-US" sz="1600" b="0" dirty="0">
                 <a:solidFill>
                   <a:srgbClr val="8B949E"/>
                 </a:solidFill>
@@ -9231,7 +9249,7 @@
               <a:t>steps and</a:t>
             </a:r>
             <a:r>
-              <a:rPr sz="1150" b="0" dirty="0">
+              <a:rPr sz="1600" b="0" dirty="0">
                 <a:solidFill>
                   <a:srgbClr val="8B949E"/>
                 </a:solidFill>

</xml_diff>

<commit_message>
Refine stacked PR training materials
</commit_message>
<xml_diff>
--- a/github-stacked-prs.pptx
+++ b/github-stacked-prs.pptx
@@ -8375,7 +8375,7 @@
                   <a:ea typeface="Arial" pitchFamily="34" charset="-122"/>
                   <a:cs typeface="Arial" pitchFamily="34" charset="-120"/>
                 </a:rPr>
-                <a:t>Review focused diffs, get approval, then update or land the stack.</a:t>
+                <a:t>After approval, sync runs the full loop. Use rebase, test + push for checkpoints.</a:t>
               </a:r>
               <a:endParaRPr lang="en-US" sz="1150" dirty="0"/>
             </a:p>
@@ -12693,7 +12693,7 @@
                 <a:ea typeface="Courier New" pitchFamily="34" charset="-122"/>
                 <a:cs typeface="Courier New" pitchFamily="34" charset="-120"/>
               </a:rPr>
-              <a:t># Separate step: after review + approval</a:t>
+              <a:t># Routine: reconcile, rebase stale, push + sync PRs</a:t>
             </a:r>
             <a:endParaRPr lang="en-US" sz="1000" dirty="0">
               <a:solidFill>

</xml_diff>